<commit_message>
Apply minimal PPT edits in original format
Co-authored-by: Sagar-konkanagaon <Sagar-konkanagaon@users.noreply.github.com>
</commit_message>
<xml_diff>
--- a/CHVAC_QA_Onboarding_Updated (1).pptx
+++ b/CHVAC_QA_Onboarding_Updated (1).pptx
@@ -14239,7 +14239,7 @@
         </p:nvSpPr>
         <p:spPr>
           <a:xfrm>
-            <a:off x="676656" y="982980"/>
+            <a:off x="676656" y="987552"/>
             <a:ext cx="3090672" cy="164592"/>
           </a:xfrm>
           <a:prstGeom prst="rect">
@@ -14417,7 +14417,7 @@
         </p:nvSpPr>
         <p:spPr>
           <a:xfrm>
-            <a:off x="676656" y="1403604"/>
+            <a:off x="676656" y="1408176"/>
             <a:ext cx="3090672" cy="164592"/>
           </a:xfrm>
           <a:prstGeom prst="rect">
@@ -14595,7 +14595,7 @@
         </p:nvSpPr>
         <p:spPr>
           <a:xfrm>
-            <a:off x="676656" y="1824228"/>
+            <a:off x="676656" y="1828800"/>
             <a:ext cx="3090672" cy="164592"/>
           </a:xfrm>
           <a:prstGeom prst="rect">
@@ -14773,7 +14773,7 @@
         </p:nvSpPr>
         <p:spPr>
           <a:xfrm>
-            <a:off x="676656" y="2244852"/>
+            <a:off x="676656" y="2249424"/>
             <a:ext cx="3090672" cy="164592"/>
           </a:xfrm>
           <a:prstGeom prst="rect">
@@ -14951,7 +14951,7 @@
         </p:nvSpPr>
         <p:spPr>
           <a:xfrm>
-            <a:off x="676656" y="2665476"/>
+            <a:off x="676656" y="2670048"/>
             <a:ext cx="3090672" cy="164592"/>
           </a:xfrm>
           <a:prstGeom prst="rect">
@@ -19550,7 +19550,7 @@
         <p:spPr>
           <a:xfrm>
             <a:off x="347472" y="1572767"/>
-            <a:ext cx="5029200" cy="2395728"/>
+            <a:ext cx="5029200" cy="2189335"/>
           </a:xfrm>
           <a:prstGeom prst="rect">
             <a:avLst/>
@@ -20644,7 +20644,7 @@
                 </a:solidFill>
                 <a:latin typeface="Aptos"/>
               </a:rPr>
-              <a:t>Ramesh Hegde · QA Manager</a:t>
+              <a:t>Ramesh Hegde · WorkSight QA Manager</a:t>
             </a:r>
           </a:p>
         </p:txBody>
@@ -20773,7 +20773,7 @@
           </a:fontRef>
         </p:style>
         <p:txBody>
-          <a:bodyPr rtlCol="0" anchor="ctr" wrap="square" lIns="36576" rIns="36576" tIns="9144" bIns="9144"/>
+          <a:bodyPr rtlCol="0" anchor="ctr" wrap="square" lIns="9144" rIns="9144" tIns="9144" bIns="9144"/>
           <a:lstStyle/>
           <a:p>
             <a:pPr algn="ctr"/>
@@ -20823,7 +20823,7 @@
           </a:fontRef>
         </p:style>
         <p:txBody>
-          <a:bodyPr rtlCol="0" anchor="ctr" wrap="square" lIns="18288" rIns="18288" tIns="9144" bIns="9144"/>
+          <a:bodyPr rtlCol="0" anchor="ctr" wrap="square" lIns="9144" rIns="9144" tIns="9144" bIns="9144"/>
           <a:lstStyle/>
           <a:p>
             <a:pPr algn="ctr"/>
@@ -20963,7 +20963,7 @@
           </a:fontRef>
         </p:style>
         <p:txBody>
-          <a:bodyPr rtlCol="0" anchor="ctr" wrap="square" lIns="36576" rIns="36576" tIns="9144" bIns="9144"/>
+          <a:bodyPr rtlCol="0" anchor="ctr" wrap="square" lIns="9144" rIns="9144" tIns="9144" bIns="9144"/>
           <a:lstStyle/>
           <a:p>
             <a:pPr algn="ctr"/>
@@ -21013,7 +21013,7 @@
           </a:fontRef>
         </p:style>
         <p:txBody>
-          <a:bodyPr rtlCol="0" anchor="ctr" wrap="square" lIns="18288" rIns="18288" tIns="9144" bIns="9144"/>
+          <a:bodyPr rtlCol="0" anchor="ctr" wrap="square" lIns="9144" rIns="9144" tIns="9144" bIns="9144"/>
           <a:lstStyle/>
           <a:p>
             <a:pPr algn="ctr"/>
@@ -21293,7 +21293,7 @@
           </a:fontRef>
         </p:style>
         <p:txBody>
-          <a:bodyPr rtlCol="0" anchor="ctr" wrap="square" lIns="36576" rIns="36576" tIns="9144" bIns="9144"/>
+          <a:bodyPr rtlCol="0" anchor="ctr" wrap="square" lIns="9144" rIns="9144" tIns="9144" bIns="9144"/>
           <a:lstStyle/>
           <a:p>
             <a:pPr algn="ctr"/>
@@ -21343,7 +21343,7 @@
           </a:fontRef>
         </p:style>
         <p:txBody>
-          <a:bodyPr rtlCol="0" anchor="ctr" wrap="square" lIns="18288" rIns="18288" tIns="9144" bIns="9144"/>
+          <a:bodyPr rtlCol="0" anchor="ctr" wrap="square" lIns="9144" rIns="9144" tIns="9144" bIns="9144"/>
           <a:lstStyle/>
           <a:p>
             <a:pPr algn="ctr"/>
@@ -21483,7 +21483,7 @@
           </a:fontRef>
         </p:style>
         <p:txBody>
-          <a:bodyPr rtlCol="0" anchor="ctr" wrap="square" lIns="36576" rIns="36576" tIns="9144" bIns="9144"/>
+          <a:bodyPr rtlCol="0" anchor="ctr" wrap="square" lIns="9144" rIns="9144" tIns="9144" bIns="9144"/>
           <a:lstStyle/>
           <a:p>
             <a:pPr algn="ctr"/>
@@ -21533,7 +21533,7 @@
           </a:fontRef>
         </p:style>
         <p:txBody>
-          <a:bodyPr rtlCol="0" anchor="ctr" wrap="square" lIns="18288" rIns="18288" tIns="9144" bIns="9144"/>
+          <a:bodyPr rtlCol="0" anchor="ctr" wrap="square" lIns="9144" rIns="9144" tIns="9144" bIns="9144"/>
           <a:lstStyle/>
           <a:p>
             <a:pPr algn="ctr"/>
@@ -21673,7 +21673,7 @@
           </a:fontRef>
         </p:style>
         <p:txBody>
-          <a:bodyPr rtlCol="0" anchor="ctr" wrap="square" lIns="36576" rIns="36576" tIns="9144" bIns="9144"/>
+          <a:bodyPr rtlCol="0" anchor="ctr" wrap="square" lIns="9144" rIns="9144" tIns="9144" bIns="9144"/>
           <a:lstStyle/>
           <a:p>
             <a:pPr algn="ctr"/>
@@ -21723,7 +21723,7 @@
           </a:fontRef>
         </p:style>
         <p:txBody>
-          <a:bodyPr rtlCol="0" anchor="ctr" wrap="square" lIns="18288" rIns="18288" tIns="9144" bIns="9144"/>
+          <a:bodyPr rtlCol="0" anchor="ctr" wrap="square" lIns="9144" rIns="9144" tIns="9144" bIns="9144"/>
           <a:lstStyle/>
           <a:p>
             <a:pPr algn="ctr"/>
@@ -21863,7 +21863,7 @@
           </a:fontRef>
         </p:style>
         <p:txBody>
-          <a:bodyPr rtlCol="0" anchor="ctr" wrap="square" lIns="36576" rIns="36576" tIns="9144" bIns="9144"/>
+          <a:bodyPr rtlCol="0" anchor="ctr" wrap="square" lIns="9144" rIns="9144" tIns="9144" bIns="9144"/>
           <a:lstStyle/>
           <a:p>
             <a:pPr algn="ctr"/>
@@ -21913,7 +21913,7 @@
           </a:fontRef>
         </p:style>
         <p:txBody>
-          <a:bodyPr rtlCol="0" anchor="ctr" wrap="square" lIns="18288" rIns="18288" tIns="9144" bIns="9144"/>
+          <a:bodyPr rtlCol="0" anchor="ctr" wrap="square" lIns="9144" rIns="9144" tIns="9144" bIns="9144"/>
           <a:lstStyle/>
           <a:p>
             <a:pPr algn="ctr"/>
@@ -22053,7 +22053,7 @@
           </a:fontRef>
         </p:style>
         <p:txBody>
-          <a:bodyPr rtlCol="0" anchor="ctr" wrap="square" lIns="36576" rIns="36576" tIns="9144" bIns="9144"/>
+          <a:bodyPr rtlCol="0" anchor="ctr" wrap="square" lIns="9144" rIns="9144" tIns="9144" bIns="9144"/>
           <a:lstStyle/>
           <a:p>
             <a:pPr algn="ctr"/>
@@ -22103,7 +22103,7 @@
           </a:fontRef>
         </p:style>
         <p:txBody>
-          <a:bodyPr rtlCol="0" anchor="ctr" wrap="square" lIns="18288" rIns="18288" tIns="9144" bIns="9144"/>
+          <a:bodyPr rtlCol="0" anchor="ctr" wrap="square" lIns="9144" rIns="9144" tIns="9144" bIns="9144"/>
           <a:lstStyle/>
           <a:p>
             <a:pPr algn="ctr"/>
@@ -22243,7 +22243,7 @@
           </a:fontRef>
         </p:style>
         <p:txBody>
-          <a:bodyPr rtlCol="0" anchor="ctr" wrap="square" lIns="36576" rIns="36576" tIns="9144" bIns="9144"/>
+          <a:bodyPr rtlCol="0" anchor="ctr" wrap="square" lIns="9144" rIns="9144" tIns="9144" bIns="9144"/>
           <a:lstStyle/>
           <a:p>
             <a:pPr algn="ctr"/>
@@ -22293,7 +22293,7 @@
           </a:fontRef>
         </p:style>
         <p:txBody>
-          <a:bodyPr rtlCol="0" anchor="ctr" wrap="square" lIns="18288" rIns="18288" tIns="9144" bIns="9144"/>
+          <a:bodyPr rtlCol="0" anchor="ctr" wrap="square" lIns="9144" rIns="9144" tIns="9144" bIns="9144"/>
           <a:lstStyle/>
           <a:p>
             <a:pPr algn="ctr"/>
@@ -22433,7 +22433,7 @@
           </a:fontRef>
         </p:style>
         <p:txBody>
-          <a:bodyPr rtlCol="0" anchor="ctr" wrap="square" lIns="36576" rIns="36576" tIns="9144" bIns="9144"/>
+          <a:bodyPr rtlCol="0" anchor="ctr" wrap="square" lIns="9144" rIns="9144" tIns="9144" bIns="9144"/>
           <a:lstStyle/>
           <a:p>
             <a:pPr algn="ctr"/>
@@ -22483,7 +22483,7 @@
           </a:fontRef>
         </p:style>
         <p:txBody>
-          <a:bodyPr rtlCol="0" anchor="ctr" wrap="square" lIns="18288" rIns="18288" tIns="9144" bIns="9144"/>
+          <a:bodyPr rtlCol="0" anchor="ctr" wrap="square" lIns="9144" rIns="9144" tIns="9144" bIns="9144"/>
           <a:lstStyle/>
           <a:p>
             <a:pPr algn="ctr"/>
@@ -22623,7 +22623,7 @@
           </a:fontRef>
         </p:style>
         <p:txBody>
-          <a:bodyPr rtlCol="0" anchor="ctr" wrap="square" lIns="36576" rIns="36576" tIns="9144" bIns="9144"/>
+          <a:bodyPr rtlCol="0" anchor="ctr" wrap="square" lIns="9144" rIns="9144" tIns="9144" bIns="9144"/>
           <a:lstStyle/>
           <a:p>
             <a:pPr algn="ctr"/>
@@ -22673,7 +22673,7 @@
           </a:fontRef>
         </p:style>
         <p:txBody>
-          <a:bodyPr rtlCol="0" anchor="ctr" wrap="square" lIns="18288" rIns="18288" tIns="9144" bIns="9144"/>
+          <a:bodyPr rtlCol="0" anchor="ctr" wrap="square" lIns="9144" rIns="9144" tIns="9144" bIns="9144"/>
           <a:lstStyle/>
           <a:p>
             <a:pPr algn="ctr"/>
@@ -24838,7 +24838,7 @@
         </p:nvSpPr>
         <p:spPr>
           <a:xfrm>
-            <a:off x="4626864" y="1645920"/>
+            <a:off x="4626864" y="1673352"/>
             <a:ext cx="4169664" cy="219456"/>
           </a:xfrm>
           <a:prstGeom prst="rect">
@@ -24870,7 +24870,7 @@
         </p:nvSpPr>
         <p:spPr>
           <a:xfrm>
-            <a:off x="4626864" y="1645920"/>
+            <a:off x="4626864" y="1673352"/>
             <a:ext cx="36576" cy="219456"/>
           </a:xfrm>
           <a:prstGeom prst="rect">
@@ -24902,7 +24902,7 @@
         </p:nvSpPr>
         <p:spPr>
           <a:xfrm>
-            <a:off x="4681728" y="1645920"/>
+            <a:off x="4681728" y="1673352"/>
             <a:ext cx="1584472" cy="219456"/>
           </a:xfrm>
           <a:prstGeom prst="rect">
@@ -24941,7 +24941,7 @@
         </p:nvSpPr>
         <p:spPr>
           <a:xfrm>
-            <a:off x="6266200" y="1645920"/>
+            <a:off x="6266200" y="1673352"/>
             <a:ext cx="1459382" cy="219456"/>
           </a:xfrm>
           <a:prstGeom prst="rect">
@@ -24980,7 +24980,7 @@
         </p:nvSpPr>
         <p:spPr>
           <a:xfrm>
-            <a:off x="7725583" y="1645920"/>
+            <a:off x="7725583" y="1673352"/>
             <a:ext cx="1042416" cy="219456"/>
           </a:xfrm>
           <a:prstGeom prst="rect">
@@ -25013,13 +25013,45 @@
       </p:sp>
       <p:sp>
         <p:nvSpPr>
-          <p:cNvPr id="131" name="Shape 129"/>
-          <p:cNvSpPr/>
-          <p:nvPr/>
-        </p:nvSpPr>
-        <p:spPr>
-          <a:xfrm>
-            <a:off x="4626864" y="1673352"/>
+          <p:cNvPr id="135" name="Shape 133"/>
+          <p:cNvSpPr/>
+          <p:nvPr/>
+        </p:nvSpPr>
+        <p:spPr>
+          <a:xfrm>
+            <a:off x="4626864" y="1892808"/>
+            <a:ext cx="4169664" cy="219456"/>
+          </a:xfrm>
+          <a:prstGeom prst="rect">
+            <a:avLst/>
+          </a:prstGeom>
+          <a:solidFill>
+            <a:srgbClr val="FFFFFF"/>
+          </a:solidFill>
+          <a:ln w="3810">
+            <a:solidFill>
+              <a:srgbClr val="EEEEEE"/>
+            </a:solidFill>
+            <a:prstDash val="solid"/>
+          </a:ln>
+        </p:spPr>
+        <p:txBody>
+          <a:bodyPr/>
+          <a:lstStyle/>
+          <a:p>
+            <a:endParaRPr lang="en-IN"/>
+          </a:p>
+        </p:txBody>
+      </p:sp>
+      <p:sp>
+        <p:nvSpPr>
+          <p:cNvPr id="136" name="Shape 134"/>
+          <p:cNvSpPr/>
+          <p:nvPr/>
+        </p:nvSpPr>
+        <p:spPr>
+          <a:xfrm>
+            <a:off x="4626864" y="1892808"/>
             <a:ext cx="36576" cy="219456"/>
           </a:xfrm>
           <a:prstGeom prst="rect">
@@ -25045,13 +25077,311 @@
       </p:sp>
       <p:sp>
         <p:nvSpPr>
-          <p:cNvPr id="135" name="Shape 133"/>
-          <p:cNvSpPr/>
-          <p:nvPr/>
-        </p:nvSpPr>
-        <p:spPr>
-          <a:xfrm>
-            <a:off x="4626864" y="1865376"/>
+          <p:cNvPr id="137" name="Text 135"/>
+          <p:cNvSpPr/>
+          <p:nvPr/>
+        </p:nvSpPr>
+        <p:spPr>
+          <a:xfrm>
+            <a:off x="4681728" y="1892808"/>
+            <a:ext cx="1584472" cy="219456"/>
+          </a:xfrm>
+          <a:prstGeom prst="rect">
+            <a:avLst/>
+          </a:prstGeom>
+          <a:noFill/>
+          <a:ln/>
+        </p:spPr>
+        <p:txBody>
+          <a:bodyPr wrap="square" lIns="0" tIns="0" rIns="0" bIns="0" rtlCol="0" anchor="ctr"/>
+          <a:lstStyle/>
+          <a:p>
+            <a:pPr marL="0" indent="0">
+              <a:buNone/>
+            </a:pPr>
+            <a:r>
+              <a:rPr lang="en-US" sz="750" b="1">
+                <a:solidFill>
+                  <a:srgbClr val="111111"/>
+                </a:solidFill>
+                <a:latin typeface="Calibri" pitchFamily="34" charset="0"/>
+                <a:ea typeface="Calibri" pitchFamily="34" charset="-122"/>
+                <a:cs typeface="Calibri" pitchFamily="34" charset="-120"/>
+              </a:rPr>
+              <a:t>Aiswarya H</a:t>
+            </a:r>
+            <a:endParaRPr lang="en-US" sz="750"/>
+          </a:p>
+        </p:txBody>
+      </p:sp>
+      <p:sp>
+        <p:nvSpPr>
+          <p:cNvPr id="138" name="Text 136"/>
+          <p:cNvSpPr/>
+          <p:nvPr/>
+        </p:nvSpPr>
+        <p:spPr>
+          <a:xfrm>
+            <a:off x="6266200" y="1892808"/>
+            <a:ext cx="1459382" cy="219456"/>
+          </a:xfrm>
+          <a:prstGeom prst="rect">
+            <a:avLst/>
+          </a:prstGeom>
+          <a:noFill/>
+          <a:ln/>
+        </p:spPr>
+        <p:txBody>
+          <a:bodyPr wrap="square" lIns="0" tIns="0" rIns="0" bIns="0" rtlCol="0" anchor="ctr"/>
+          <a:lstStyle/>
+          <a:p>
+            <a:pPr marL="0" indent="0">
+              <a:buNone/>
+            </a:pPr>
+            <a:r>
+              <a:rPr lang="en-US" sz="700">
+                <a:solidFill>
+                  <a:srgbClr val="6B21D4"/>
+                </a:solidFill>
+                <a:latin typeface="Calibri" pitchFamily="34" charset="0"/>
+                <a:ea typeface="Calibri" pitchFamily="34" charset="-122"/>
+                <a:cs typeface="Calibri" pitchFamily="34" charset="-120"/>
+              </a:rPr>
+              <a:t>QA – Func Lead</a:t>
+            </a:r>
+            <a:endParaRPr lang="en-US" sz="700"/>
+          </a:p>
+        </p:txBody>
+      </p:sp>
+      <p:sp>
+        <p:nvSpPr>
+          <p:cNvPr id="139" name="Text 137"/>
+          <p:cNvSpPr/>
+          <p:nvPr/>
+        </p:nvSpPr>
+        <p:spPr>
+          <a:xfrm>
+            <a:off x="7725583" y="1892808"/>
+            <a:ext cx="1042416" cy="219456"/>
+          </a:xfrm>
+          <a:prstGeom prst="rect">
+            <a:avLst/>
+          </a:prstGeom>
+          <a:noFill/>
+          <a:ln/>
+        </p:spPr>
+        <p:txBody>
+          <a:bodyPr wrap="square" lIns="0" tIns="0" rIns="0" bIns="0" rtlCol="0" anchor="ctr"/>
+          <a:lstStyle/>
+          <a:p>
+            <a:pPr marL="0" indent="0">
+              <a:buNone/>
+            </a:pPr>
+            <a:r>
+              <a:rPr lang="en-US" sz="650">
+                <a:solidFill>
+                  <a:srgbClr val="777777"/>
+                </a:solidFill>
+                <a:latin typeface="Calibri" pitchFamily="34" charset="0"/>
+                <a:ea typeface="Calibri" pitchFamily="34" charset="-122"/>
+                <a:cs typeface="Calibri" pitchFamily="34" charset="-120"/>
+              </a:rPr>
+              <a:t>Offshore · Trane-ITC</a:t>
+            </a:r>
+            <a:endParaRPr lang="en-US" sz="650"/>
+          </a:p>
+        </p:txBody>
+      </p:sp>
+      <p:sp>
+        <p:nvSpPr>
+          <p:cNvPr id="140" name="Shape 138"/>
+          <p:cNvSpPr/>
+          <p:nvPr/>
+        </p:nvSpPr>
+        <p:spPr>
+          <a:xfrm>
+            <a:off x="4626864" y="2112264"/>
+            <a:ext cx="4169664" cy="219456"/>
+          </a:xfrm>
+          <a:prstGeom prst="rect">
+            <a:avLst/>
+          </a:prstGeom>
+          <a:solidFill>
+            <a:srgbClr val="F3F0FA"/>
+          </a:solidFill>
+          <a:ln w="3810">
+            <a:solidFill>
+              <a:srgbClr val="EEEEEE"/>
+            </a:solidFill>
+            <a:prstDash val="solid"/>
+          </a:ln>
+        </p:spPr>
+        <p:txBody>
+          <a:bodyPr/>
+          <a:lstStyle/>
+          <a:p>
+            <a:endParaRPr lang="en-IN"/>
+          </a:p>
+        </p:txBody>
+      </p:sp>
+      <p:sp>
+        <p:nvSpPr>
+          <p:cNvPr id="141" name="Shape 139"/>
+          <p:cNvSpPr/>
+          <p:nvPr/>
+        </p:nvSpPr>
+        <p:spPr>
+          <a:xfrm>
+            <a:off x="4626864" y="2112264"/>
+            <a:ext cx="36576" cy="219456"/>
+          </a:xfrm>
+          <a:prstGeom prst="rect">
+            <a:avLst/>
+          </a:prstGeom>
+          <a:solidFill>
+            <a:srgbClr val="6B21D4"/>
+          </a:solidFill>
+          <a:ln w="12700">
+            <a:solidFill>
+              <a:srgbClr val="6B21D4"/>
+            </a:solidFill>
+            <a:prstDash val="solid"/>
+          </a:ln>
+        </p:spPr>
+        <p:txBody>
+          <a:bodyPr/>
+          <a:lstStyle/>
+          <a:p>
+            <a:endParaRPr lang="en-IN"/>
+          </a:p>
+        </p:txBody>
+      </p:sp>
+      <p:sp>
+        <p:nvSpPr>
+          <p:cNvPr id="142" name="Text 140"/>
+          <p:cNvSpPr/>
+          <p:nvPr/>
+        </p:nvSpPr>
+        <p:spPr>
+          <a:xfrm>
+            <a:off x="4681728" y="2112264"/>
+            <a:ext cx="1584472" cy="219456"/>
+          </a:xfrm>
+          <a:prstGeom prst="rect">
+            <a:avLst/>
+          </a:prstGeom>
+          <a:noFill/>
+          <a:ln/>
+        </p:spPr>
+        <p:txBody>
+          <a:bodyPr wrap="square" lIns="0" tIns="0" rIns="0" bIns="0" rtlCol="0" anchor="ctr"/>
+          <a:lstStyle/>
+          <a:p>
+            <a:pPr marL="0" indent="0">
+              <a:buNone/>
+            </a:pPr>
+            <a:r>
+              <a:rPr lang="en-US" sz="750" b="1">
+                <a:solidFill>
+                  <a:srgbClr val="111111"/>
+                </a:solidFill>
+                <a:latin typeface="Calibri" pitchFamily="34" charset="0"/>
+                <a:ea typeface="Calibri" pitchFamily="34" charset="-122"/>
+                <a:cs typeface="Calibri" pitchFamily="34" charset="-120"/>
+              </a:rPr>
+              <a:t>Sowmya Shetty</a:t>
+            </a:r>
+            <a:endParaRPr lang="en-US" sz="750"/>
+          </a:p>
+        </p:txBody>
+      </p:sp>
+      <p:sp>
+        <p:nvSpPr>
+          <p:cNvPr id="143" name="Text 141"/>
+          <p:cNvSpPr/>
+          <p:nvPr/>
+        </p:nvSpPr>
+        <p:spPr>
+          <a:xfrm>
+            <a:off x="6266200" y="2112264"/>
+            <a:ext cx="1459382" cy="219456"/>
+          </a:xfrm>
+          <a:prstGeom prst="rect">
+            <a:avLst/>
+          </a:prstGeom>
+          <a:noFill/>
+          <a:ln/>
+        </p:spPr>
+        <p:txBody>
+          <a:bodyPr wrap="square" lIns="0" tIns="0" rIns="0" bIns="0" rtlCol="0" anchor="ctr"/>
+          <a:lstStyle/>
+          <a:p>
+            <a:pPr marL="0" indent="0">
+              <a:buNone/>
+            </a:pPr>
+            <a:r>
+              <a:rPr lang="en-US" sz="700">
+                <a:solidFill>
+                  <a:srgbClr val="6B21D4"/>
+                </a:solidFill>
+                <a:latin typeface="Calibri" pitchFamily="34" charset="0"/>
+                <a:ea typeface="Calibri" pitchFamily="34" charset="-122"/>
+                <a:cs typeface="Calibri" pitchFamily="34" charset="-120"/>
+              </a:rPr>
+              <a:t>QA – Func / R12</a:t>
+            </a:r>
+            <a:endParaRPr lang="en-US" sz="700"/>
+          </a:p>
+        </p:txBody>
+      </p:sp>
+      <p:sp>
+        <p:nvSpPr>
+          <p:cNvPr id="144" name="Text 142"/>
+          <p:cNvSpPr/>
+          <p:nvPr/>
+        </p:nvSpPr>
+        <p:spPr>
+          <a:xfrm>
+            <a:off x="7725583" y="2112264"/>
+            <a:ext cx="1042416" cy="219456"/>
+          </a:xfrm>
+          <a:prstGeom prst="rect">
+            <a:avLst/>
+          </a:prstGeom>
+          <a:noFill/>
+          <a:ln/>
+        </p:spPr>
+        <p:txBody>
+          <a:bodyPr wrap="square" lIns="0" tIns="0" rIns="0" bIns="0" rtlCol="0" anchor="ctr"/>
+          <a:lstStyle/>
+          <a:p>
+            <a:pPr marL="0" indent="0">
+              <a:buNone/>
+            </a:pPr>
+            <a:r>
+              <a:rPr lang="en-US" sz="650">
+                <a:solidFill>
+                  <a:srgbClr val="777777"/>
+                </a:solidFill>
+                <a:latin typeface="Calibri" pitchFamily="34" charset="0"/>
+                <a:ea typeface="Calibri" pitchFamily="34" charset="-122"/>
+                <a:cs typeface="Calibri" pitchFamily="34" charset="-120"/>
+              </a:rPr>
+              <a:t>Offshore · Trane-ITC</a:t>
+            </a:r>
+            <a:endParaRPr lang="en-US" sz="650"/>
+          </a:p>
+        </p:txBody>
+      </p:sp>
+      <p:sp>
+        <p:nvSpPr>
+          <p:cNvPr id="145" name="Shape 143"/>
+          <p:cNvSpPr/>
+          <p:nvPr/>
+        </p:nvSpPr>
+        <p:spPr>
+          <a:xfrm>
+            <a:off x="4626864" y="2331720"/>
             <a:ext cx="4169664" cy="219456"/>
           </a:xfrm>
           <a:prstGeom prst="rect">
@@ -25077,13 +25407,13 @@
       </p:sp>
       <p:sp>
         <p:nvSpPr>
-          <p:cNvPr id="136" name="Shape 134"/>
-          <p:cNvSpPr/>
-          <p:nvPr/>
-        </p:nvSpPr>
-        <p:spPr>
-          <a:xfrm>
-            <a:off x="4626864" y="1865376"/>
+          <p:cNvPr id="146" name="Shape 144"/>
+          <p:cNvSpPr/>
+          <p:nvPr/>
+        </p:nvSpPr>
+        <p:spPr>
+          <a:xfrm>
+            <a:off x="4626864" y="2331720"/>
             <a:ext cx="36576" cy="219456"/>
           </a:xfrm>
           <a:prstGeom prst="rect">
@@ -25109,13 +25439,13 @@
       </p:sp>
       <p:sp>
         <p:nvSpPr>
-          <p:cNvPr id="137" name="Text 135"/>
-          <p:cNvSpPr/>
-          <p:nvPr/>
-        </p:nvSpPr>
-        <p:spPr>
-          <a:xfrm>
-            <a:off x="4681728" y="1865376"/>
+          <p:cNvPr id="147" name="Text 145"/>
+          <p:cNvSpPr/>
+          <p:nvPr/>
+        </p:nvSpPr>
+        <p:spPr>
+          <a:xfrm>
+            <a:off x="4681728" y="2331720"/>
             <a:ext cx="1584472" cy="219456"/>
           </a:xfrm>
           <a:prstGeom prst="rect">
@@ -25140,7 +25470,7 @@
                 <a:ea typeface="Calibri" pitchFamily="34" charset="-122"/>
                 <a:cs typeface="Calibri" pitchFamily="34" charset="-120"/>
               </a:rPr>
-              <a:t>Aiswarya H</a:t>
+              <a:t>Greeshma Balan</a:t>
             </a:r>
             <a:endParaRPr lang="en-US" sz="750"/>
           </a:p>
@@ -25148,13 +25478,13 @@
       </p:sp>
       <p:sp>
         <p:nvSpPr>
-          <p:cNvPr id="138" name="Text 136"/>
-          <p:cNvSpPr/>
-          <p:nvPr/>
-        </p:nvSpPr>
-        <p:spPr>
-          <a:xfrm>
-            <a:off x="6266200" y="1865376"/>
+          <p:cNvPr id="148" name="Text 146"/>
+          <p:cNvSpPr/>
+          <p:nvPr/>
+        </p:nvSpPr>
+        <p:spPr>
+          <a:xfrm>
+            <a:off x="6266200" y="2331720"/>
             <a:ext cx="1459382" cy="219456"/>
           </a:xfrm>
           <a:prstGeom prst="rect">
@@ -25179,7 +25509,7 @@
                 <a:ea typeface="Calibri" pitchFamily="34" charset="-122"/>
                 <a:cs typeface="Calibri" pitchFamily="34" charset="-120"/>
               </a:rPr>
-              <a:t>QA – Func Lead</a:t>
+              <a:t>QA – Functional</a:t>
             </a:r>
             <a:endParaRPr lang="en-US" sz="700"/>
           </a:p>
@@ -25187,13 +25517,13 @@
       </p:sp>
       <p:sp>
         <p:nvSpPr>
-          <p:cNvPr id="139" name="Text 137"/>
-          <p:cNvSpPr/>
-          <p:nvPr/>
-        </p:nvSpPr>
-        <p:spPr>
-          <a:xfrm>
-            <a:off x="7725583" y="1865376"/>
+          <p:cNvPr id="149" name="Text 147"/>
+          <p:cNvSpPr/>
+          <p:nvPr/>
+        </p:nvSpPr>
+        <p:spPr>
+          <a:xfrm>
+            <a:off x="7725583" y="2331720"/>
             <a:ext cx="1042416" cy="219456"/>
           </a:xfrm>
           <a:prstGeom prst="rect">
@@ -25218,7 +25548,7 @@
                 <a:ea typeface="Calibri" pitchFamily="34" charset="-122"/>
                 <a:cs typeface="Calibri" pitchFamily="34" charset="-120"/>
               </a:rPr>
-              <a:t>Offshore · Trane-ITC</a:t>
+              <a:t>Offshore · Cognizant</a:t>
             </a:r>
             <a:endParaRPr lang="en-US" sz="650"/>
           </a:p>
@@ -25226,13 +25556,13 @@
       </p:sp>
       <p:sp>
         <p:nvSpPr>
-          <p:cNvPr id="140" name="Shape 138"/>
-          <p:cNvSpPr/>
-          <p:nvPr/>
-        </p:nvSpPr>
-        <p:spPr>
-          <a:xfrm>
-            <a:off x="4626864" y="2084831"/>
+          <p:cNvPr id="150" name="Shape 148"/>
+          <p:cNvSpPr/>
+          <p:nvPr/>
+        </p:nvSpPr>
+        <p:spPr>
+          <a:xfrm>
+            <a:off x="4626864" y="2551176"/>
             <a:ext cx="4169664" cy="219456"/>
           </a:xfrm>
           <a:prstGeom prst="rect">
@@ -25258,13 +25588,13 @@
       </p:sp>
       <p:sp>
         <p:nvSpPr>
-          <p:cNvPr id="141" name="Shape 139"/>
-          <p:cNvSpPr/>
-          <p:nvPr/>
-        </p:nvSpPr>
-        <p:spPr>
-          <a:xfrm>
-            <a:off x="4626864" y="2084831"/>
+          <p:cNvPr id="151" name="Shape 149"/>
+          <p:cNvSpPr/>
+          <p:nvPr/>
+        </p:nvSpPr>
+        <p:spPr>
+          <a:xfrm>
+            <a:off x="4626864" y="2551176"/>
             <a:ext cx="36576" cy="219456"/>
           </a:xfrm>
           <a:prstGeom prst="rect">
@@ -25290,13 +25620,13 @@
       </p:sp>
       <p:sp>
         <p:nvSpPr>
-          <p:cNvPr id="142" name="Text 140"/>
-          <p:cNvSpPr/>
-          <p:nvPr/>
-        </p:nvSpPr>
-        <p:spPr>
-          <a:xfrm>
-            <a:off x="4681728" y="2084831"/>
+          <p:cNvPr id="152" name="Text 150"/>
+          <p:cNvSpPr/>
+          <p:nvPr/>
+        </p:nvSpPr>
+        <p:spPr>
+          <a:xfrm>
+            <a:off x="4681728" y="2551176"/>
             <a:ext cx="1584472" cy="219456"/>
           </a:xfrm>
           <a:prstGeom prst="rect">
@@ -25321,7 +25651,7 @@
                 <a:ea typeface="Calibri" pitchFamily="34" charset="-122"/>
                 <a:cs typeface="Calibri" pitchFamily="34" charset="-120"/>
               </a:rPr>
-              <a:t>Sowmya Shetty</a:t>
+              <a:t>Brahmananda R</a:t>
             </a:r>
             <a:endParaRPr lang="en-US" sz="750"/>
           </a:p>
@@ -25329,13 +25659,13 @@
       </p:sp>
       <p:sp>
         <p:nvSpPr>
-          <p:cNvPr id="143" name="Text 141"/>
-          <p:cNvSpPr/>
-          <p:nvPr/>
-        </p:nvSpPr>
-        <p:spPr>
-          <a:xfrm>
-            <a:off x="6266200" y="2084831"/>
+          <p:cNvPr id="153" name="Text 151"/>
+          <p:cNvSpPr/>
+          <p:nvPr/>
+        </p:nvSpPr>
+        <p:spPr>
+          <a:xfrm>
+            <a:off x="6266200" y="2551176"/>
             <a:ext cx="1459382" cy="219456"/>
           </a:xfrm>
           <a:prstGeom prst="rect">
@@ -25360,7 +25690,7 @@
                 <a:ea typeface="Calibri" pitchFamily="34" charset="-122"/>
                 <a:cs typeface="Calibri" pitchFamily="34" charset="-120"/>
               </a:rPr>
-              <a:t>QA – Func / R12</a:t>
+              <a:t>QA – Functional</a:t>
             </a:r>
             <a:endParaRPr lang="en-US" sz="700"/>
           </a:p>
@@ -25368,13 +25698,13 @@
       </p:sp>
       <p:sp>
         <p:nvSpPr>
-          <p:cNvPr id="144" name="Text 142"/>
-          <p:cNvSpPr/>
-          <p:nvPr/>
-        </p:nvSpPr>
-        <p:spPr>
-          <a:xfrm>
-            <a:off x="7725583" y="2084831"/>
+          <p:cNvPr id="154" name="Text 152"/>
+          <p:cNvSpPr/>
+          <p:nvPr/>
+        </p:nvSpPr>
+        <p:spPr>
+          <a:xfrm>
+            <a:off x="7725583" y="2551176"/>
             <a:ext cx="1042416" cy="219456"/>
           </a:xfrm>
           <a:prstGeom prst="rect">
@@ -25407,13 +25737,13 @@
       </p:sp>
       <p:sp>
         <p:nvSpPr>
-          <p:cNvPr id="145" name="Shape 143"/>
-          <p:cNvSpPr/>
-          <p:nvPr/>
-        </p:nvSpPr>
-        <p:spPr>
-          <a:xfrm>
-            <a:off x="4626864" y="2304288"/>
+          <p:cNvPr id="155" name="Shape 153"/>
+          <p:cNvSpPr/>
+          <p:nvPr/>
+        </p:nvSpPr>
+        <p:spPr>
+          <a:xfrm>
+            <a:off x="4626864" y="2770632"/>
             <a:ext cx="4169664" cy="219456"/>
           </a:xfrm>
           <a:prstGeom prst="rect">
@@ -25439,13 +25769,13 @@
       </p:sp>
       <p:sp>
         <p:nvSpPr>
-          <p:cNvPr id="146" name="Shape 144"/>
-          <p:cNvSpPr/>
-          <p:nvPr/>
-        </p:nvSpPr>
-        <p:spPr>
-          <a:xfrm>
-            <a:off x="4626864" y="2304288"/>
+          <p:cNvPr id="156" name="Shape 154"/>
+          <p:cNvSpPr/>
+          <p:nvPr/>
+        </p:nvSpPr>
+        <p:spPr>
+          <a:xfrm>
+            <a:off x="4626864" y="2770632"/>
             <a:ext cx="36576" cy="219456"/>
           </a:xfrm>
           <a:prstGeom prst="rect">
@@ -25471,13 +25801,13 @@
       </p:sp>
       <p:sp>
         <p:nvSpPr>
-          <p:cNvPr id="147" name="Text 145"/>
-          <p:cNvSpPr/>
-          <p:nvPr/>
-        </p:nvSpPr>
-        <p:spPr>
-          <a:xfrm>
-            <a:off x="4681728" y="2304288"/>
+          <p:cNvPr id="157" name="Text 155"/>
+          <p:cNvSpPr/>
+          <p:nvPr/>
+        </p:nvSpPr>
+        <p:spPr>
+          <a:xfrm>
+            <a:off x="4681728" y="2770632"/>
             <a:ext cx="1584472" cy="219456"/>
           </a:xfrm>
           <a:prstGeom prst="rect">
@@ -25502,7 +25832,7 @@
                 <a:ea typeface="Calibri" pitchFamily="34" charset="-122"/>
                 <a:cs typeface="Calibri" pitchFamily="34" charset="-120"/>
               </a:rPr>
-              <a:t>Greeshma Balan</a:t>
+              <a:t>Kavya B N</a:t>
             </a:r>
             <a:endParaRPr lang="en-US" sz="750"/>
           </a:p>
@@ -25510,13 +25840,13 @@
       </p:sp>
       <p:sp>
         <p:nvSpPr>
-          <p:cNvPr id="148" name="Text 146"/>
-          <p:cNvSpPr/>
-          <p:nvPr/>
-        </p:nvSpPr>
-        <p:spPr>
-          <a:xfrm>
-            <a:off x="6266200" y="2304288"/>
+          <p:cNvPr id="158" name="Text 156"/>
+          <p:cNvSpPr/>
+          <p:nvPr/>
+        </p:nvSpPr>
+        <p:spPr>
+          <a:xfrm>
+            <a:off x="6266200" y="2770632"/>
             <a:ext cx="1459382" cy="219456"/>
           </a:xfrm>
           <a:prstGeom prst="rect">
@@ -25541,7 +25871,7 @@
                 <a:ea typeface="Calibri" pitchFamily="34" charset="-122"/>
                 <a:cs typeface="Calibri" pitchFamily="34" charset="-120"/>
               </a:rPr>
-              <a:t>QA – Functional</a:t>
+              <a:t>QA – Automation</a:t>
             </a:r>
             <a:endParaRPr lang="en-US" sz="700"/>
           </a:p>
@@ -25549,375 +25879,13 @@
       </p:sp>
       <p:sp>
         <p:nvSpPr>
-          <p:cNvPr id="149" name="Text 147"/>
-          <p:cNvSpPr/>
-          <p:nvPr/>
-        </p:nvSpPr>
-        <p:spPr>
-          <a:xfrm>
-            <a:off x="7725583" y="2304288"/>
-            <a:ext cx="1042416" cy="219456"/>
-          </a:xfrm>
-          <a:prstGeom prst="rect">
-            <a:avLst/>
-          </a:prstGeom>
-          <a:noFill/>
-          <a:ln/>
-        </p:spPr>
-        <p:txBody>
-          <a:bodyPr wrap="square" lIns="0" tIns="0" rIns="0" bIns="0" rtlCol="0" anchor="ctr"/>
-          <a:lstStyle/>
-          <a:p>
-            <a:pPr marL="0" indent="0">
-              <a:buNone/>
-            </a:pPr>
-            <a:r>
-              <a:rPr lang="en-US" sz="650">
-                <a:solidFill>
-                  <a:srgbClr val="777777"/>
-                </a:solidFill>
-                <a:latin typeface="Calibri" pitchFamily="34" charset="0"/>
-                <a:ea typeface="Calibri" pitchFamily="34" charset="-122"/>
-                <a:cs typeface="Calibri" pitchFamily="34" charset="-120"/>
-              </a:rPr>
-              <a:t>Offshore · Cognizant</a:t>
-            </a:r>
-            <a:endParaRPr lang="en-US" sz="650"/>
-          </a:p>
-        </p:txBody>
-      </p:sp>
-      <p:sp>
-        <p:nvSpPr>
-          <p:cNvPr id="150" name="Shape 148"/>
-          <p:cNvSpPr/>
-          <p:nvPr/>
-        </p:nvSpPr>
-        <p:spPr>
-          <a:xfrm>
-            <a:off x="4626864" y="2523744"/>
-            <a:ext cx="4169664" cy="219456"/>
-          </a:xfrm>
-          <a:prstGeom prst="rect">
-            <a:avLst/>
-          </a:prstGeom>
-          <a:solidFill>
-            <a:srgbClr val="F3F0FA"/>
-          </a:solidFill>
-          <a:ln w="3810">
-            <a:solidFill>
-              <a:srgbClr val="EEEEEE"/>
-            </a:solidFill>
-            <a:prstDash val="solid"/>
-          </a:ln>
-        </p:spPr>
-        <p:txBody>
-          <a:bodyPr/>
-          <a:lstStyle/>
-          <a:p>
-            <a:endParaRPr lang="en-IN"/>
-          </a:p>
-        </p:txBody>
-      </p:sp>
-      <p:sp>
-        <p:nvSpPr>
-          <p:cNvPr id="151" name="Shape 149"/>
-          <p:cNvSpPr/>
-          <p:nvPr/>
-        </p:nvSpPr>
-        <p:spPr>
-          <a:xfrm>
-            <a:off x="4626864" y="2523744"/>
-            <a:ext cx="36576" cy="219456"/>
-          </a:xfrm>
-          <a:prstGeom prst="rect">
-            <a:avLst/>
-          </a:prstGeom>
-          <a:solidFill>
-            <a:srgbClr val="6B21D4"/>
-          </a:solidFill>
-          <a:ln w="12700">
-            <a:solidFill>
-              <a:srgbClr val="6B21D4"/>
-            </a:solidFill>
-            <a:prstDash val="solid"/>
-          </a:ln>
-        </p:spPr>
-        <p:txBody>
-          <a:bodyPr/>
-          <a:lstStyle/>
-          <a:p>
-            <a:endParaRPr lang="en-IN"/>
-          </a:p>
-        </p:txBody>
-      </p:sp>
-      <p:sp>
-        <p:nvSpPr>
-          <p:cNvPr id="152" name="Text 150"/>
-          <p:cNvSpPr/>
-          <p:nvPr/>
-        </p:nvSpPr>
-        <p:spPr>
-          <a:xfrm>
-            <a:off x="4681728" y="2523744"/>
-            <a:ext cx="1584472" cy="219456"/>
-          </a:xfrm>
-          <a:prstGeom prst="rect">
-            <a:avLst/>
-          </a:prstGeom>
-          <a:noFill/>
-          <a:ln/>
-        </p:spPr>
-        <p:txBody>
-          <a:bodyPr wrap="square" lIns="0" tIns="0" rIns="0" bIns="0" rtlCol="0" anchor="ctr"/>
-          <a:lstStyle/>
-          <a:p>
-            <a:pPr marL="0" indent="0">
-              <a:buNone/>
-            </a:pPr>
-            <a:r>
-              <a:rPr lang="en-US" sz="750" b="1">
-                <a:solidFill>
-                  <a:srgbClr val="111111"/>
-                </a:solidFill>
-                <a:latin typeface="Calibri" pitchFamily="34" charset="0"/>
-                <a:ea typeface="Calibri" pitchFamily="34" charset="-122"/>
-                <a:cs typeface="Calibri" pitchFamily="34" charset="-120"/>
-              </a:rPr>
-              <a:t>Brahmananda R</a:t>
-            </a:r>
-            <a:endParaRPr lang="en-US" sz="750"/>
-          </a:p>
-        </p:txBody>
-      </p:sp>
-      <p:sp>
-        <p:nvSpPr>
-          <p:cNvPr id="153" name="Text 151"/>
-          <p:cNvSpPr/>
-          <p:nvPr/>
-        </p:nvSpPr>
-        <p:spPr>
-          <a:xfrm>
-            <a:off x="6266200" y="2523744"/>
-            <a:ext cx="1459382" cy="219456"/>
-          </a:xfrm>
-          <a:prstGeom prst="rect">
-            <a:avLst/>
-          </a:prstGeom>
-          <a:noFill/>
-          <a:ln/>
-        </p:spPr>
-        <p:txBody>
-          <a:bodyPr wrap="square" lIns="0" tIns="0" rIns="0" bIns="0" rtlCol="0" anchor="ctr"/>
-          <a:lstStyle/>
-          <a:p>
-            <a:pPr marL="0" indent="0">
-              <a:buNone/>
-            </a:pPr>
-            <a:r>
-              <a:rPr lang="en-US" sz="700">
-                <a:solidFill>
-                  <a:srgbClr val="6B21D4"/>
-                </a:solidFill>
-                <a:latin typeface="Calibri" pitchFamily="34" charset="0"/>
-                <a:ea typeface="Calibri" pitchFamily="34" charset="-122"/>
-                <a:cs typeface="Calibri" pitchFamily="34" charset="-120"/>
-              </a:rPr>
-              <a:t>QA – Functional</a:t>
-            </a:r>
-            <a:endParaRPr lang="en-US" sz="700"/>
-          </a:p>
-        </p:txBody>
-      </p:sp>
-      <p:sp>
-        <p:nvSpPr>
-          <p:cNvPr id="154" name="Text 152"/>
-          <p:cNvSpPr/>
-          <p:nvPr/>
-        </p:nvSpPr>
-        <p:spPr>
-          <a:xfrm>
-            <a:off x="7725583" y="2523744"/>
-            <a:ext cx="1042416" cy="219456"/>
-          </a:xfrm>
-          <a:prstGeom prst="rect">
-            <a:avLst/>
-          </a:prstGeom>
-          <a:noFill/>
-          <a:ln/>
-        </p:spPr>
-        <p:txBody>
-          <a:bodyPr wrap="square" lIns="0" tIns="0" rIns="0" bIns="0" rtlCol="0" anchor="ctr"/>
-          <a:lstStyle/>
-          <a:p>
-            <a:pPr marL="0" indent="0">
-              <a:buNone/>
-            </a:pPr>
-            <a:r>
-              <a:rPr lang="en-US" sz="650">
-                <a:solidFill>
-                  <a:srgbClr val="777777"/>
-                </a:solidFill>
-                <a:latin typeface="Calibri" pitchFamily="34" charset="0"/>
-                <a:ea typeface="Calibri" pitchFamily="34" charset="-122"/>
-                <a:cs typeface="Calibri" pitchFamily="34" charset="-120"/>
-              </a:rPr>
-              <a:t>Offshore · Trane-ITC</a:t>
-            </a:r>
-            <a:endParaRPr lang="en-US" sz="650"/>
-          </a:p>
-        </p:txBody>
-      </p:sp>
-      <p:sp>
-        <p:nvSpPr>
-          <p:cNvPr id="155" name="Shape 153"/>
-          <p:cNvSpPr/>
-          <p:nvPr/>
-        </p:nvSpPr>
-        <p:spPr>
-          <a:xfrm>
-            <a:off x="4626864" y="2743200"/>
-            <a:ext cx="4169664" cy="219456"/>
-          </a:xfrm>
-          <a:prstGeom prst="rect">
-            <a:avLst/>
-          </a:prstGeom>
-          <a:solidFill>
-            <a:srgbClr val="FFFFFF"/>
-          </a:solidFill>
-          <a:ln w="3810">
-            <a:solidFill>
-              <a:srgbClr val="EEEEEE"/>
-            </a:solidFill>
-            <a:prstDash val="solid"/>
-          </a:ln>
-        </p:spPr>
-        <p:txBody>
-          <a:bodyPr/>
-          <a:lstStyle/>
-          <a:p>
-            <a:endParaRPr lang="en-IN"/>
-          </a:p>
-        </p:txBody>
-      </p:sp>
-      <p:sp>
-        <p:nvSpPr>
-          <p:cNvPr id="156" name="Shape 154"/>
-          <p:cNvSpPr/>
-          <p:nvPr/>
-        </p:nvSpPr>
-        <p:spPr>
-          <a:xfrm>
-            <a:off x="4626864" y="2743200"/>
-            <a:ext cx="36576" cy="219456"/>
-          </a:xfrm>
-          <a:prstGeom prst="rect">
-            <a:avLst/>
-          </a:prstGeom>
-          <a:solidFill>
-            <a:srgbClr val="6B21D4"/>
-          </a:solidFill>
-          <a:ln w="12700">
-            <a:solidFill>
-              <a:srgbClr val="6B21D4"/>
-            </a:solidFill>
-            <a:prstDash val="solid"/>
-          </a:ln>
-        </p:spPr>
-        <p:txBody>
-          <a:bodyPr/>
-          <a:lstStyle/>
-          <a:p>
-            <a:endParaRPr lang="en-IN"/>
-          </a:p>
-        </p:txBody>
-      </p:sp>
-      <p:sp>
-        <p:nvSpPr>
-          <p:cNvPr id="157" name="Text 155"/>
-          <p:cNvSpPr/>
-          <p:nvPr/>
-        </p:nvSpPr>
-        <p:spPr>
-          <a:xfrm>
-            <a:off x="4681728" y="2743200"/>
-            <a:ext cx="1584472" cy="219456"/>
-          </a:xfrm>
-          <a:prstGeom prst="rect">
-            <a:avLst/>
-          </a:prstGeom>
-          <a:noFill/>
-          <a:ln/>
-        </p:spPr>
-        <p:txBody>
-          <a:bodyPr wrap="square" lIns="0" tIns="0" rIns="0" bIns="0" rtlCol="0" anchor="ctr"/>
-          <a:lstStyle/>
-          <a:p>
-            <a:pPr marL="0" indent="0">
-              <a:buNone/>
-            </a:pPr>
-            <a:r>
-              <a:rPr lang="en-US" sz="750" b="1">
-                <a:solidFill>
-                  <a:srgbClr val="111111"/>
-                </a:solidFill>
-                <a:latin typeface="Calibri" pitchFamily="34" charset="0"/>
-                <a:ea typeface="Calibri" pitchFamily="34" charset="-122"/>
-                <a:cs typeface="Calibri" pitchFamily="34" charset="-120"/>
-              </a:rPr>
-              <a:t>Kavya B N</a:t>
-            </a:r>
-            <a:endParaRPr lang="en-US" sz="750"/>
-          </a:p>
-        </p:txBody>
-      </p:sp>
-      <p:sp>
-        <p:nvSpPr>
-          <p:cNvPr id="158" name="Text 156"/>
-          <p:cNvSpPr/>
-          <p:nvPr/>
-        </p:nvSpPr>
-        <p:spPr>
-          <a:xfrm>
-            <a:off x="6266200" y="2743200"/>
-            <a:ext cx="1459382" cy="219456"/>
-          </a:xfrm>
-          <a:prstGeom prst="rect">
-            <a:avLst/>
-          </a:prstGeom>
-          <a:noFill/>
-          <a:ln/>
-        </p:spPr>
-        <p:txBody>
-          <a:bodyPr wrap="square" lIns="0" tIns="0" rIns="0" bIns="0" rtlCol="0" anchor="ctr"/>
-          <a:lstStyle/>
-          <a:p>
-            <a:pPr marL="0" indent="0">
-              <a:buNone/>
-            </a:pPr>
-            <a:r>
-              <a:rPr lang="en-US" sz="700">
-                <a:solidFill>
-                  <a:srgbClr val="6B21D4"/>
-                </a:solidFill>
-                <a:latin typeface="Calibri" pitchFamily="34" charset="0"/>
-                <a:ea typeface="Calibri" pitchFamily="34" charset="-122"/>
-                <a:cs typeface="Calibri" pitchFamily="34" charset="-120"/>
-              </a:rPr>
-              <a:t>QA – Automation</a:t>
-            </a:r>
-            <a:endParaRPr lang="en-US" sz="700"/>
-          </a:p>
-        </p:txBody>
-      </p:sp>
-      <p:sp>
-        <p:nvSpPr>
           <p:cNvPr id="159" name="Text 157"/>
           <p:cNvSpPr/>
           <p:nvPr/>
         </p:nvSpPr>
         <p:spPr>
           <a:xfrm>
-            <a:off x="7725583" y="2743200"/>
+            <a:off x="7725583" y="2770632"/>
             <a:ext cx="1042416" cy="219456"/>
           </a:xfrm>
           <a:prstGeom prst="rect">
@@ -36885,7 +36853,7 @@
         </p:nvSpPr>
         <p:spPr>
           <a:xfrm>
-            <a:off x="2380254" y="3250692"/>
+            <a:off x="2380254" y="3342132"/>
             <a:ext cx="4169664" cy="201168"/>
           </a:xfrm>
           <a:prstGeom prst="rect">
@@ -36923,7 +36891,7 @@
         </p:nvSpPr>
         <p:spPr>
           <a:xfrm>
-            <a:off x="2380254" y="3250692"/>
+            <a:off x="2380254" y="3342132"/>
             <a:ext cx="36576" cy="201168"/>
           </a:xfrm>
           <a:prstGeom prst="rect">
@@ -36961,7 +36929,7 @@
         </p:nvSpPr>
         <p:spPr>
           <a:xfrm>
-            <a:off x="2435118" y="3250692"/>
+            <a:off x="2435118" y="3342132"/>
             <a:ext cx="1584472" cy="201168"/>
           </a:xfrm>
           <a:prstGeom prst="rect">
@@ -37006,7 +36974,7 @@
         </p:nvSpPr>
         <p:spPr>
           <a:xfrm>
-            <a:off x="4019590" y="3250692"/>
+            <a:off x="4019590" y="3342132"/>
             <a:ext cx="1459382" cy="201168"/>
           </a:xfrm>
           <a:prstGeom prst="rect">
@@ -37051,7 +37019,7 @@
         </p:nvSpPr>
         <p:spPr>
           <a:xfrm>
-            <a:off x="5478973" y="3250692"/>
+            <a:off x="5478973" y="3342132"/>
             <a:ext cx="1042416" cy="201168"/>
           </a:xfrm>
           <a:prstGeom prst="rect">
@@ -37096,7 +37064,7 @@
         </p:nvSpPr>
         <p:spPr>
           <a:xfrm>
-            <a:off x="2380254" y="3451860"/>
+            <a:off x="2380254" y="3543300"/>
             <a:ext cx="4169664" cy="201168"/>
           </a:xfrm>
           <a:prstGeom prst="rect">
@@ -37134,7 +37102,7 @@
         </p:nvSpPr>
         <p:spPr>
           <a:xfrm>
-            <a:off x="2380254" y="3451860"/>
+            <a:off x="2380254" y="3543300"/>
             <a:ext cx="36576" cy="201168"/>
           </a:xfrm>
           <a:prstGeom prst="rect">
@@ -37172,7 +37140,7 @@
         </p:nvSpPr>
         <p:spPr>
           <a:xfrm>
-            <a:off x="2435118" y="3451860"/>
+            <a:off x="2435118" y="3543300"/>
             <a:ext cx="1584472" cy="201168"/>
           </a:xfrm>
           <a:prstGeom prst="rect">
@@ -37217,7 +37185,7 @@
         </p:nvSpPr>
         <p:spPr>
           <a:xfrm>
-            <a:off x="4019590" y="3451860"/>
+            <a:off x="4019590" y="3543300"/>
             <a:ext cx="1459382" cy="201168"/>
           </a:xfrm>
           <a:prstGeom prst="rect">
@@ -37262,7 +37230,7 @@
         </p:nvSpPr>
         <p:spPr>
           <a:xfrm>
-            <a:off x="5478973" y="3451860"/>
+            <a:off x="5478973" y="3543300"/>
             <a:ext cx="1042416" cy="201168"/>
           </a:xfrm>
           <a:prstGeom prst="rect">
@@ -37307,7 +37275,7 @@
         </p:nvSpPr>
         <p:spPr>
           <a:xfrm>
-            <a:off x="2380254" y="3653028"/>
+            <a:off x="2380254" y="3744468"/>
             <a:ext cx="4169664" cy="201168"/>
           </a:xfrm>
           <a:prstGeom prst="rect">
@@ -37345,7 +37313,7 @@
         </p:nvSpPr>
         <p:spPr>
           <a:xfrm>
-            <a:off x="2380254" y="3653028"/>
+            <a:off x="2380254" y="3744468"/>
             <a:ext cx="36576" cy="201168"/>
           </a:xfrm>
           <a:prstGeom prst="rect">
@@ -37383,7 +37351,7 @@
         </p:nvSpPr>
         <p:spPr>
           <a:xfrm>
-            <a:off x="2435118" y="3653028"/>
+            <a:off x="2435118" y="3744468"/>
             <a:ext cx="1584472" cy="201168"/>
           </a:xfrm>
           <a:prstGeom prst="rect">
@@ -37428,7 +37396,7 @@
         </p:nvSpPr>
         <p:spPr>
           <a:xfrm>
-            <a:off x="4019590" y="3653028"/>
+            <a:off x="4019590" y="3744468"/>
             <a:ext cx="1459382" cy="201168"/>
           </a:xfrm>
           <a:prstGeom prst="rect">
@@ -37473,7 +37441,7 @@
         </p:nvSpPr>
         <p:spPr>
           <a:xfrm>
-            <a:off x="5478973" y="3653028"/>
+            <a:off x="5478973" y="3744468"/>
             <a:ext cx="1042416" cy="201168"/>
           </a:xfrm>
           <a:prstGeom prst="rect">
@@ -37518,7 +37486,7 @@
         </p:nvSpPr>
         <p:spPr>
           <a:xfrm>
-            <a:off x="2380254" y="3854196"/>
+            <a:off x="2380254" y="3945636"/>
             <a:ext cx="4169664" cy="201168"/>
           </a:xfrm>
           <a:prstGeom prst="rect">
@@ -37556,7 +37524,7 @@
         </p:nvSpPr>
         <p:spPr>
           <a:xfrm>
-            <a:off x="2380254" y="3854196"/>
+            <a:off x="2380254" y="3945636"/>
             <a:ext cx="36576" cy="201168"/>
           </a:xfrm>
           <a:prstGeom prst="rect">
@@ -37594,7 +37562,7 @@
         </p:nvSpPr>
         <p:spPr>
           <a:xfrm>
-            <a:off x="2435118" y="3854196"/>
+            <a:off x="2435118" y="3945636"/>
             <a:ext cx="1584472" cy="201168"/>
           </a:xfrm>
           <a:prstGeom prst="rect">
@@ -37639,7 +37607,7 @@
         </p:nvSpPr>
         <p:spPr>
           <a:xfrm>
-            <a:off x="4019590" y="3854196"/>
+            <a:off x="4019590" y="3945636"/>
             <a:ext cx="1459382" cy="201168"/>
           </a:xfrm>
           <a:prstGeom prst="rect">
@@ -37684,7 +37652,7 @@
         </p:nvSpPr>
         <p:spPr>
           <a:xfrm>
-            <a:off x="5478973" y="3854196"/>
+            <a:off x="5478973" y="3945636"/>
             <a:ext cx="1042416" cy="201168"/>
           </a:xfrm>
           <a:prstGeom prst="rect">
@@ -37723,7 +37691,7 @@
         </p:nvSpPr>
         <p:spPr>
           <a:xfrm>
-            <a:off x="2380254" y="3015058"/>
+            <a:off x="2380254" y="3106498"/>
             <a:ext cx="4169664" cy="219456"/>
           </a:xfrm>
           <a:prstGeom prst="rect">

</xml_diff>

<commit_message>
Fix Slide 3 delivery track overlap
Co-authored-by: Sagar-konkanagaon <Sagar-konkanagaon@users.noreply.github.com>
</commit_message>
<xml_diff>
--- a/CHVAC_QA_Onboarding_Updated (1).pptx
+++ b/CHVAC_QA_Onboarding_Updated (1).pptx
@@ -19543,61 +19543,6 @@
       </p:sp>
       <p:sp>
         <p:nvSpPr>
-          <p:cNvPr id="8" name="Text 6"/>
-          <p:cNvSpPr/>
-          <p:nvPr/>
-        </p:nvSpPr>
-        <p:spPr>
-          <a:xfrm>
-            <a:off x="347472" y="1572767"/>
-            <a:ext cx="5029200" cy="2189335"/>
-          </a:xfrm>
-          <a:prstGeom prst="rect">
-            <a:avLst/>
-          </a:prstGeom>
-          <a:noFill/>
-          <a:ln/>
-        </p:spPr>
-        <p:txBody>
-          <a:bodyPr wrap="square" rtlCol="0" anchor="ctr"/>
-          <a:lstStyle/>
-          <a:p>
-            <a:r>
-              <a:rPr sz="1000">
-                <a:solidFill>
-                  <a:srgbClr val="1F2937"/>
-                </a:solidFill>
-                <a:latin typeface="Aptos"/>
-              </a:rPr>
-              <a:t>Delivery Tracks</a:t>
-            </a:r>
-          </a:p>
-          <a:p>
-            <a:r>
-              <a:rPr sz="1000">
-                <a:solidFill>
-                  <a:srgbClr val="1F2937"/>
-                </a:solidFill>
-                <a:latin typeface="Aptos"/>
-              </a:rPr>
-              <a:t>WorkSight Projects: TSA (Trane Select Assist) · Equipment (R12) · DMC / MDP · Jobs &amp; CoJo · Contracting (Team 1 &amp; 2) · Work Package · Documents (DocGen) · Service</a:t>
-            </a:r>
-          </a:p>
-          <a:p>
-            <a:r>
-              <a:rPr sz="1000">
-                <a:solidFill>
-                  <a:srgbClr val="1F2937"/>
-                </a:solidFill>
-                <a:latin typeface="Aptos"/>
-              </a:rPr>
-              <a:t>Other Projects: TDA (Trane Design Assist)</a:t>
-            </a:r>
-          </a:p>
-        </p:txBody>
-      </p:sp>
-      <p:sp>
-        <p:nvSpPr>
           <p:cNvPr id="13" name="Text 11"/>
           <p:cNvSpPr/>
           <p:nvPr/>
@@ -20355,6 +20300,340 @@
               <a:t>3</a:t>
             </a:r>
             <a:endParaRPr lang="en-US" sz="900" dirty="0"/>
+          </a:p>
+        </p:txBody>
+      </p:sp>
+      <p:sp>
+        <p:nvSpPr>
+          <p:cNvPr id="34" name="Rectangle 33"/>
+          <p:cNvSpPr/>
+          <p:nvPr/>
+        </p:nvSpPr>
+        <p:spPr>
+          <a:xfrm>
+            <a:off x="347472" y="1627632"/>
+            <a:ext cx="5029200" cy="182880"/>
+          </a:xfrm>
+          <a:prstGeom prst="rect">
+            <a:avLst/>
+          </a:prstGeom>
+          <a:noFill/>
+          <a:ln>
+            <a:noFill/>
+          </a:ln>
+        </p:spPr>
+        <p:style>
+          <a:lnRef idx="1">
+            <a:schemeClr val="accent1"/>
+          </a:lnRef>
+          <a:fillRef idx="3">
+            <a:schemeClr val="accent1"/>
+          </a:fillRef>
+          <a:effectRef idx="2">
+            <a:schemeClr val="accent1"/>
+          </a:effectRef>
+          <a:fontRef idx="minor">
+            <a:schemeClr val="lt1"/>
+          </a:fontRef>
+        </p:style>
+        <p:txBody>
+          <a:bodyPr rtlCol="0" anchor="t" wrap="square" lIns="0" rIns="0" tIns="0" bIns="0"/>
+          <a:lstStyle/>
+          <a:p>
+            <a:pPr algn="l"/>
+            <a:r>
+              <a:rPr sz="1000" b="1">
+                <a:solidFill>
+                  <a:srgbClr val="1F2937"/>
+                </a:solidFill>
+                <a:latin typeface="Aptos"/>
+              </a:rPr>
+              <a:t>Delivery Tracks</a:t>
+            </a:r>
+          </a:p>
+        </p:txBody>
+      </p:sp>
+      <p:sp>
+        <p:nvSpPr>
+          <p:cNvPr id="35" name="Rectangle 34"/>
+          <p:cNvSpPr/>
+          <p:nvPr/>
+        </p:nvSpPr>
+        <p:spPr>
+          <a:xfrm>
+            <a:off x="347472" y="1901952"/>
+            <a:ext cx="5029200" cy="182880"/>
+          </a:xfrm>
+          <a:prstGeom prst="rect">
+            <a:avLst/>
+          </a:prstGeom>
+          <a:noFill/>
+          <a:ln>
+            <a:noFill/>
+          </a:ln>
+        </p:spPr>
+        <p:style>
+          <a:lnRef idx="1">
+            <a:schemeClr val="accent1"/>
+          </a:lnRef>
+          <a:fillRef idx="3">
+            <a:schemeClr val="accent1"/>
+          </a:fillRef>
+          <a:effectRef idx="2">
+            <a:schemeClr val="accent1"/>
+          </a:effectRef>
+          <a:fontRef idx="minor">
+            <a:schemeClr val="lt1"/>
+          </a:fontRef>
+        </p:style>
+        <p:txBody>
+          <a:bodyPr rtlCol="0" anchor="t" wrap="square" lIns="0" rIns="0" tIns="0" bIns="0"/>
+          <a:lstStyle/>
+          <a:p>
+            <a:pPr algn="l"/>
+            <a:r>
+              <a:rPr sz="950" b="1">
+                <a:solidFill>
+                  <a:srgbClr val="1F2937"/>
+                </a:solidFill>
+                <a:latin typeface="Aptos"/>
+              </a:rPr>
+              <a:t>WorkSight Projects:</a:t>
+            </a:r>
+          </a:p>
+        </p:txBody>
+      </p:sp>
+      <p:sp>
+        <p:nvSpPr>
+          <p:cNvPr id="36" name="Rectangle 35"/>
+          <p:cNvSpPr/>
+          <p:nvPr/>
+        </p:nvSpPr>
+        <p:spPr>
+          <a:xfrm>
+            <a:off x="347472" y="2157984"/>
+            <a:ext cx="5029200" cy="1554480"/>
+          </a:xfrm>
+          <a:prstGeom prst="rect">
+            <a:avLst/>
+          </a:prstGeom>
+          <a:noFill/>
+          <a:ln>
+            <a:noFill/>
+          </a:ln>
+        </p:spPr>
+        <p:style>
+          <a:lnRef idx="1">
+            <a:schemeClr val="accent1"/>
+          </a:lnRef>
+          <a:fillRef idx="3">
+            <a:schemeClr val="accent1"/>
+          </a:fillRef>
+          <a:effectRef idx="2">
+            <a:schemeClr val="accent1"/>
+          </a:effectRef>
+          <a:fontRef idx="minor">
+            <a:schemeClr val="lt1"/>
+          </a:fontRef>
+        </p:style>
+        <p:txBody>
+          <a:bodyPr rtlCol="0" anchor="t" wrap="square" lIns="0" rIns="0" tIns="0" bIns="0"/>
+          <a:lstStyle/>
+          <a:p>
+            <a:pPr algn="l"/>
+            <a:r>
+              <a:rPr sz="850" b="0">
+                <a:solidFill>
+                  <a:srgbClr val="1F2937"/>
+                </a:solidFill>
+                <a:latin typeface="Aptos"/>
+              </a:rPr>
+              <a:t>- TSA (Trane Select Assist)</a:t>
+            </a:r>
+          </a:p>
+          <a:p>
+            <a:pPr algn="l"/>
+            <a:r>
+              <a:rPr sz="850" b="0">
+                <a:solidFill>
+                  <a:srgbClr val="1F2937"/>
+                </a:solidFill>
+                <a:latin typeface="Aptos"/>
+              </a:rPr>
+              <a:t>- Equipment (R12)</a:t>
+            </a:r>
+          </a:p>
+          <a:p>
+            <a:pPr algn="l"/>
+            <a:r>
+              <a:rPr sz="850" b="0">
+                <a:solidFill>
+                  <a:srgbClr val="1F2937"/>
+                </a:solidFill>
+                <a:latin typeface="Aptos"/>
+              </a:rPr>
+              <a:t>- DMC / MDP</a:t>
+            </a:r>
+          </a:p>
+          <a:p>
+            <a:pPr algn="l"/>
+            <a:r>
+              <a:rPr sz="850" b="0">
+                <a:solidFill>
+                  <a:srgbClr val="1F2937"/>
+                </a:solidFill>
+                <a:latin typeface="Aptos"/>
+              </a:rPr>
+              <a:t>- Jobs &amp; CoJo</a:t>
+            </a:r>
+          </a:p>
+          <a:p>
+            <a:pPr algn="l"/>
+            <a:r>
+              <a:rPr sz="850" b="0">
+                <a:solidFill>
+                  <a:srgbClr val="1F2937"/>
+                </a:solidFill>
+                <a:latin typeface="Aptos"/>
+              </a:rPr>
+              <a:t>- Contracting (Team 1 &amp; 2)</a:t>
+            </a:r>
+          </a:p>
+          <a:p>
+            <a:pPr algn="l"/>
+            <a:r>
+              <a:rPr sz="850" b="0">
+                <a:solidFill>
+                  <a:srgbClr val="1F2937"/>
+                </a:solidFill>
+                <a:latin typeface="Aptos"/>
+              </a:rPr>
+              <a:t>- Work Package</a:t>
+            </a:r>
+          </a:p>
+          <a:p>
+            <a:pPr algn="l"/>
+            <a:r>
+              <a:rPr sz="850" b="0">
+                <a:solidFill>
+                  <a:srgbClr val="1F2937"/>
+                </a:solidFill>
+                <a:latin typeface="Aptos"/>
+              </a:rPr>
+              <a:t>- Documents (DocGen)</a:t>
+            </a:r>
+          </a:p>
+          <a:p>
+            <a:pPr algn="l"/>
+            <a:r>
+              <a:rPr sz="850" b="0">
+                <a:solidFill>
+                  <a:srgbClr val="1F2937"/>
+                </a:solidFill>
+                <a:latin typeface="Aptos"/>
+              </a:rPr>
+              <a:t>- Service</a:t>
+            </a:r>
+          </a:p>
+        </p:txBody>
+      </p:sp>
+      <p:sp>
+        <p:nvSpPr>
+          <p:cNvPr id="37" name="Rectangle 36"/>
+          <p:cNvSpPr/>
+          <p:nvPr/>
+        </p:nvSpPr>
+        <p:spPr>
+          <a:xfrm>
+            <a:off x="347472" y="3950208"/>
+            <a:ext cx="5029200" cy="182880"/>
+          </a:xfrm>
+          <a:prstGeom prst="rect">
+            <a:avLst/>
+          </a:prstGeom>
+          <a:noFill/>
+          <a:ln>
+            <a:noFill/>
+          </a:ln>
+        </p:spPr>
+        <p:style>
+          <a:lnRef idx="1">
+            <a:schemeClr val="accent1"/>
+          </a:lnRef>
+          <a:fillRef idx="3">
+            <a:schemeClr val="accent1"/>
+          </a:fillRef>
+          <a:effectRef idx="2">
+            <a:schemeClr val="accent1"/>
+          </a:effectRef>
+          <a:fontRef idx="minor">
+            <a:schemeClr val="lt1"/>
+          </a:fontRef>
+        </p:style>
+        <p:txBody>
+          <a:bodyPr rtlCol="0" anchor="t" wrap="square" lIns="0" rIns="0" tIns="0" bIns="0"/>
+          <a:lstStyle/>
+          <a:p>
+            <a:pPr algn="l"/>
+            <a:r>
+              <a:rPr sz="950" b="1">
+                <a:solidFill>
+                  <a:srgbClr val="1F2937"/>
+                </a:solidFill>
+                <a:latin typeface="Aptos"/>
+              </a:rPr>
+              <a:t>Other Projects:</a:t>
+            </a:r>
+          </a:p>
+        </p:txBody>
+      </p:sp>
+      <p:sp>
+        <p:nvSpPr>
+          <p:cNvPr id="38" name="Rectangle 37"/>
+          <p:cNvSpPr/>
+          <p:nvPr/>
+        </p:nvSpPr>
+        <p:spPr>
+          <a:xfrm>
+            <a:off x="347472" y="4206240"/>
+            <a:ext cx="5029200" cy="219456"/>
+          </a:xfrm>
+          <a:prstGeom prst="rect">
+            <a:avLst/>
+          </a:prstGeom>
+          <a:noFill/>
+          <a:ln>
+            <a:noFill/>
+          </a:ln>
+        </p:spPr>
+        <p:style>
+          <a:lnRef idx="1">
+            <a:schemeClr val="accent1"/>
+          </a:lnRef>
+          <a:fillRef idx="3">
+            <a:schemeClr val="accent1"/>
+          </a:fillRef>
+          <a:effectRef idx="2">
+            <a:schemeClr val="accent1"/>
+          </a:effectRef>
+          <a:fontRef idx="minor">
+            <a:schemeClr val="lt1"/>
+          </a:fontRef>
+        </p:style>
+        <p:txBody>
+          <a:bodyPr rtlCol="0" anchor="t" wrap="square" lIns="0" rIns="0" tIns="0" bIns="0"/>
+          <a:lstStyle/>
+          <a:p>
+            <a:pPr algn="l"/>
+            <a:r>
+              <a:rPr sz="850" b="0">
+                <a:solidFill>
+                  <a:srgbClr val="1F2937"/>
+                </a:solidFill>
+                <a:latin typeface="Aptos"/>
+              </a:rPr>
+              <a:t>- TDA (Trane Design Assist)</a:t>
+            </a:r>
           </a:p>
         </p:txBody>
       </p:sp>

</xml_diff>

<commit_message>
Fix rendered PPT slide overlaps
Co-authored-by: Sagar-konkanagaon <Sagar-konkanagaon@users.noreply.github.com>
</commit_message>
<xml_diff>
--- a/CHVAC_QA_Onboarding_Updated (1).pptx
+++ b/CHVAC_QA_Onboarding_Updated (1).pptx
@@ -2094,7 +2094,7 @@
         </p:nvSpPr>
         <p:spPr>
           <a:xfrm>
-            <a:off x="265176" y="548640"/>
+            <a:off x="265176" y="658368"/>
             <a:ext cx="4169663" cy="219456"/>
           </a:xfrm>
           <a:prstGeom prst="rect">
@@ -2144,7 +2144,7 @@
         </p:nvSpPr>
         <p:spPr>
           <a:xfrm>
-            <a:off x="265176" y="786384"/>
+            <a:off x="265176" y="896112"/>
             <a:ext cx="4169663" cy="192024"/>
           </a:xfrm>
           <a:prstGeom prst="rect">
@@ -2189,7 +2189,7 @@
         </p:nvSpPr>
         <p:spPr>
           <a:xfrm>
-            <a:off x="265176" y="786384"/>
+            <a:off x="265176" y="896112"/>
             <a:ext cx="36576" cy="192024"/>
           </a:xfrm>
           <a:prstGeom prst="rect">
@@ -2234,7 +2234,7 @@
         </p:nvSpPr>
         <p:spPr>
           <a:xfrm>
-            <a:off x="320040" y="786384"/>
+            <a:off x="320040" y="896112"/>
             <a:ext cx="1581912" cy="192024"/>
           </a:xfrm>
           <a:prstGeom prst="rect">
@@ -2284,7 +2284,7 @@
         </p:nvSpPr>
         <p:spPr>
           <a:xfrm>
-            <a:off x="1901952" y="786384"/>
+            <a:off x="1901952" y="896112"/>
             <a:ext cx="1463040" cy="192024"/>
           </a:xfrm>
           <a:prstGeom prst="rect">
@@ -2334,7 +2334,7 @@
         </p:nvSpPr>
         <p:spPr>
           <a:xfrm>
-            <a:off x="3364992" y="786384"/>
+            <a:off x="3364992" y="896112"/>
             <a:ext cx="1042415" cy="192024"/>
           </a:xfrm>
           <a:prstGeom prst="rect">
@@ -2384,7 +2384,7 @@
         </p:nvSpPr>
         <p:spPr>
           <a:xfrm>
-            <a:off x="265176" y="978408"/>
+            <a:off x="265176" y="1088136"/>
             <a:ext cx="4169663" cy="192024"/>
           </a:xfrm>
           <a:prstGeom prst="rect">
@@ -2429,7 +2429,7 @@
         </p:nvSpPr>
         <p:spPr>
           <a:xfrm>
-            <a:off x="265176" y="978408"/>
+            <a:off x="265176" y="1088136"/>
             <a:ext cx="36576" cy="192024"/>
           </a:xfrm>
           <a:prstGeom prst="rect">
@@ -2474,7 +2474,7 @@
         </p:nvSpPr>
         <p:spPr>
           <a:xfrm>
-            <a:off x="320040" y="978408"/>
+            <a:off x="320040" y="1088136"/>
             <a:ext cx="1581912" cy="192024"/>
           </a:xfrm>
           <a:prstGeom prst="rect">
@@ -2524,7 +2524,7 @@
         </p:nvSpPr>
         <p:spPr>
           <a:xfrm>
-            <a:off x="1901952" y="978408"/>
+            <a:off x="1901952" y="1088136"/>
             <a:ext cx="1463040" cy="192024"/>
           </a:xfrm>
           <a:prstGeom prst="rect">
@@ -2574,7 +2574,7 @@
         </p:nvSpPr>
         <p:spPr>
           <a:xfrm>
-            <a:off x="3364992" y="978408"/>
+            <a:off x="3364992" y="1088136"/>
             <a:ext cx="1042415" cy="192024"/>
           </a:xfrm>
           <a:prstGeom prst="rect">
@@ -2624,7 +2624,7 @@
         </p:nvSpPr>
         <p:spPr>
           <a:xfrm>
-            <a:off x="265176" y="1170432"/>
+            <a:off x="265176" y="1280160"/>
             <a:ext cx="4169663" cy="192024"/>
           </a:xfrm>
           <a:prstGeom prst="rect">
@@ -2669,7 +2669,7 @@
         </p:nvSpPr>
         <p:spPr>
           <a:xfrm>
-            <a:off x="265176" y="1170432"/>
+            <a:off x="265176" y="1280160"/>
             <a:ext cx="36576" cy="192024"/>
           </a:xfrm>
           <a:prstGeom prst="rect">
@@ -2714,7 +2714,7 @@
         </p:nvSpPr>
         <p:spPr>
           <a:xfrm>
-            <a:off x="320040" y="1170432"/>
+            <a:off x="320040" y="1280160"/>
             <a:ext cx="1581912" cy="192024"/>
           </a:xfrm>
           <a:prstGeom prst="rect">
@@ -2764,7 +2764,7 @@
         </p:nvSpPr>
         <p:spPr>
           <a:xfrm>
-            <a:off x="1901952" y="1170432"/>
+            <a:off x="1901952" y="1280160"/>
             <a:ext cx="1463040" cy="192024"/>
           </a:xfrm>
           <a:prstGeom prst="rect">
@@ -2814,7 +2814,7 @@
         </p:nvSpPr>
         <p:spPr>
           <a:xfrm>
-            <a:off x="3364992" y="1170432"/>
+            <a:off x="3364992" y="1280160"/>
             <a:ext cx="1042415" cy="192024"/>
           </a:xfrm>
           <a:prstGeom prst="rect">
@@ -2864,7 +2864,7 @@
         </p:nvSpPr>
         <p:spPr>
           <a:xfrm>
-            <a:off x="265176" y="1362456"/>
+            <a:off x="265176" y="1472184"/>
             <a:ext cx="4169663" cy="192024"/>
           </a:xfrm>
           <a:prstGeom prst="rect">
@@ -2909,7 +2909,7 @@
         </p:nvSpPr>
         <p:spPr>
           <a:xfrm>
-            <a:off x="265176" y="1362456"/>
+            <a:off x="265176" y="1472184"/>
             <a:ext cx="36576" cy="192024"/>
           </a:xfrm>
           <a:prstGeom prst="rect">
@@ -2954,7 +2954,7 @@
         </p:nvSpPr>
         <p:spPr>
           <a:xfrm>
-            <a:off x="320040" y="1362456"/>
+            <a:off x="320040" y="1472184"/>
             <a:ext cx="1581912" cy="192024"/>
           </a:xfrm>
           <a:prstGeom prst="rect">
@@ -3004,7 +3004,7 @@
         </p:nvSpPr>
         <p:spPr>
           <a:xfrm>
-            <a:off x="1901952" y="1362456"/>
+            <a:off x="1901952" y="1472184"/>
             <a:ext cx="1463040" cy="192024"/>
           </a:xfrm>
           <a:prstGeom prst="rect">
@@ -3054,7 +3054,7 @@
         </p:nvSpPr>
         <p:spPr>
           <a:xfrm>
-            <a:off x="3364992" y="1362456"/>
+            <a:off x="3364992" y="1472184"/>
             <a:ext cx="1042415" cy="192024"/>
           </a:xfrm>
           <a:prstGeom prst="rect">
@@ -3104,7 +3104,7 @@
         </p:nvSpPr>
         <p:spPr>
           <a:xfrm>
-            <a:off x="265176" y="1664208"/>
+            <a:off x="265176" y="1773936"/>
             <a:ext cx="4169663" cy="219456"/>
           </a:xfrm>
           <a:prstGeom prst="rect">
@@ -3154,7 +3154,7 @@
         </p:nvSpPr>
         <p:spPr>
           <a:xfrm>
-            <a:off x="265176" y="1901952"/>
+            <a:off x="265176" y="2011680"/>
             <a:ext cx="4169663" cy="173736"/>
           </a:xfrm>
           <a:prstGeom prst="rect">
@@ -3199,7 +3199,7 @@
         </p:nvSpPr>
         <p:spPr>
           <a:xfrm>
-            <a:off x="265176" y="1901952"/>
+            <a:off x="265176" y="2011680"/>
             <a:ext cx="36576" cy="173736"/>
           </a:xfrm>
           <a:prstGeom prst="rect">
@@ -3244,7 +3244,7 @@
         </p:nvSpPr>
         <p:spPr>
           <a:xfrm>
-            <a:off x="320040" y="1901952"/>
+            <a:off x="320040" y="2011680"/>
             <a:ext cx="1581912" cy="173736"/>
           </a:xfrm>
           <a:prstGeom prst="rect">
@@ -3294,7 +3294,7 @@
         </p:nvSpPr>
         <p:spPr>
           <a:xfrm>
-            <a:off x="1901952" y="1901952"/>
+            <a:off x="1901952" y="2011680"/>
             <a:ext cx="1463040" cy="173736"/>
           </a:xfrm>
           <a:prstGeom prst="rect">
@@ -3344,7 +3344,7 @@
         </p:nvSpPr>
         <p:spPr>
           <a:xfrm>
-            <a:off x="3364992" y="1901952"/>
+            <a:off x="3364992" y="2011680"/>
             <a:ext cx="1042415" cy="173736"/>
           </a:xfrm>
           <a:prstGeom prst="rect">
@@ -3394,7 +3394,7 @@
         </p:nvSpPr>
         <p:spPr>
           <a:xfrm>
-            <a:off x="265176" y="2075688"/>
+            <a:off x="265176" y="2185416"/>
             <a:ext cx="4169663" cy="173736"/>
           </a:xfrm>
           <a:prstGeom prst="rect">
@@ -3439,7 +3439,7 @@
         </p:nvSpPr>
         <p:spPr>
           <a:xfrm>
-            <a:off x="265176" y="2075688"/>
+            <a:off x="265176" y="2185416"/>
             <a:ext cx="36576" cy="173736"/>
           </a:xfrm>
           <a:prstGeom prst="rect">
@@ -3484,7 +3484,7 @@
         </p:nvSpPr>
         <p:spPr>
           <a:xfrm>
-            <a:off x="320040" y="2075688"/>
+            <a:off x="320040" y="2185416"/>
             <a:ext cx="1581912" cy="173736"/>
           </a:xfrm>
           <a:prstGeom prst="rect">
@@ -3534,7 +3534,7 @@
         </p:nvSpPr>
         <p:spPr>
           <a:xfrm>
-            <a:off x="1901952" y="2075688"/>
+            <a:off x="1901952" y="2185416"/>
             <a:ext cx="1463040" cy="173736"/>
           </a:xfrm>
           <a:prstGeom prst="rect">
@@ -3584,7 +3584,7 @@
         </p:nvSpPr>
         <p:spPr>
           <a:xfrm>
-            <a:off x="3364992" y="2075688"/>
+            <a:off x="3364992" y="2185416"/>
             <a:ext cx="1042415" cy="173736"/>
           </a:xfrm>
           <a:prstGeom prst="rect">
@@ -3634,7 +3634,7 @@
         </p:nvSpPr>
         <p:spPr>
           <a:xfrm>
-            <a:off x="265176" y="2249424"/>
+            <a:off x="265176" y="2359152"/>
             <a:ext cx="4169663" cy="173736"/>
           </a:xfrm>
           <a:prstGeom prst="rect">
@@ -3679,7 +3679,7 @@
         </p:nvSpPr>
         <p:spPr>
           <a:xfrm>
-            <a:off x="265176" y="2249424"/>
+            <a:off x="265176" y="2359152"/>
             <a:ext cx="36576" cy="173736"/>
           </a:xfrm>
           <a:prstGeom prst="rect">
@@ -3724,7 +3724,7 @@
         </p:nvSpPr>
         <p:spPr>
           <a:xfrm>
-            <a:off x="320040" y="2249424"/>
+            <a:off x="320040" y="2359152"/>
             <a:ext cx="1581912" cy="173736"/>
           </a:xfrm>
           <a:prstGeom prst="rect">
@@ -3774,7 +3774,7 @@
         </p:nvSpPr>
         <p:spPr>
           <a:xfrm>
-            <a:off x="1901952" y="2249424"/>
+            <a:off x="1901952" y="2359152"/>
             <a:ext cx="1463040" cy="173736"/>
           </a:xfrm>
           <a:prstGeom prst="rect">
@@ -3824,7 +3824,7 @@
         </p:nvSpPr>
         <p:spPr>
           <a:xfrm>
-            <a:off x="3364992" y="2249424"/>
+            <a:off x="3364992" y="2359152"/>
             <a:ext cx="1042415" cy="173736"/>
           </a:xfrm>
           <a:prstGeom prst="rect">
@@ -3874,7 +3874,7 @@
         </p:nvSpPr>
         <p:spPr>
           <a:xfrm>
-            <a:off x="265176" y="2423160"/>
+            <a:off x="265176" y="2532888"/>
             <a:ext cx="4169663" cy="173736"/>
           </a:xfrm>
           <a:prstGeom prst="rect">
@@ -3919,7 +3919,7 @@
         </p:nvSpPr>
         <p:spPr>
           <a:xfrm>
-            <a:off x="265176" y="2423160"/>
+            <a:off x="265176" y="2532888"/>
             <a:ext cx="36576" cy="173736"/>
           </a:xfrm>
           <a:prstGeom prst="rect">
@@ -3964,7 +3964,7 @@
         </p:nvSpPr>
         <p:spPr>
           <a:xfrm>
-            <a:off x="320040" y="2423160"/>
+            <a:off x="320040" y="2532888"/>
             <a:ext cx="1581912" cy="173736"/>
           </a:xfrm>
           <a:prstGeom prst="rect">
@@ -4014,7 +4014,7 @@
         </p:nvSpPr>
         <p:spPr>
           <a:xfrm>
-            <a:off x="1901952" y="2423160"/>
+            <a:off x="1901952" y="2532888"/>
             <a:ext cx="1463040" cy="173736"/>
           </a:xfrm>
           <a:prstGeom prst="rect">
@@ -4064,7 +4064,7 @@
         </p:nvSpPr>
         <p:spPr>
           <a:xfrm>
-            <a:off x="3364992" y="2423160"/>
+            <a:off x="3364992" y="2532888"/>
             <a:ext cx="1042415" cy="173736"/>
           </a:xfrm>
           <a:prstGeom prst="rect">
@@ -4114,7 +4114,7 @@
         </p:nvSpPr>
         <p:spPr>
           <a:xfrm>
-            <a:off x="265176" y="2596896"/>
+            <a:off x="265176" y="2706624"/>
             <a:ext cx="4169663" cy="173736"/>
           </a:xfrm>
           <a:prstGeom prst="rect">
@@ -4159,7 +4159,7 @@
         </p:nvSpPr>
         <p:spPr>
           <a:xfrm>
-            <a:off x="265176" y="2596896"/>
+            <a:off x="265176" y="2706624"/>
             <a:ext cx="36576" cy="173736"/>
           </a:xfrm>
           <a:prstGeom prst="rect">
@@ -4204,7 +4204,7 @@
         </p:nvSpPr>
         <p:spPr>
           <a:xfrm>
-            <a:off x="320040" y="2596896"/>
+            <a:off x="320040" y="2706624"/>
             <a:ext cx="1581912" cy="173736"/>
           </a:xfrm>
           <a:prstGeom prst="rect">
@@ -4254,7 +4254,7 @@
         </p:nvSpPr>
         <p:spPr>
           <a:xfrm>
-            <a:off x="1901952" y="2596896"/>
+            <a:off x="1901952" y="2706624"/>
             <a:ext cx="1463040" cy="173736"/>
           </a:xfrm>
           <a:prstGeom prst="rect">
@@ -4304,7 +4304,7 @@
         </p:nvSpPr>
         <p:spPr>
           <a:xfrm>
-            <a:off x="3364992" y="2596896"/>
+            <a:off x="3364992" y="2706624"/>
             <a:ext cx="1042415" cy="173736"/>
           </a:xfrm>
           <a:prstGeom prst="rect">
@@ -4354,7 +4354,7 @@
         </p:nvSpPr>
         <p:spPr>
           <a:xfrm>
-            <a:off x="265176" y="2770632"/>
+            <a:off x="265176" y="2880360"/>
             <a:ext cx="4169663" cy="173736"/>
           </a:xfrm>
           <a:prstGeom prst="rect">
@@ -4399,7 +4399,7 @@
         </p:nvSpPr>
         <p:spPr>
           <a:xfrm>
-            <a:off x="265176" y="2770632"/>
+            <a:off x="265176" y="2880360"/>
             <a:ext cx="36576" cy="173736"/>
           </a:xfrm>
           <a:prstGeom prst="rect">
@@ -4444,7 +4444,7 @@
         </p:nvSpPr>
         <p:spPr>
           <a:xfrm>
-            <a:off x="320040" y="2770632"/>
+            <a:off x="320040" y="2880360"/>
             <a:ext cx="1581912" cy="173736"/>
           </a:xfrm>
           <a:prstGeom prst="rect">
@@ -4494,7 +4494,7 @@
         </p:nvSpPr>
         <p:spPr>
           <a:xfrm>
-            <a:off x="1901952" y="2770632"/>
+            <a:off x="1901952" y="2880360"/>
             <a:ext cx="1463040" cy="173736"/>
           </a:xfrm>
           <a:prstGeom prst="rect">
@@ -4544,7 +4544,7 @@
         </p:nvSpPr>
         <p:spPr>
           <a:xfrm>
-            <a:off x="3364992" y="2770632"/>
+            <a:off x="3364992" y="2880360"/>
             <a:ext cx="1042415" cy="173736"/>
           </a:xfrm>
           <a:prstGeom prst="rect">
@@ -4594,7 +4594,7 @@
         </p:nvSpPr>
         <p:spPr>
           <a:xfrm>
-            <a:off x="265176" y="2944368"/>
+            <a:off x="265176" y="3054096"/>
             <a:ext cx="4169663" cy="173736"/>
           </a:xfrm>
           <a:prstGeom prst="rect">
@@ -4639,7 +4639,7 @@
         </p:nvSpPr>
         <p:spPr>
           <a:xfrm>
-            <a:off x="265176" y="2944368"/>
+            <a:off x="265176" y="3054096"/>
             <a:ext cx="36576" cy="173736"/>
           </a:xfrm>
           <a:prstGeom prst="rect">
@@ -4684,7 +4684,7 @@
         </p:nvSpPr>
         <p:spPr>
           <a:xfrm>
-            <a:off x="320040" y="2944368"/>
+            <a:off x="320040" y="3054096"/>
             <a:ext cx="1581912" cy="173736"/>
           </a:xfrm>
           <a:prstGeom prst="rect">
@@ -4734,7 +4734,7 @@
         </p:nvSpPr>
         <p:spPr>
           <a:xfrm>
-            <a:off x="1901952" y="2944368"/>
+            <a:off x="1901952" y="3054096"/>
             <a:ext cx="1463040" cy="173736"/>
           </a:xfrm>
           <a:prstGeom prst="rect">
@@ -4784,7 +4784,7 @@
         </p:nvSpPr>
         <p:spPr>
           <a:xfrm>
-            <a:off x="3364992" y="2944368"/>
+            <a:off x="3364992" y="3054096"/>
             <a:ext cx="1042415" cy="173736"/>
           </a:xfrm>
           <a:prstGeom prst="rect">
@@ -4834,7 +4834,7 @@
         </p:nvSpPr>
         <p:spPr>
           <a:xfrm>
-            <a:off x="265176" y="3310128"/>
+            <a:off x="265176" y="3419856"/>
             <a:ext cx="4169663" cy="219456"/>
           </a:xfrm>
           <a:prstGeom prst="rect">
@@ -4884,7 +4884,7 @@
         </p:nvSpPr>
         <p:spPr>
           <a:xfrm>
-            <a:off x="265176" y="3547872"/>
+            <a:off x="265176" y="3657600"/>
             <a:ext cx="4169663" cy="173736"/>
           </a:xfrm>
           <a:prstGeom prst="rect">
@@ -4929,7 +4929,7 @@
         </p:nvSpPr>
         <p:spPr>
           <a:xfrm>
-            <a:off x="265176" y="3547872"/>
+            <a:off x="265176" y="3657600"/>
             <a:ext cx="36576" cy="173736"/>
           </a:xfrm>
           <a:prstGeom prst="rect">
@@ -4974,7 +4974,7 @@
         </p:nvSpPr>
         <p:spPr>
           <a:xfrm>
-            <a:off x="320040" y="3547872"/>
+            <a:off x="320040" y="3657600"/>
             <a:ext cx="1581912" cy="173736"/>
           </a:xfrm>
           <a:prstGeom prst="rect">
@@ -5024,7 +5024,7 @@
         </p:nvSpPr>
         <p:spPr>
           <a:xfrm>
-            <a:off x="1901952" y="3547872"/>
+            <a:off x="1901952" y="3657600"/>
             <a:ext cx="1463040" cy="173736"/>
           </a:xfrm>
           <a:prstGeom prst="rect">
@@ -5074,7 +5074,7 @@
         </p:nvSpPr>
         <p:spPr>
           <a:xfrm>
-            <a:off x="3364992" y="3547872"/>
+            <a:off x="3364992" y="3657600"/>
             <a:ext cx="1042415" cy="173736"/>
           </a:xfrm>
           <a:prstGeom prst="rect">
@@ -5124,7 +5124,7 @@
         </p:nvSpPr>
         <p:spPr>
           <a:xfrm>
-            <a:off x="265176" y="3721608"/>
+            <a:off x="265176" y="3831336"/>
             <a:ext cx="4169663" cy="173736"/>
           </a:xfrm>
           <a:prstGeom prst="rect">
@@ -5169,7 +5169,7 @@
         </p:nvSpPr>
         <p:spPr>
           <a:xfrm>
-            <a:off x="265176" y="3721608"/>
+            <a:off x="265176" y="3831336"/>
             <a:ext cx="36576" cy="173736"/>
           </a:xfrm>
           <a:prstGeom prst="rect">
@@ -5214,7 +5214,7 @@
         </p:nvSpPr>
         <p:spPr>
           <a:xfrm>
-            <a:off x="320040" y="3721608"/>
+            <a:off x="320040" y="3831336"/>
             <a:ext cx="1581912" cy="173736"/>
           </a:xfrm>
           <a:prstGeom prst="rect">
@@ -5264,7 +5264,7 @@
         </p:nvSpPr>
         <p:spPr>
           <a:xfrm>
-            <a:off x="1901952" y="3721608"/>
+            <a:off x="1901952" y="3831336"/>
             <a:ext cx="1463040" cy="173736"/>
           </a:xfrm>
           <a:prstGeom prst="rect">
@@ -5314,7 +5314,7 @@
         </p:nvSpPr>
         <p:spPr>
           <a:xfrm>
-            <a:off x="3364992" y="3721608"/>
+            <a:off x="3364992" y="3831336"/>
             <a:ext cx="1042415" cy="173736"/>
           </a:xfrm>
           <a:prstGeom prst="rect">
@@ -5364,7 +5364,7 @@
         </p:nvSpPr>
         <p:spPr>
           <a:xfrm>
-            <a:off x="265176" y="3895344"/>
+            <a:off x="265176" y="4005072"/>
             <a:ext cx="4169663" cy="173736"/>
           </a:xfrm>
           <a:prstGeom prst="rect">
@@ -5409,7 +5409,7 @@
         </p:nvSpPr>
         <p:spPr>
           <a:xfrm>
-            <a:off x="265176" y="3895344"/>
+            <a:off x="265176" y="4005072"/>
             <a:ext cx="36576" cy="173736"/>
           </a:xfrm>
           <a:prstGeom prst="rect">
@@ -5454,7 +5454,7 @@
         </p:nvSpPr>
         <p:spPr>
           <a:xfrm>
-            <a:off x="320040" y="3895344"/>
+            <a:off x="320040" y="4005072"/>
             <a:ext cx="1581912" cy="173736"/>
           </a:xfrm>
           <a:prstGeom prst="rect">
@@ -5504,7 +5504,7 @@
         </p:nvSpPr>
         <p:spPr>
           <a:xfrm>
-            <a:off x="1901952" y="3895344"/>
+            <a:off x="1901952" y="4005072"/>
             <a:ext cx="1463040" cy="173736"/>
           </a:xfrm>
           <a:prstGeom prst="rect">
@@ -5554,7 +5554,7 @@
         </p:nvSpPr>
         <p:spPr>
           <a:xfrm>
-            <a:off x="3364992" y="3895344"/>
+            <a:off x="3364992" y="4005072"/>
             <a:ext cx="1042415" cy="173736"/>
           </a:xfrm>
           <a:prstGeom prst="rect">
@@ -5604,7 +5604,7 @@
         </p:nvSpPr>
         <p:spPr>
           <a:xfrm>
-            <a:off x="265176" y="4069080"/>
+            <a:off x="265176" y="4178808"/>
             <a:ext cx="4169663" cy="173736"/>
           </a:xfrm>
           <a:prstGeom prst="rect">
@@ -5649,7 +5649,7 @@
         </p:nvSpPr>
         <p:spPr>
           <a:xfrm>
-            <a:off x="265176" y="4069080"/>
+            <a:off x="265176" y="4178808"/>
             <a:ext cx="36576" cy="173736"/>
           </a:xfrm>
           <a:prstGeom prst="rect">
@@ -5694,7 +5694,7 @@
         </p:nvSpPr>
         <p:spPr>
           <a:xfrm>
-            <a:off x="320040" y="4069080"/>
+            <a:off x="320040" y="4178808"/>
             <a:ext cx="1581912" cy="173736"/>
           </a:xfrm>
           <a:prstGeom prst="rect">
@@ -5744,7 +5744,7 @@
         </p:nvSpPr>
         <p:spPr>
           <a:xfrm>
-            <a:off x="1901952" y="4069080"/>
+            <a:off x="1901952" y="4178808"/>
             <a:ext cx="1463040" cy="173736"/>
           </a:xfrm>
           <a:prstGeom prst="rect">
@@ -5794,7 +5794,7 @@
         </p:nvSpPr>
         <p:spPr>
           <a:xfrm>
-            <a:off x="3364992" y="4069080"/>
+            <a:off x="3364992" y="4178808"/>
             <a:ext cx="1042415" cy="173736"/>
           </a:xfrm>
           <a:prstGeom prst="rect">
@@ -5844,7 +5844,7 @@
         </p:nvSpPr>
         <p:spPr>
           <a:xfrm>
-            <a:off x="265176" y="4242816"/>
+            <a:off x="265176" y="4352544"/>
             <a:ext cx="4169663" cy="173736"/>
           </a:xfrm>
           <a:prstGeom prst="rect">
@@ -5889,7 +5889,7 @@
         </p:nvSpPr>
         <p:spPr>
           <a:xfrm>
-            <a:off x="265176" y="4242816"/>
+            <a:off x="265176" y="4352544"/>
             <a:ext cx="36576" cy="173736"/>
           </a:xfrm>
           <a:prstGeom prst="rect">
@@ -5934,7 +5934,7 @@
         </p:nvSpPr>
         <p:spPr>
           <a:xfrm>
-            <a:off x="320040" y="4242816"/>
+            <a:off x="320040" y="4352544"/>
             <a:ext cx="1581912" cy="173736"/>
           </a:xfrm>
           <a:prstGeom prst="rect">
@@ -5984,7 +5984,7 @@
         </p:nvSpPr>
         <p:spPr>
           <a:xfrm>
-            <a:off x="1901952" y="4242816"/>
+            <a:off x="1901952" y="4352544"/>
             <a:ext cx="1463040" cy="173736"/>
           </a:xfrm>
           <a:prstGeom prst="rect">
@@ -6034,7 +6034,7 @@
         </p:nvSpPr>
         <p:spPr>
           <a:xfrm>
-            <a:off x="3364992" y="4242816"/>
+            <a:off x="3364992" y="4352544"/>
             <a:ext cx="1042415" cy="173736"/>
           </a:xfrm>
           <a:prstGeom prst="rect">
@@ -6084,7 +6084,7 @@
         </p:nvSpPr>
         <p:spPr>
           <a:xfrm>
-            <a:off x="265176" y="4416552"/>
+            <a:off x="265176" y="4526280"/>
             <a:ext cx="4169663" cy="173736"/>
           </a:xfrm>
           <a:prstGeom prst="rect">
@@ -6129,7 +6129,7 @@
         </p:nvSpPr>
         <p:spPr>
           <a:xfrm>
-            <a:off x="265176" y="4416552"/>
+            <a:off x="265176" y="4526280"/>
             <a:ext cx="36576" cy="173736"/>
           </a:xfrm>
           <a:prstGeom prst="rect">
@@ -6174,7 +6174,7 @@
         </p:nvSpPr>
         <p:spPr>
           <a:xfrm>
-            <a:off x="320040" y="4416552"/>
+            <a:off x="320040" y="4526280"/>
             <a:ext cx="1581912" cy="173736"/>
           </a:xfrm>
           <a:prstGeom prst="rect">
@@ -6224,7 +6224,7 @@
         </p:nvSpPr>
         <p:spPr>
           <a:xfrm>
-            <a:off x="1901952" y="4416552"/>
+            <a:off x="1901952" y="4526280"/>
             <a:ext cx="1463040" cy="173736"/>
           </a:xfrm>
           <a:prstGeom prst="rect">
@@ -6274,7 +6274,7 @@
         </p:nvSpPr>
         <p:spPr>
           <a:xfrm>
-            <a:off x="3364992" y="4416552"/>
+            <a:off x="3364992" y="4526280"/>
             <a:ext cx="1042415" cy="173736"/>
           </a:xfrm>
           <a:prstGeom prst="rect">
@@ -6324,7 +6324,7 @@
         </p:nvSpPr>
         <p:spPr>
           <a:xfrm>
-            <a:off x="4626864" y="548640"/>
+            <a:off x="4626864" y="658368"/>
             <a:ext cx="4169663" cy="219456"/>
           </a:xfrm>
           <a:prstGeom prst="rect">
@@ -6374,7 +6374,7 @@
         </p:nvSpPr>
         <p:spPr>
           <a:xfrm>
-            <a:off x="4626864" y="786384"/>
+            <a:off x="4626864" y="896112"/>
             <a:ext cx="4169663" cy="192024"/>
           </a:xfrm>
           <a:prstGeom prst="rect">
@@ -6419,7 +6419,7 @@
         </p:nvSpPr>
         <p:spPr>
           <a:xfrm>
-            <a:off x="4626864" y="786384"/>
+            <a:off x="4626864" y="896112"/>
             <a:ext cx="36576" cy="192024"/>
           </a:xfrm>
           <a:prstGeom prst="rect">
@@ -6464,7 +6464,7 @@
         </p:nvSpPr>
         <p:spPr>
           <a:xfrm>
-            <a:off x="4681727" y="786384"/>
+            <a:off x="4681727" y="896112"/>
             <a:ext cx="1581912" cy="192024"/>
           </a:xfrm>
           <a:prstGeom prst="rect">
@@ -6514,7 +6514,7 @@
         </p:nvSpPr>
         <p:spPr>
           <a:xfrm>
-            <a:off x="6263640" y="786384"/>
+            <a:off x="6263640" y="896112"/>
             <a:ext cx="1463040" cy="192024"/>
           </a:xfrm>
           <a:prstGeom prst="rect">
@@ -6564,7 +6564,7 @@
         </p:nvSpPr>
         <p:spPr>
           <a:xfrm>
-            <a:off x="7726679" y="786384"/>
+            <a:off x="7726679" y="896112"/>
             <a:ext cx="1042415" cy="192024"/>
           </a:xfrm>
           <a:prstGeom prst="rect">
@@ -6614,7 +6614,7 @@
         </p:nvSpPr>
         <p:spPr>
           <a:xfrm>
-            <a:off x="4626864" y="978408"/>
+            <a:off x="4626864" y="1088136"/>
             <a:ext cx="4169663" cy="192024"/>
           </a:xfrm>
           <a:prstGeom prst="rect">
@@ -6659,7 +6659,7 @@
         </p:nvSpPr>
         <p:spPr>
           <a:xfrm>
-            <a:off x="4626864" y="978408"/>
+            <a:off x="4626864" y="1088136"/>
             <a:ext cx="36576" cy="192024"/>
           </a:xfrm>
           <a:prstGeom prst="rect">
@@ -6704,7 +6704,7 @@
         </p:nvSpPr>
         <p:spPr>
           <a:xfrm>
-            <a:off x="4681727" y="978408"/>
+            <a:off x="4681727" y="1088136"/>
             <a:ext cx="1581912" cy="192024"/>
           </a:xfrm>
           <a:prstGeom prst="rect">
@@ -6754,7 +6754,7 @@
         </p:nvSpPr>
         <p:spPr>
           <a:xfrm>
-            <a:off x="6263640" y="978408"/>
+            <a:off x="6263640" y="1088136"/>
             <a:ext cx="1463040" cy="192024"/>
           </a:xfrm>
           <a:prstGeom prst="rect">
@@ -6804,7 +6804,7 @@
         </p:nvSpPr>
         <p:spPr>
           <a:xfrm>
-            <a:off x="7726679" y="978408"/>
+            <a:off x="7726679" y="1088136"/>
             <a:ext cx="1042415" cy="192024"/>
           </a:xfrm>
           <a:prstGeom prst="rect">
@@ -6854,7 +6854,7 @@
         </p:nvSpPr>
         <p:spPr>
           <a:xfrm>
-            <a:off x="4626864" y="1170432"/>
+            <a:off x="4626864" y="1280160"/>
             <a:ext cx="4169663" cy="192024"/>
           </a:xfrm>
           <a:prstGeom prst="rect">
@@ -6899,7 +6899,7 @@
         </p:nvSpPr>
         <p:spPr>
           <a:xfrm>
-            <a:off x="4626864" y="1170432"/>
+            <a:off x="4626864" y="1280160"/>
             <a:ext cx="36576" cy="192024"/>
           </a:xfrm>
           <a:prstGeom prst="rect">
@@ -6944,7 +6944,7 @@
         </p:nvSpPr>
         <p:spPr>
           <a:xfrm>
-            <a:off x="4681727" y="1170432"/>
+            <a:off x="4681727" y="1280160"/>
             <a:ext cx="1581912" cy="192024"/>
           </a:xfrm>
           <a:prstGeom prst="rect">
@@ -6994,7 +6994,7 @@
         </p:nvSpPr>
         <p:spPr>
           <a:xfrm>
-            <a:off x="6263640" y="1170432"/>
+            <a:off x="6263640" y="1280160"/>
             <a:ext cx="1463040" cy="192024"/>
           </a:xfrm>
           <a:prstGeom prst="rect">
@@ -7044,7 +7044,7 @@
         </p:nvSpPr>
         <p:spPr>
           <a:xfrm>
-            <a:off x="7726679" y="1170432"/>
+            <a:off x="7726679" y="1280160"/>
             <a:ext cx="1042415" cy="192024"/>
           </a:xfrm>
           <a:prstGeom prst="rect">
@@ -7094,7 +7094,7 @@
         </p:nvSpPr>
         <p:spPr>
           <a:xfrm>
-            <a:off x="4626864" y="1362456"/>
+            <a:off x="4626864" y="1472184"/>
             <a:ext cx="4169663" cy="192024"/>
           </a:xfrm>
           <a:prstGeom prst="rect">
@@ -7139,7 +7139,7 @@
         </p:nvSpPr>
         <p:spPr>
           <a:xfrm>
-            <a:off x="4626864" y="1362456"/>
+            <a:off x="4626864" y="1472184"/>
             <a:ext cx="36576" cy="192024"/>
           </a:xfrm>
           <a:prstGeom prst="rect">
@@ -7184,7 +7184,7 @@
         </p:nvSpPr>
         <p:spPr>
           <a:xfrm>
-            <a:off x="4681727" y="1362456"/>
+            <a:off x="4681727" y="1472184"/>
             <a:ext cx="1581912" cy="192024"/>
           </a:xfrm>
           <a:prstGeom prst="rect">
@@ -7234,7 +7234,7 @@
         </p:nvSpPr>
         <p:spPr>
           <a:xfrm>
-            <a:off x="6263640" y="1362456"/>
+            <a:off x="6263640" y="1472184"/>
             <a:ext cx="1463040" cy="192024"/>
           </a:xfrm>
           <a:prstGeom prst="rect">
@@ -7284,7 +7284,7 @@
         </p:nvSpPr>
         <p:spPr>
           <a:xfrm>
-            <a:off x="7726679" y="1362456"/>
+            <a:off x="7726679" y="1472184"/>
             <a:ext cx="1042415" cy="192024"/>
           </a:xfrm>
           <a:prstGeom prst="rect">
@@ -7334,7 +7334,7 @@
         </p:nvSpPr>
         <p:spPr>
           <a:xfrm>
-            <a:off x="4626864" y="1847088"/>
+            <a:off x="4626864" y="1956816"/>
             <a:ext cx="4169663" cy="219456"/>
           </a:xfrm>
           <a:prstGeom prst="rect">
@@ -7384,7 +7384,7 @@
         </p:nvSpPr>
         <p:spPr>
           <a:xfrm>
-            <a:off x="4626864" y="2084831"/>
+            <a:off x="4626864" y="2194559"/>
             <a:ext cx="4169663" cy="192024"/>
           </a:xfrm>
           <a:prstGeom prst="rect">
@@ -7429,7 +7429,7 @@
         </p:nvSpPr>
         <p:spPr>
           <a:xfrm>
-            <a:off x="4626864" y="2084831"/>
+            <a:off x="4626864" y="2194559"/>
             <a:ext cx="36576" cy="192024"/>
           </a:xfrm>
           <a:prstGeom prst="rect">
@@ -7474,7 +7474,7 @@
         </p:nvSpPr>
         <p:spPr>
           <a:xfrm>
-            <a:off x="4681727" y="2084831"/>
+            <a:off x="4681727" y="2194559"/>
             <a:ext cx="1581912" cy="192024"/>
           </a:xfrm>
           <a:prstGeom prst="rect">
@@ -7524,7 +7524,7 @@
         </p:nvSpPr>
         <p:spPr>
           <a:xfrm>
-            <a:off x="6263640" y="2084831"/>
+            <a:off x="6263640" y="2194559"/>
             <a:ext cx="1463040" cy="192024"/>
           </a:xfrm>
           <a:prstGeom prst="rect">
@@ -7574,7 +7574,7 @@
         </p:nvSpPr>
         <p:spPr>
           <a:xfrm>
-            <a:off x="7726679" y="2084831"/>
+            <a:off x="7726679" y="2194559"/>
             <a:ext cx="1042415" cy="192024"/>
           </a:xfrm>
           <a:prstGeom prst="rect">
@@ -7624,7 +7624,7 @@
         </p:nvSpPr>
         <p:spPr>
           <a:xfrm>
-            <a:off x="4626864" y="2276856"/>
+            <a:off x="4626864" y="2386584"/>
             <a:ext cx="4169663" cy="192024"/>
           </a:xfrm>
           <a:prstGeom prst="rect">
@@ -7669,7 +7669,7 @@
         </p:nvSpPr>
         <p:spPr>
           <a:xfrm>
-            <a:off x="4626864" y="2276856"/>
+            <a:off x="4626864" y="2386584"/>
             <a:ext cx="36576" cy="192024"/>
           </a:xfrm>
           <a:prstGeom prst="rect">
@@ -7714,7 +7714,7 @@
         </p:nvSpPr>
         <p:spPr>
           <a:xfrm>
-            <a:off x="4681727" y="2276856"/>
+            <a:off x="4681727" y="2386584"/>
             <a:ext cx="1581912" cy="192024"/>
           </a:xfrm>
           <a:prstGeom prst="rect">
@@ -7764,7 +7764,7 @@
         </p:nvSpPr>
         <p:spPr>
           <a:xfrm>
-            <a:off x="6263640" y="2276856"/>
+            <a:off x="6263640" y="2386584"/>
             <a:ext cx="1463040" cy="192024"/>
           </a:xfrm>
           <a:prstGeom prst="rect">
@@ -7814,7 +7814,7 @@
         </p:nvSpPr>
         <p:spPr>
           <a:xfrm>
-            <a:off x="7726679" y="2276856"/>
+            <a:off x="7726679" y="2386584"/>
             <a:ext cx="1042415" cy="192024"/>
           </a:xfrm>
           <a:prstGeom prst="rect">
@@ -7864,7 +7864,7 @@
         </p:nvSpPr>
         <p:spPr>
           <a:xfrm>
-            <a:off x="4626864" y="2468879"/>
+            <a:off x="4626864" y="2578607"/>
             <a:ext cx="4169663" cy="192024"/>
           </a:xfrm>
           <a:prstGeom prst="rect">
@@ -7909,7 +7909,7 @@
         </p:nvSpPr>
         <p:spPr>
           <a:xfrm>
-            <a:off x="4626864" y="2468879"/>
+            <a:off x="4626864" y="2578607"/>
             <a:ext cx="36576" cy="192024"/>
           </a:xfrm>
           <a:prstGeom prst="rect">
@@ -7954,7 +7954,7 @@
         </p:nvSpPr>
         <p:spPr>
           <a:xfrm>
-            <a:off x="4681727" y="2468879"/>
+            <a:off x="4681727" y="2578607"/>
             <a:ext cx="1581912" cy="192024"/>
           </a:xfrm>
           <a:prstGeom prst="rect">
@@ -8004,7 +8004,7 @@
         </p:nvSpPr>
         <p:spPr>
           <a:xfrm>
-            <a:off x="6263640" y="2468879"/>
+            <a:off x="6263640" y="2578607"/>
             <a:ext cx="1463040" cy="192024"/>
           </a:xfrm>
           <a:prstGeom prst="rect">
@@ -8054,7 +8054,7 @@
         </p:nvSpPr>
         <p:spPr>
           <a:xfrm>
-            <a:off x="7726679" y="2468879"/>
+            <a:off x="7726679" y="2578607"/>
             <a:ext cx="1042415" cy="192024"/>
           </a:xfrm>
           <a:prstGeom prst="rect">
@@ -8104,7 +8104,7 @@
         </p:nvSpPr>
         <p:spPr>
           <a:xfrm>
-            <a:off x="4626864" y="2660903"/>
+            <a:off x="4626864" y="2770631"/>
             <a:ext cx="4169663" cy="192024"/>
           </a:xfrm>
           <a:prstGeom prst="rect">
@@ -8149,7 +8149,7 @@
         </p:nvSpPr>
         <p:spPr>
           <a:xfrm>
-            <a:off x="4626864" y="2660903"/>
+            <a:off x="4626864" y="2770631"/>
             <a:ext cx="36576" cy="192024"/>
           </a:xfrm>
           <a:prstGeom prst="rect">
@@ -8194,7 +8194,7 @@
         </p:nvSpPr>
         <p:spPr>
           <a:xfrm>
-            <a:off x="4681727" y="2660903"/>
+            <a:off x="4681727" y="2770631"/>
             <a:ext cx="1581912" cy="192024"/>
           </a:xfrm>
           <a:prstGeom prst="rect">
@@ -8244,7 +8244,7 @@
         </p:nvSpPr>
         <p:spPr>
           <a:xfrm>
-            <a:off x="6263640" y="2660903"/>
+            <a:off x="6263640" y="2770631"/>
             <a:ext cx="1463040" cy="192024"/>
           </a:xfrm>
           <a:prstGeom prst="rect">
@@ -8294,7 +8294,7 @@
         </p:nvSpPr>
         <p:spPr>
           <a:xfrm>
-            <a:off x="7726679" y="2660903"/>
+            <a:off x="7726679" y="2770631"/>
             <a:ext cx="1042415" cy="192024"/>
           </a:xfrm>
           <a:prstGeom prst="rect">
@@ -8344,7 +8344,7 @@
         </p:nvSpPr>
         <p:spPr>
           <a:xfrm>
-            <a:off x="4626864" y="3145536"/>
+            <a:off x="4626864" y="3255264"/>
             <a:ext cx="4169663" cy="219456"/>
           </a:xfrm>
           <a:prstGeom prst="rect">
@@ -8394,7 +8394,7 @@
         </p:nvSpPr>
         <p:spPr>
           <a:xfrm>
-            <a:off x="4626864" y="3383280"/>
+            <a:off x="4626864" y="3493008"/>
             <a:ext cx="4169663" cy="192024"/>
           </a:xfrm>
           <a:prstGeom prst="rect">
@@ -8439,7 +8439,7 @@
         </p:nvSpPr>
         <p:spPr>
           <a:xfrm>
-            <a:off x="4626864" y="3383280"/>
+            <a:off x="4626864" y="3493008"/>
             <a:ext cx="36576" cy="192024"/>
           </a:xfrm>
           <a:prstGeom prst="rect">
@@ -8484,7 +8484,7 @@
         </p:nvSpPr>
         <p:spPr>
           <a:xfrm>
-            <a:off x="4681727" y="3383280"/>
+            <a:off x="4681727" y="3493008"/>
             <a:ext cx="1581912" cy="192024"/>
           </a:xfrm>
           <a:prstGeom prst="rect">
@@ -8534,7 +8534,7 @@
         </p:nvSpPr>
         <p:spPr>
           <a:xfrm>
-            <a:off x="6263640" y="3383280"/>
+            <a:off x="6263640" y="3493008"/>
             <a:ext cx="1463040" cy="192024"/>
           </a:xfrm>
           <a:prstGeom prst="rect">
@@ -8584,7 +8584,7 @@
         </p:nvSpPr>
         <p:spPr>
           <a:xfrm>
-            <a:off x="7726679" y="3383280"/>
+            <a:off x="7726679" y="3493008"/>
             <a:ext cx="1042415" cy="192024"/>
           </a:xfrm>
           <a:prstGeom prst="rect">
@@ -8634,7 +8634,7 @@
         </p:nvSpPr>
         <p:spPr>
           <a:xfrm>
-            <a:off x="4626864" y="3575304"/>
+            <a:off x="4626864" y="3685032"/>
             <a:ext cx="4169663" cy="192024"/>
           </a:xfrm>
           <a:prstGeom prst="rect">
@@ -8679,7 +8679,7 @@
         </p:nvSpPr>
         <p:spPr>
           <a:xfrm>
-            <a:off x="4626864" y="3575304"/>
+            <a:off x="4626864" y="3685032"/>
             <a:ext cx="36576" cy="192024"/>
           </a:xfrm>
           <a:prstGeom prst="rect">
@@ -8724,7 +8724,7 @@
         </p:nvSpPr>
         <p:spPr>
           <a:xfrm>
-            <a:off x="4681727" y="3575304"/>
+            <a:off x="4681727" y="3685032"/>
             <a:ext cx="1581912" cy="192024"/>
           </a:xfrm>
           <a:prstGeom prst="rect">
@@ -8774,7 +8774,7 @@
         </p:nvSpPr>
         <p:spPr>
           <a:xfrm>
-            <a:off x="6263640" y="3575304"/>
+            <a:off x="6263640" y="3685032"/>
             <a:ext cx="1463040" cy="192024"/>
           </a:xfrm>
           <a:prstGeom prst="rect">
@@ -8824,7 +8824,7 @@
         </p:nvSpPr>
         <p:spPr>
           <a:xfrm>
-            <a:off x="7726679" y="3575304"/>
+            <a:off x="7726679" y="3685032"/>
             <a:ext cx="1042415" cy="192024"/>
           </a:xfrm>
           <a:prstGeom prst="rect">
@@ -17132,21 +17132,12 @@
           <a:bodyPr wrap="square" rtlCol="0" anchor="ctr"/>
           <a:lstStyle/>
           <a:p>
-            <a:pPr marL="0" indent="0">
-              <a:buNone/>
-            </a:pPr>
-            <a:r>
-              <a:rPr lang="en-US" sz="800" b="1" dirty="0">
-                <a:solidFill>
-                  <a:srgbClr val="111111"/>
-                </a:solidFill>
-                <a:latin typeface="Calibri" pitchFamily="34" charset="0"/>
-                <a:ea typeface="Calibri" pitchFamily="34" charset="-122"/>
-                <a:cs typeface="Calibri" pitchFamily="34" charset="-120"/>
-              </a:rPr>
-              <a:t>Contracting Team 1 &amp; 2</a:t>
-            </a:r>
-            <a:endParaRPr lang="en-US" sz="800" dirty="0"/>
+            <a:r>
+              <a:rPr sz="750">
+                <a:latin typeface="Aptos"/>
+              </a:rPr>
+              <a:t>Contracting T1 &amp; T2</a:t>
+            </a:r>
           </a:p>
         </p:txBody>
       </p:sp>

</xml_diff>

<commit_message>
Apply requested PPT edits with original styling
Co-authored-by: Sagar-konkanagaon <Sagar-konkanagaon@users.noreply.github.com>
</commit_message>
<xml_diff>
--- a/CHVAC_QA_Onboarding_Updated (1).pptx
+++ b/CHVAC_QA_Onboarding_Updated (1).pptx
@@ -2077,11 +2077,23 @@
             <a:r>
               <a:rPr sz="2000" b="1">
                 <a:solidFill>
-                  <a:srgbClr val="1F2937"/>
+                  <a:srgbClr val="6B21D4"/>
                 </a:solidFill>
                 <a:latin typeface="Aptos"/>
               </a:rPr>
-              <a:t>Other Teams – WorkPackage, TSA, TDA, Jobs CoJo, Documents, Service</a:t>
+              <a:t>Other Teams – WorkPackage, TSA, TDA, Jobs CoJo, Documents,</a:t>
+            </a:r>
+          </a:p>
+          <a:p>
+            <a:pPr algn="l"/>
+            <a:r>
+              <a:rPr sz="2000" b="1">
+                <a:solidFill>
+                  <a:srgbClr val="6B21D4"/>
+                </a:solidFill>
+                <a:latin typeface="Aptos"/>
+              </a:rPr>
+              <a:t>Service</a:t>
             </a:r>
           </a:p>
         </p:txBody>
@@ -2125,9 +2137,9 @@
           <a:p>
             <a:pPr algn="l"/>
             <a:r>
-              <a:rPr sz="950" b="0">
-                <a:solidFill>
-                  <a:srgbClr val="1F2937"/>
+              <a:rPr sz="950" b="1">
+                <a:solidFill>
+                  <a:srgbClr val="4A148C"/>
                 </a:solidFill>
                 <a:latin typeface="Aptos"/>
               </a:rPr>
@@ -2265,9 +2277,9 @@
           <a:p>
             <a:pPr algn="l"/>
             <a:r>
-              <a:rPr sz="750" b="0">
-                <a:solidFill>
-                  <a:srgbClr val="1F2937"/>
+              <a:rPr sz="750" b="1">
+                <a:solidFill>
+                  <a:srgbClr val="111111"/>
                 </a:solidFill>
                 <a:latin typeface="Aptos"/>
               </a:rPr>
@@ -2317,7 +2329,7 @@
             <a:r>
               <a:rPr sz="700" b="0">
                 <a:solidFill>
-                  <a:srgbClr val="1F2937"/>
+                  <a:srgbClr val="6B21D4"/>
                 </a:solidFill>
                 <a:latin typeface="Aptos"/>
               </a:rPr>
@@ -2367,7 +2379,7 @@
             <a:r>
               <a:rPr sz="650" b="0">
                 <a:solidFill>
-                  <a:srgbClr val="4B5563"/>
+                  <a:srgbClr val="777777"/>
                 </a:solidFill>
                 <a:latin typeface="Aptos"/>
               </a:rPr>
@@ -2505,9 +2517,9 @@
           <a:p>
             <a:pPr algn="l"/>
             <a:r>
-              <a:rPr sz="750" b="0">
-                <a:solidFill>
-                  <a:srgbClr val="1F2937"/>
+              <a:rPr sz="750" b="1">
+                <a:solidFill>
+                  <a:srgbClr val="111111"/>
                 </a:solidFill>
                 <a:latin typeface="Aptos"/>
               </a:rPr>
@@ -2557,7 +2569,7 @@
             <a:r>
               <a:rPr sz="700" b="0">
                 <a:solidFill>
-                  <a:srgbClr val="1F2937"/>
+                  <a:srgbClr val="6B21D4"/>
                 </a:solidFill>
                 <a:latin typeface="Aptos"/>
               </a:rPr>
@@ -2607,7 +2619,7 @@
             <a:r>
               <a:rPr sz="650" b="0">
                 <a:solidFill>
-                  <a:srgbClr val="4B5563"/>
+                  <a:srgbClr val="777777"/>
                 </a:solidFill>
                 <a:latin typeface="Aptos"/>
               </a:rPr>
@@ -2745,9 +2757,9 @@
           <a:p>
             <a:pPr algn="l"/>
             <a:r>
-              <a:rPr sz="750" b="0">
-                <a:solidFill>
-                  <a:srgbClr val="1F2937"/>
+              <a:rPr sz="750" b="1">
+                <a:solidFill>
+                  <a:srgbClr val="111111"/>
                 </a:solidFill>
                 <a:latin typeface="Aptos"/>
               </a:rPr>
@@ -2797,7 +2809,7 @@
             <a:r>
               <a:rPr sz="700" b="0">
                 <a:solidFill>
-                  <a:srgbClr val="1F2937"/>
+                  <a:srgbClr val="6B21D4"/>
                 </a:solidFill>
                 <a:latin typeface="Aptos"/>
               </a:rPr>
@@ -2847,7 +2859,7 @@
             <a:r>
               <a:rPr sz="650" b="0">
                 <a:solidFill>
-                  <a:srgbClr val="4B5563"/>
+                  <a:srgbClr val="777777"/>
                 </a:solidFill>
                 <a:latin typeface="Aptos"/>
               </a:rPr>
@@ -2985,9 +2997,9 @@
           <a:p>
             <a:pPr algn="l"/>
             <a:r>
-              <a:rPr sz="750" b="0">
-                <a:solidFill>
-                  <a:srgbClr val="1F2937"/>
+              <a:rPr sz="750" b="1">
+                <a:solidFill>
+                  <a:srgbClr val="111111"/>
                 </a:solidFill>
                 <a:latin typeface="Aptos"/>
               </a:rPr>
@@ -3037,7 +3049,7 @@
             <a:r>
               <a:rPr sz="700" b="0">
                 <a:solidFill>
-                  <a:srgbClr val="1F2937"/>
+                  <a:srgbClr val="6B21D4"/>
                 </a:solidFill>
                 <a:latin typeface="Aptos"/>
               </a:rPr>
@@ -3087,7 +3099,7 @@
             <a:r>
               <a:rPr sz="650" b="0">
                 <a:solidFill>
-                  <a:srgbClr val="4B5563"/>
+                  <a:srgbClr val="777777"/>
                 </a:solidFill>
                 <a:latin typeface="Aptos"/>
               </a:rPr>
@@ -3135,9 +3147,9 @@
           <a:p>
             <a:pPr algn="l"/>
             <a:r>
-              <a:rPr sz="950" b="0">
-                <a:solidFill>
-                  <a:srgbClr val="1F2937"/>
+              <a:rPr sz="950" b="1">
+                <a:solidFill>
+                  <a:srgbClr val="4A148C"/>
                 </a:solidFill>
                 <a:latin typeface="Aptos"/>
               </a:rPr>
@@ -3275,9 +3287,9 @@
           <a:p>
             <a:pPr algn="l"/>
             <a:r>
-              <a:rPr sz="750" b="0">
-                <a:solidFill>
-                  <a:srgbClr val="1F2937"/>
+              <a:rPr sz="750" b="1">
+                <a:solidFill>
+                  <a:srgbClr val="111111"/>
                 </a:solidFill>
                 <a:latin typeface="Aptos"/>
               </a:rPr>
@@ -3327,7 +3339,7 @@
             <a:r>
               <a:rPr sz="700" b="0">
                 <a:solidFill>
-                  <a:srgbClr val="1F2937"/>
+                  <a:srgbClr val="6B21D4"/>
                 </a:solidFill>
                 <a:latin typeface="Aptos"/>
               </a:rPr>
@@ -3377,7 +3389,7 @@
             <a:r>
               <a:rPr sz="650" b="0">
                 <a:solidFill>
-                  <a:srgbClr val="4B5563"/>
+                  <a:srgbClr val="777777"/>
                 </a:solidFill>
                 <a:latin typeface="Aptos"/>
               </a:rPr>
@@ -3515,9 +3527,9 @@
           <a:p>
             <a:pPr algn="l"/>
             <a:r>
-              <a:rPr sz="750" b="0">
-                <a:solidFill>
-                  <a:srgbClr val="1F2937"/>
+              <a:rPr sz="750" b="1">
+                <a:solidFill>
+                  <a:srgbClr val="111111"/>
                 </a:solidFill>
                 <a:latin typeface="Aptos"/>
               </a:rPr>
@@ -3567,7 +3579,7 @@
             <a:r>
               <a:rPr sz="700" b="0">
                 <a:solidFill>
-                  <a:srgbClr val="1F2937"/>
+                  <a:srgbClr val="6B21D4"/>
                 </a:solidFill>
                 <a:latin typeface="Aptos"/>
               </a:rPr>
@@ -3617,7 +3629,7 @@
             <a:r>
               <a:rPr sz="650" b="0">
                 <a:solidFill>
-                  <a:srgbClr val="4B5563"/>
+                  <a:srgbClr val="777777"/>
                 </a:solidFill>
                 <a:latin typeface="Aptos"/>
               </a:rPr>
@@ -3755,9 +3767,9 @@
           <a:p>
             <a:pPr algn="l"/>
             <a:r>
-              <a:rPr sz="750" b="0">
-                <a:solidFill>
-                  <a:srgbClr val="1F2937"/>
+              <a:rPr sz="750" b="1">
+                <a:solidFill>
+                  <a:srgbClr val="111111"/>
                 </a:solidFill>
                 <a:latin typeface="Aptos"/>
               </a:rPr>
@@ -3807,7 +3819,7 @@
             <a:r>
               <a:rPr sz="700" b="0">
                 <a:solidFill>
-                  <a:srgbClr val="1F2937"/>
+                  <a:srgbClr val="6B21D4"/>
                 </a:solidFill>
                 <a:latin typeface="Aptos"/>
               </a:rPr>
@@ -3857,7 +3869,7 @@
             <a:r>
               <a:rPr sz="650" b="0">
                 <a:solidFill>
-                  <a:srgbClr val="4B5563"/>
+                  <a:srgbClr val="777777"/>
                 </a:solidFill>
                 <a:latin typeface="Aptos"/>
               </a:rPr>
@@ -3995,9 +4007,9 @@
           <a:p>
             <a:pPr algn="l"/>
             <a:r>
-              <a:rPr sz="750" b="0">
-                <a:solidFill>
-                  <a:srgbClr val="1F2937"/>
+              <a:rPr sz="750" b="1">
+                <a:solidFill>
+                  <a:srgbClr val="111111"/>
                 </a:solidFill>
                 <a:latin typeface="Aptos"/>
               </a:rPr>
@@ -4047,7 +4059,7 @@
             <a:r>
               <a:rPr sz="700" b="0">
                 <a:solidFill>
-                  <a:srgbClr val="1F2937"/>
+                  <a:srgbClr val="6B21D4"/>
                 </a:solidFill>
                 <a:latin typeface="Aptos"/>
               </a:rPr>
@@ -4097,7 +4109,7 @@
             <a:r>
               <a:rPr sz="650" b="0">
                 <a:solidFill>
-                  <a:srgbClr val="4B5563"/>
+                  <a:srgbClr val="777777"/>
                 </a:solidFill>
                 <a:latin typeface="Aptos"/>
               </a:rPr>
@@ -4235,9 +4247,9 @@
           <a:p>
             <a:pPr algn="l"/>
             <a:r>
-              <a:rPr sz="750" b="0">
-                <a:solidFill>
-                  <a:srgbClr val="1F2937"/>
+              <a:rPr sz="750" b="1">
+                <a:solidFill>
+                  <a:srgbClr val="111111"/>
                 </a:solidFill>
                 <a:latin typeface="Aptos"/>
               </a:rPr>
@@ -4287,7 +4299,7 @@
             <a:r>
               <a:rPr sz="700" b="0">
                 <a:solidFill>
-                  <a:srgbClr val="1F2937"/>
+                  <a:srgbClr val="6B21D4"/>
                 </a:solidFill>
                 <a:latin typeface="Aptos"/>
               </a:rPr>
@@ -4337,7 +4349,7 @@
             <a:r>
               <a:rPr sz="650" b="0">
                 <a:solidFill>
-                  <a:srgbClr val="4B5563"/>
+                  <a:srgbClr val="777777"/>
                 </a:solidFill>
                 <a:latin typeface="Aptos"/>
               </a:rPr>
@@ -4475,9 +4487,9 @@
           <a:p>
             <a:pPr algn="l"/>
             <a:r>
-              <a:rPr sz="750" b="0">
-                <a:solidFill>
-                  <a:srgbClr val="1F2937"/>
+              <a:rPr sz="750" b="1">
+                <a:solidFill>
+                  <a:srgbClr val="111111"/>
                 </a:solidFill>
                 <a:latin typeface="Aptos"/>
               </a:rPr>
@@ -4527,7 +4539,7 @@
             <a:r>
               <a:rPr sz="700" b="0">
                 <a:solidFill>
-                  <a:srgbClr val="1F2937"/>
+                  <a:srgbClr val="6B21D4"/>
                 </a:solidFill>
                 <a:latin typeface="Aptos"/>
               </a:rPr>
@@ -4577,7 +4589,7 @@
             <a:r>
               <a:rPr sz="650" b="0">
                 <a:solidFill>
-                  <a:srgbClr val="4B5563"/>
+                  <a:srgbClr val="777777"/>
                 </a:solidFill>
                 <a:latin typeface="Aptos"/>
               </a:rPr>
@@ -4715,9 +4727,9 @@
           <a:p>
             <a:pPr algn="l"/>
             <a:r>
-              <a:rPr sz="750" b="0">
-                <a:solidFill>
-                  <a:srgbClr val="1F2937"/>
+              <a:rPr sz="750" b="1">
+                <a:solidFill>
+                  <a:srgbClr val="111111"/>
                 </a:solidFill>
                 <a:latin typeface="Aptos"/>
               </a:rPr>
@@ -4767,7 +4779,7 @@
             <a:r>
               <a:rPr sz="700" b="0">
                 <a:solidFill>
-                  <a:srgbClr val="1F2937"/>
+                  <a:srgbClr val="6B21D4"/>
                 </a:solidFill>
                 <a:latin typeface="Aptos"/>
               </a:rPr>
@@ -4817,7 +4829,7 @@
             <a:r>
               <a:rPr sz="650" b="0">
                 <a:solidFill>
-                  <a:srgbClr val="4B5563"/>
+                  <a:srgbClr val="777777"/>
                 </a:solidFill>
                 <a:latin typeface="Aptos"/>
               </a:rPr>
@@ -4865,9 +4877,9 @@
           <a:p>
             <a:pPr algn="l"/>
             <a:r>
-              <a:rPr sz="950" b="0">
-                <a:solidFill>
-                  <a:srgbClr val="1F2937"/>
+              <a:rPr sz="950" b="1">
+                <a:solidFill>
+                  <a:srgbClr val="4A148C"/>
                 </a:solidFill>
                 <a:latin typeface="Aptos"/>
               </a:rPr>
@@ -5005,9 +5017,9 @@
           <a:p>
             <a:pPr algn="l"/>
             <a:r>
-              <a:rPr sz="750" b="0">
-                <a:solidFill>
-                  <a:srgbClr val="1F2937"/>
+              <a:rPr sz="750" b="1">
+                <a:solidFill>
+                  <a:srgbClr val="111111"/>
                 </a:solidFill>
                 <a:latin typeface="Aptos"/>
               </a:rPr>
@@ -5057,7 +5069,7 @@
             <a:r>
               <a:rPr sz="700" b="0">
                 <a:solidFill>
-                  <a:srgbClr val="1F2937"/>
+                  <a:srgbClr val="6B21D4"/>
                 </a:solidFill>
                 <a:latin typeface="Aptos"/>
               </a:rPr>
@@ -5107,7 +5119,7 @@
             <a:r>
               <a:rPr sz="650" b="0">
                 <a:solidFill>
-                  <a:srgbClr val="4B5563"/>
+                  <a:srgbClr val="777777"/>
                 </a:solidFill>
                 <a:latin typeface="Aptos"/>
               </a:rPr>
@@ -5245,9 +5257,9 @@
           <a:p>
             <a:pPr algn="l"/>
             <a:r>
-              <a:rPr sz="750" b="0">
-                <a:solidFill>
-                  <a:srgbClr val="1F2937"/>
+              <a:rPr sz="750" b="1">
+                <a:solidFill>
+                  <a:srgbClr val="111111"/>
                 </a:solidFill>
                 <a:latin typeface="Aptos"/>
               </a:rPr>
@@ -5297,7 +5309,7 @@
             <a:r>
               <a:rPr sz="700" b="0">
                 <a:solidFill>
-                  <a:srgbClr val="1F2937"/>
+                  <a:srgbClr val="6B21D4"/>
                 </a:solidFill>
                 <a:latin typeface="Aptos"/>
               </a:rPr>
@@ -5347,7 +5359,7 @@
             <a:r>
               <a:rPr sz="650" b="0">
                 <a:solidFill>
-                  <a:srgbClr val="4B5563"/>
+                  <a:srgbClr val="777777"/>
                 </a:solidFill>
                 <a:latin typeface="Aptos"/>
               </a:rPr>
@@ -5485,9 +5497,9 @@
           <a:p>
             <a:pPr algn="l"/>
             <a:r>
-              <a:rPr sz="750" b="0">
-                <a:solidFill>
-                  <a:srgbClr val="1F2937"/>
+              <a:rPr sz="750" b="1">
+                <a:solidFill>
+                  <a:srgbClr val="111111"/>
                 </a:solidFill>
                 <a:latin typeface="Aptos"/>
               </a:rPr>
@@ -5537,7 +5549,7 @@
             <a:r>
               <a:rPr sz="700" b="0">
                 <a:solidFill>
-                  <a:srgbClr val="1F2937"/>
+                  <a:srgbClr val="6B21D4"/>
                 </a:solidFill>
                 <a:latin typeface="Aptos"/>
               </a:rPr>
@@ -5587,7 +5599,7 @@
             <a:r>
               <a:rPr sz="650" b="0">
                 <a:solidFill>
-                  <a:srgbClr val="4B5563"/>
+                  <a:srgbClr val="777777"/>
                 </a:solidFill>
                 <a:latin typeface="Aptos"/>
               </a:rPr>
@@ -5725,9 +5737,9 @@
           <a:p>
             <a:pPr algn="l"/>
             <a:r>
-              <a:rPr sz="750" b="0">
-                <a:solidFill>
-                  <a:srgbClr val="1F2937"/>
+              <a:rPr sz="750" b="1">
+                <a:solidFill>
+                  <a:srgbClr val="111111"/>
                 </a:solidFill>
                 <a:latin typeface="Aptos"/>
               </a:rPr>
@@ -5777,7 +5789,7 @@
             <a:r>
               <a:rPr sz="700" b="0">
                 <a:solidFill>
-                  <a:srgbClr val="1F2937"/>
+                  <a:srgbClr val="6B21D4"/>
                 </a:solidFill>
                 <a:latin typeface="Aptos"/>
               </a:rPr>
@@ -5827,7 +5839,7 @@
             <a:r>
               <a:rPr sz="650" b="0">
                 <a:solidFill>
-                  <a:srgbClr val="4B5563"/>
+                  <a:srgbClr val="777777"/>
                 </a:solidFill>
                 <a:latin typeface="Aptos"/>
               </a:rPr>
@@ -5965,9 +5977,9 @@
           <a:p>
             <a:pPr algn="l"/>
             <a:r>
-              <a:rPr sz="750" b="0">
-                <a:solidFill>
-                  <a:srgbClr val="1F2937"/>
+              <a:rPr sz="750" b="1">
+                <a:solidFill>
+                  <a:srgbClr val="111111"/>
                 </a:solidFill>
                 <a:latin typeface="Aptos"/>
               </a:rPr>
@@ -6017,7 +6029,7 @@
             <a:r>
               <a:rPr sz="700" b="0">
                 <a:solidFill>
-                  <a:srgbClr val="1F2937"/>
+                  <a:srgbClr val="6B21D4"/>
                 </a:solidFill>
                 <a:latin typeface="Aptos"/>
               </a:rPr>
@@ -6063,16 +6075,7 @@
           <a:bodyPr rtlCol="0" anchor="ctr" wrap="square" lIns="36576" rIns="36576" tIns="9144" bIns="9144"/>
           <a:lstStyle/>
           <a:p>
-            <a:pPr algn="l"/>
-            <a:r>
-              <a:rPr sz="650" b="0">
-                <a:solidFill>
-                  <a:srgbClr val="4B5563"/>
-                </a:solidFill>
-                <a:latin typeface="Aptos"/>
-              </a:rPr>
-              <a:t/>
-            </a:r>
+            <a:pPr algn="ctr"/>
           </a:p>
         </p:txBody>
       </p:sp>
@@ -6205,9 +6208,9 @@
           <a:p>
             <a:pPr algn="l"/>
             <a:r>
-              <a:rPr sz="750" b="0">
-                <a:solidFill>
-                  <a:srgbClr val="1F2937"/>
+              <a:rPr sz="750" b="1">
+                <a:solidFill>
+                  <a:srgbClr val="111111"/>
                 </a:solidFill>
                 <a:latin typeface="Aptos"/>
               </a:rPr>
@@ -6257,7 +6260,7 @@
             <a:r>
               <a:rPr sz="700" b="0">
                 <a:solidFill>
-                  <a:srgbClr val="1F2937"/>
+                  <a:srgbClr val="6B21D4"/>
                 </a:solidFill>
                 <a:latin typeface="Aptos"/>
               </a:rPr>
@@ -6303,16 +6306,7 @@
           <a:bodyPr rtlCol="0" anchor="ctr" wrap="square" lIns="36576" rIns="36576" tIns="9144" bIns="9144"/>
           <a:lstStyle/>
           <a:p>
-            <a:pPr algn="l"/>
-            <a:r>
-              <a:rPr sz="650" b="0">
-                <a:solidFill>
-                  <a:srgbClr val="4B5563"/>
-                </a:solidFill>
-                <a:latin typeface="Aptos"/>
-              </a:rPr>
-              <a:t/>
-            </a:r>
+            <a:pPr algn="ctr"/>
           </a:p>
         </p:txBody>
       </p:sp>
@@ -6355,9 +6349,9 @@
           <a:p>
             <a:pPr algn="l"/>
             <a:r>
-              <a:rPr sz="950" b="0">
-                <a:solidFill>
-                  <a:srgbClr val="1F2937"/>
+              <a:rPr sz="950" b="1">
+                <a:solidFill>
+                  <a:srgbClr val="4A148C"/>
                 </a:solidFill>
                 <a:latin typeface="Aptos"/>
               </a:rPr>
@@ -6495,9 +6489,9 @@
           <a:p>
             <a:pPr algn="l"/>
             <a:r>
-              <a:rPr sz="750" b="0">
-                <a:solidFill>
-                  <a:srgbClr val="1F2937"/>
+              <a:rPr sz="750" b="1">
+                <a:solidFill>
+                  <a:srgbClr val="111111"/>
                 </a:solidFill>
                 <a:latin typeface="Aptos"/>
               </a:rPr>
@@ -6547,7 +6541,7 @@
             <a:r>
               <a:rPr sz="700" b="0">
                 <a:solidFill>
-                  <a:srgbClr val="1F2937"/>
+                  <a:srgbClr val="6B21D4"/>
                 </a:solidFill>
                 <a:latin typeface="Aptos"/>
               </a:rPr>
@@ -6597,7 +6591,7 @@
             <a:r>
               <a:rPr sz="650" b="0">
                 <a:solidFill>
-                  <a:srgbClr val="4B5563"/>
+                  <a:srgbClr val="777777"/>
                 </a:solidFill>
                 <a:latin typeface="Aptos"/>
               </a:rPr>
@@ -6735,9 +6729,9 @@
           <a:p>
             <a:pPr algn="l"/>
             <a:r>
-              <a:rPr sz="750" b="0">
-                <a:solidFill>
-                  <a:srgbClr val="1F2937"/>
+              <a:rPr sz="750" b="1">
+                <a:solidFill>
+                  <a:srgbClr val="111111"/>
                 </a:solidFill>
                 <a:latin typeface="Aptos"/>
               </a:rPr>
@@ -6787,7 +6781,7 @@
             <a:r>
               <a:rPr sz="700" b="0">
                 <a:solidFill>
-                  <a:srgbClr val="1F2937"/>
+                  <a:srgbClr val="6B21D4"/>
                 </a:solidFill>
                 <a:latin typeface="Aptos"/>
               </a:rPr>
@@ -6837,7 +6831,7 @@
             <a:r>
               <a:rPr sz="650" b="0">
                 <a:solidFill>
-                  <a:srgbClr val="4B5563"/>
+                  <a:srgbClr val="777777"/>
                 </a:solidFill>
                 <a:latin typeface="Aptos"/>
               </a:rPr>
@@ -6975,9 +6969,9 @@
           <a:p>
             <a:pPr algn="l"/>
             <a:r>
-              <a:rPr sz="750" b="0">
-                <a:solidFill>
-                  <a:srgbClr val="1F2937"/>
+              <a:rPr sz="750" b="1">
+                <a:solidFill>
+                  <a:srgbClr val="111111"/>
                 </a:solidFill>
                 <a:latin typeface="Aptos"/>
               </a:rPr>
@@ -7027,7 +7021,7 @@
             <a:r>
               <a:rPr sz="700" b="0">
                 <a:solidFill>
-                  <a:srgbClr val="1F2937"/>
+                  <a:srgbClr val="6B21D4"/>
                 </a:solidFill>
                 <a:latin typeface="Aptos"/>
               </a:rPr>
@@ -7077,7 +7071,7 @@
             <a:r>
               <a:rPr sz="650" b="0">
                 <a:solidFill>
-                  <a:srgbClr val="4B5563"/>
+                  <a:srgbClr val="777777"/>
                 </a:solidFill>
                 <a:latin typeface="Aptos"/>
               </a:rPr>
@@ -7215,9 +7209,9 @@
           <a:p>
             <a:pPr algn="l"/>
             <a:r>
-              <a:rPr sz="750" b="0">
-                <a:solidFill>
-                  <a:srgbClr val="1F2937"/>
+              <a:rPr sz="750" b="1">
+                <a:solidFill>
+                  <a:srgbClr val="111111"/>
                 </a:solidFill>
                 <a:latin typeface="Aptos"/>
               </a:rPr>
@@ -7267,7 +7261,7 @@
             <a:r>
               <a:rPr sz="700" b="0">
                 <a:solidFill>
-                  <a:srgbClr val="1F2937"/>
+                  <a:srgbClr val="6B21D4"/>
                 </a:solidFill>
                 <a:latin typeface="Aptos"/>
               </a:rPr>
@@ -7317,7 +7311,7 @@
             <a:r>
               <a:rPr sz="650" b="0">
                 <a:solidFill>
-                  <a:srgbClr val="4B5563"/>
+                  <a:srgbClr val="777777"/>
                 </a:solidFill>
                 <a:latin typeface="Aptos"/>
               </a:rPr>
@@ -7365,9 +7359,9 @@
           <a:p>
             <a:pPr algn="l"/>
             <a:r>
-              <a:rPr sz="950" b="0">
-                <a:solidFill>
-                  <a:srgbClr val="1F2937"/>
+              <a:rPr sz="950" b="1">
+                <a:solidFill>
+                  <a:srgbClr val="4A148C"/>
                 </a:solidFill>
                 <a:latin typeface="Aptos"/>
               </a:rPr>
@@ -7384,7 +7378,7 @@
         </p:nvSpPr>
         <p:spPr>
           <a:xfrm>
-            <a:off x="4626864" y="2194559"/>
+            <a:off x="4626864" y="2194560"/>
             <a:ext cx="4169663" cy="192024"/>
           </a:xfrm>
           <a:prstGeom prst="rect">
@@ -7429,7 +7423,7 @@
         </p:nvSpPr>
         <p:spPr>
           <a:xfrm>
-            <a:off x="4626864" y="2194559"/>
+            <a:off x="4626864" y="2194560"/>
             <a:ext cx="36576" cy="192024"/>
           </a:xfrm>
           <a:prstGeom prst="rect">
@@ -7474,7 +7468,7 @@
         </p:nvSpPr>
         <p:spPr>
           <a:xfrm>
-            <a:off x="4681727" y="2194559"/>
+            <a:off x="4681727" y="2194560"/>
             <a:ext cx="1581912" cy="192024"/>
           </a:xfrm>
           <a:prstGeom prst="rect">
@@ -7505,9 +7499,9 @@
           <a:p>
             <a:pPr algn="l"/>
             <a:r>
-              <a:rPr sz="750" b="0">
-                <a:solidFill>
-                  <a:srgbClr val="1F2937"/>
+              <a:rPr sz="750" b="1">
+                <a:solidFill>
+                  <a:srgbClr val="111111"/>
                 </a:solidFill>
                 <a:latin typeface="Aptos"/>
               </a:rPr>
@@ -7524,7 +7518,7 @@
         </p:nvSpPr>
         <p:spPr>
           <a:xfrm>
-            <a:off x="6263640" y="2194559"/>
+            <a:off x="6263640" y="2194560"/>
             <a:ext cx="1463040" cy="192024"/>
           </a:xfrm>
           <a:prstGeom prst="rect">
@@ -7557,7 +7551,7 @@
             <a:r>
               <a:rPr sz="700" b="0">
                 <a:solidFill>
-                  <a:srgbClr val="1F2937"/>
+                  <a:srgbClr val="6B21D4"/>
                 </a:solidFill>
                 <a:latin typeface="Aptos"/>
               </a:rPr>
@@ -7574,7 +7568,7 @@
         </p:nvSpPr>
         <p:spPr>
           <a:xfrm>
-            <a:off x="7726679" y="2194559"/>
+            <a:off x="7726679" y="2194560"/>
             <a:ext cx="1042415" cy="192024"/>
           </a:xfrm>
           <a:prstGeom prst="rect">
@@ -7607,7 +7601,7 @@
             <a:r>
               <a:rPr sz="650" b="0">
                 <a:solidFill>
-                  <a:srgbClr val="4B5563"/>
+                  <a:srgbClr val="777777"/>
                 </a:solidFill>
                 <a:latin typeface="Aptos"/>
               </a:rPr>
@@ -7745,9 +7739,9 @@
           <a:p>
             <a:pPr algn="l"/>
             <a:r>
-              <a:rPr sz="750" b="0">
-                <a:solidFill>
-                  <a:srgbClr val="1F2937"/>
+              <a:rPr sz="750" b="1">
+                <a:solidFill>
+                  <a:srgbClr val="111111"/>
                 </a:solidFill>
                 <a:latin typeface="Aptos"/>
               </a:rPr>
@@ -7797,7 +7791,7 @@
             <a:r>
               <a:rPr sz="700" b="0">
                 <a:solidFill>
-                  <a:srgbClr val="1F2937"/>
+                  <a:srgbClr val="6B21D4"/>
                 </a:solidFill>
                 <a:latin typeface="Aptos"/>
               </a:rPr>
@@ -7847,7 +7841,7 @@
             <a:r>
               <a:rPr sz="650" b="0">
                 <a:solidFill>
-                  <a:srgbClr val="4B5563"/>
+                  <a:srgbClr val="777777"/>
                 </a:solidFill>
                 <a:latin typeface="Aptos"/>
               </a:rPr>
@@ -7864,7 +7858,7 @@
         </p:nvSpPr>
         <p:spPr>
           <a:xfrm>
-            <a:off x="4626864" y="2578607"/>
+            <a:off x="4626864" y="2578608"/>
             <a:ext cx="4169663" cy="192024"/>
           </a:xfrm>
           <a:prstGeom prst="rect">
@@ -7909,7 +7903,7 @@
         </p:nvSpPr>
         <p:spPr>
           <a:xfrm>
-            <a:off x="4626864" y="2578607"/>
+            <a:off x="4626864" y="2578608"/>
             <a:ext cx="36576" cy="192024"/>
           </a:xfrm>
           <a:prstGeom prst="rect">
@@ -7954,7 +7948,7 @@
         </p:nvSpPr>
         <p:spPr>
           <a:xfrm>
-            <a:off x="4681727" y="2578607"/>
+            <a:off x="4681727" y="2578608"/>
             <a:ext cx="1581912" cy="192024"/>
           </a:xfrm>
           <a:prstGeom prst="rect">
@@ -7985,9 +7979,9 @@
           <a:p>
             <a:pPr algn="l"/>
             <a:r>
-              <a:rPr sz="750" b="0">
-                <a:solidFill>
-                  <a:srgbClr val="1F2937"/>
+              <a:rPr sz="750" b="1">
+                <a:solidFill>
+                  <a:srgbClr val="111111"/>
                 </a:solidFill>
                 <a:latin typeface="Aptos"/>
               </a:rPr>
@@ -8004,7 +7998,7 @@
         </p:nvSpPr>
         <p:spPr>
           <a:xfrm>
-            <a:off x="6263640" y="2578607"/>
+            <a:off x="6263640" y="2578608"/>
             <a:ext cx="1463040" cy="192024"/>
           </a:xfrm>
           <a:prstGeom prst="rect">
@@ -8037,7 +8031,7 @@
             <a:r>
               <a:rPr sz="700" b="0">
                 <a:solidFill>
-                  <a:srgbClr val="1F2937"/>
+                  <a:srgbClr val="6B21D4"/>
                 </a:solidFill>
                 <a:latin typeface="Aptos"/>
               </a:rPr>
@@ -8054,7 +8048,7 @@
         </p:nvSpPr>
         <p:spPr>
           <a:xfrm>
-            <a:off x="7726679" y="2578607"/>
+            <a:off x="7726679" y="2578608"/>
             <a:ext cx="1042415" cy="192024"/>
           </a:xfrm>
           <a:prstGeom prst="rect">
@@ -8087,7 +8081,7 @@
             <a:r>
               <a:rPr sz="650" b="0">
                 <a:solidFill>
-                  <a:srgbClr val="4B5563"/>
+                  <a:srgbClr val="777777"/>
                 </a:solidFill>
                 <a:latin typeface="Aptos"/>
               </a:rPr>
@@ -8104,7 +8098,7 @@
         </p:nvSpPr>
         <p:spPr>
           <a:xfrm>
-            <a:off x="4626864" y="2770631"/>
+            <a:off x="4626864" y="2770632"/>
             <a:ext cx="4169663" cy="192024"/>
           </a:xfrm>
           <a:prstGeom prst="rect">
@@ -8149,7 +8143,7 @@
         </p:nvSpPr>
         <p:spPr>
           <a:xfrm>
-            <a:off x="4626864" y="2770631"/>
+            <a:off x="4626864" y="2770632"/>
             <a:ext cx="36576" cy="192024"/>
           </a:xfrm>
           <a:prstGeom prst="rect">
@@ -8194,7 +8188,7 @@
         </p:nvSpPr>
         <p:spPr>
           <a:xfrm>
-            <a:off x="4681727" y="2770631"/>
+            <a:off x="4681727" y="2770632"/>
             <a:ext cx="1581912" cy="192024"/>
           </a:xfrm>
           <a:prstGeom prst="rect">
@@ -8225,9 +8219,9 @@
           <a:p>
             <a:pPr algn="l"/>
             <a:r>
-              <a:rPr sz="750" b="0">
-                <a:solidFill>
-                  <a:srgbClr val="1F2937"/>
+              <a:rPr sz="750" b="1">
+                <a:solidFill>
+                  <a:srgbClr val="111111"/>
                 </a:solidFill>
                 <a:latin typeface="Aptos"/>
               </a:rPr>
@@ -8244,7 +8238,7 @@
         </p:nvSpPr>
         <p:spPr>
           <a:xfrm>
-            <a:off x="6263640" y="2770631"/>
+            <a:off x="6263640" y="2770632"/>
             <a:ext cx="1463040" cy="192024"/>
           </a:xfrm>
           <a:prstGeom prst="rect">
@@ -8277,7 +8271,7 @@
             <a:r>
               <a:rPr sz="700" b="0">
                 <a:solidFill>
-                  <a:srgbClr val="1F2937"/>
+                  <a:srgbClr val="6B21D4"/>
                 </a:solidFill>
                 <a:latin typeface="Aptos"/>
               </a:rPr>
@@ -8294,7 +8288,7 @@
         </p:nvSpPr>
         <p:spPr>
           <a:xfrm>
-            <a:off x="7726679" y="2770631"/>
+            <a:off x="7726679" y="2770632"/>
             <a:ext cx="1042415" cy="192024"/>
           </a:xfrm>
           <a:prstGeom prst="rect">
@@ -8327,7 +8321,7 @@
             <a:r>
               <a:rPr sz="650" b="0">
                 <a:solidFill>
-                  <a:srgbClr val="4B5563"/>
+                  <a:srgbClr val="777777"/>
                 </a:solidFill>
                 <a:latin typeface="Aptos"/>
               </a:rPr>
@@ -8375,9 +8369,9 @@
           <a:p>
             <a:pPr algn="l"/>
             <a:r>
-              <a:rPr sz="950" b="0">
-                <a:solidFill>
-                  <a:srgbClr val="1F2937"/>
+              <a:rPr sz="950" b="1">
+                <a:solidFill>
+                  <a:srgbClr val="4A148C"/>
                 </a:solidFill>
                 <a:latin typeface="Aptos"/>
               </a:rPr>
@@ -8515,9 +8509,9 @@
           <a:p>
             <a:pPr algn="l"/>
             <a:r>
-              <a:rPr sz="750" b="0">
-                <a:solidFill>
-                  <a:srgbClr val="1F2937"/>
+              <a:rPr sz="750" b="1">
+                <a:solidFill>
+                  <a:srgbClr val="111111"/>
                 </a:solidFill>
                 <a:latin typeface="Aptos"/>
               </a:rPr>
@@ -8567,7 +8561,7 @@
             <a:r>
               <a:rPr sz="700" b="0">
                 <a:solidFill>
-                  <a:srgbClr val="1F2937"/>
+                  <a:srgbClr val="6B21D4"/>
                 </a:solidFill>
                 <a:latin typeface="Aptos"/>
               </a:rPr>
@@ -8617,7 +8611,7 @@
             <a:r>
               <a:rPr sz="650" b="0">
                 <a:solidFill>
-                  <a:srgbClr val="4B5563"/>
+                  <a:srgbClr val="777777"/>
                 </a:solidFill>
                 <a:latin typeface="Aptos"/>
               </a:rPr>
@@ -8755,9 +8749,9 @@
           <a:p>
             <a:pPr algn="l"/>
             <a:r>
-              <a:rPr sz="750" b="0">
-                <a:solidFill>
-                  <a:srgbClr val="1F2937"/>
+              <a:rPr sz="750" b="1">
+                <a:solidFill>
+                  <a:srgbClr val="111111"/>
                 </a:solidFill>
                 <a:latin typeface="Aptos"/>
               </a:rPr>
@@ -8807,7 +8801,7 @@
             <a:r>
               <a:rPr sz="700" b="0">
                 <a:solidFill>
-                  <a:srgbClr val="1F2937"/>
+                  <a:srgbClr val="6B21D4"/>
                 </a:solidFill>
                 <a:latin typeface="Aptos"/>
               </a:rPr>
@@ -8857,7 +8851,7 @@
             <a:r>
               <a:rPr sz="650" b="0">
                 <a:solidFill>
-                  <a:srgbClr val="4B5563"/>
+                  <a:srgbClr val="777777"/>
                 </a:solidFill>
                 <a:latin typeface="Aptos"/>
               </a:rPr>
@@ -13827,7 +13821,7 @@
         </p:nvSpPr>
         <p:spPr>
           <a:xfrm>
-            <a:off x="361058" y="2913888"/>
+            <a:off x="361058" y="2926080"/>
             <a:ext cx="1371600" cy="274320"/>
           </a:xfrm>
           <a:prstGeom prst="rect">
@@ -13872,7 +13866,7 @@
         </p:nvSpPr>
         <p:spPr>
           <a:xfrm>
-            <a:off x="338328" y="3203010"/>
+            <a:off x="338328" y="3200400"/>
             <a:ext cx="1371600" cy="274320"/>
           </a:xfrm>
           <a:prstGeom prst="rect">
@@ -13909,7 +13903,7 @@
         </p:nvSpPr>
         <p:spPr>
           <a:xfrm>
-            <a:off x="1819656" y="3218688"/>
+            <a:off x="1819656" y="3200400"/>
             <a:ext cx="2807208" cy="274320"/>
           </a:xfrm>
           <a:prstGeom prst="rect">
@@ -13954,7 +13948,7 @@
         </p:nvSpPr>
         <p:spPr>
           <a:xfrm>
-            <a:off x="1796666" y="2924772"/>
+            <a:off x="1796666" y="2926080"/>
             <a:ext cx="2807208" cy="274320"/>
           </a:xfrm>
           <a:prstGeom prst="rect">
@@ -14239,7 +14233,7 @@
         </p:nvSpPr>
         <p:spPr>
           <a:xfrm>
-            <a:off x="676656" y="987552"/>
+            <a:off x="676656" y="950976"/>
             <a:ext cx="3090672" cy="164592"/>
           </a:xfrm>
           <a:prstGeom prst="rect">
@@ -14417,7 +14411,7 @@
         </p:nvSpPr>
         <p:spPr>
           <a:xfrm>
-            <a:off x="676656" y="1408176"/>
+            <a:off x="676656" y="1371600"/>
             <a:ext cx="3090672" cy="164592"/>
           </a:xfrm>
           <a:prstGeom prst="rect">
@@ -14595,7 +14589,7 @@
         </p:nvSpPr>
         <p:spPr>
           <a:xfrm>
-            <a:off x="676656" y="1828800"/>
+            <a:off x="676656" y="1792224"/>
             <a:ext cx="3090672" cy="164592"/>
           </a:xfrm>
           <a:prstGeom prst="rect">
@@ -14773,7 +14767,7 @@
         </p:nvSpPr>
         <p:spPr>
           <a:xfrm>
-            <a:off x="676656" y="2249424"/>
+            <a:off x="676656" y="2212848"/>
             <a:ext cx="3090672" cy="164592"/>
           </a:xfrm>
           <a:prstGeom prst="rect">
@@ -14951,7 +14945,7 @@
         </p:nvSpPr>
         <p:spPr>
           <a:xfrm>
-            <a:off x="676656" y="2670048"/>
+            <a:off x="676656" y="2633472"/>
             <a:ext cx="3090672" cy="164592"/>
           </a:xfrm>
           <a:prstGeom prst="rect">
@@ -17133,7 +17127,10 @@
           <a:lstStyle/>
           <a:p>
             <a:r>
-              <a:rPr sz="750">
+              <a:rPr sz="750" b="1">
+                <a:solidFill>
+                  <a:srgbClr val="111111"/>
+                </a:solidFill>
                 <a:latin typeface="Aptos"/>
               </a:rPr>
               <a:t>Contracting T1 &amp; T2</a:t>
@@ -17603,9 +17600,9 @@
           <a:lstStyle/>
           <a:p>
             <a:r>
-              <a:rPr sz="750">
-                <a:solidFill>
-                  <a:srgbClr val="1F2937"/>
+              <a:rPr sz="750" b="1">
+                <a:solidFill>
+                  <a:srgbClr val="4A148C"/>
                 </a:solidFill>
                 <a:latin typeface="Aptos"/>
               </a:rPr>
@@ -20328,14 +20325,14 @@
           </a:fontRef>
         </p:style>
         <p:txBody>
-          <a:bodyPr rtlCol="0" anchor="t" wrap="square" lIns="0" rIns="0" tIns="0" bIns="0"/>
+          <a:bodyPr rtlCol="0" anchor="t" wrap="square" lIns="0" rIns="0" tIns="9144" bIns="9144"/>
           <a:lstStyle/>
           <a:p>
             <a:pPr algn="l"/>
             <a:r>
               <a:rPr sz="1000" b="1">
                 <a:solidFill>
-                  <a:srgbClr val="1F2937"/>
+                  <a:srgbClr val="111111"/>
                 </a:solidFill>
                 <a:latin typeface="Aptos"/>
               </a:rPr>
@@ -20378,14 +20375,14 @@
           </a:fontRef>
         </p:style>
         <p:txBody>
-          <a:bodyPr rtlCol="0" anchor="t" wrap="square" lIns="0" rIns="0" tIns="0" bIns="0"/>
+          <a:bodyPr rtlCol="0" anchor="t" wrap="square" lIns="0" rIns="0" tIns="9144" bIns="9144"/>
           <a:lstStyle/>
           <a:p>
             <a:pPr algn="l"/>
             <a:r>
               <a:rPr sz="950" b="1">
                 <a:solidFill>
-                  <a:srgbClr val="1F2937"/>
+                  <a:srgbClr val="111111"/>
                 </a:solidFill>
                 <a:latin typeface="Aptos"/>
               </a:rPr>
@@ -20428,14 +20425,14 @@
           </a:fontRef>
         </p:style>
         <p:txBody>
-          <a:bodyPr rtlCol="0" anchor="t" wrap="square" lIns="0" rIns="0" tIns="0" bIns="0"/>
+          <a:bodyPr rtlCol="0" anchor="t" wrap="square" lIns="0" rIns="0" tIns="9144" bIns="9144"/>
           <a:lstStyle/>
           <a:p>
             <a:pPr algn="l"/>
             <a:r>
               <a:rPr sz="850" b="0">
                 <a:solidFill>
-                  <a:srgbClr val="1F2937"/>
+                  <a:srgbClr val="111111"/>
                 </a:solidFill>
                 <a:latin typeface="Aptos"/>
               </a:rPr>
@@ -20447,7 +20444,7 @@
             <a:r>
               <a:rPr sz="850" b="0">
                 <a:solidFill>
-                  <a:srgbClr val="1F2937"/>
+                  <a:srgbClr val="111111"/>
                 </a:solidFill>
                 <a:latin typeface="Aptos"/>
               </a:rPr>
@@ -20459,7 +20456,7 @@
             <a:r>
               <a:rPr sz="850" b="0">
                 <a:solidFill>
-                  <a:srgbClr val="1F2937"/>
+                  <a:srgbClr val="111111"/>
                 </a:solidFill>
                 <a:latin typeface="Aptos"/>
               </a:rPr>
@@ -20471,7 +20468,7 @@
             <a:r>
               <a:rPr sz="850" b="0">
                 <a:solidFill>
-                  <a:srgbClr val="1F2937"/>
+                  <a:srgbClr val="111111"/>
                 </a:solidFill>
                 <a:latin typeface="Aptos"/>
               </a:rPr>
@@ -20483,7 +20480,7 @@
             <a:r>
               <a:rPr sz="850" b="0">
                 <a:solidFill>
-                  <a:srgbClr val="1F2937"/>
+                  <a:srgbClr val="111111"/>
                 </a:solidFill>
                 <a:latin typeface="Aptos"/>
               </a:rPr>
@@ -20495,7 +20492,7 @@
             <a:r>
               <a:rPr sz="850" b="0">
                 <a:solidFill>
-                  <a:srgbClr val="1F2937"/>
+                  <a:srgbClr val="111111"/>
                 </a:solidFill>
                 <a:latin typeface="Aptos"/>
               </a:rPr>
@@ -20507,7 +20504,7 @@
             <a:r>
               <a:rPr sz="850" b="0">
                 <a:solidFill>
-                  <a:srgbClr val="1F2937"/>
+                  <a:srgbClr val="111111"/>
                 </a:solidFill>
                 <a:latin typeface="Aptos"/>
               </a:rPr>
@@ -20519,7 +20516,7 @@
             <a:r>
               <a:rPr sz="850" b="0">
                 <a:solidFill>
-                  <a:srgbClr val="1F2937"/>
+                  <a:srgbClr val="111111"/>
                 </a:solidFill>
                 <a:latin typeface="Aptos"/>
               </a:rPr>
@@ -20562,14 +20559,14 @@
           </a:fontRef>
         </p:style>
         <p:txBody>
-          <a:bodyPr rtlCol="0" anchor="t" wrap="square" lIns="0" rIns="0" tIns="0" bIns="0"/>
+          <a:bodyPr rtlCol="0" anchor="t" wrap="square" lIns="0" rIns="0" tIns="9144" bIns="9144"/>
           <a:lstStyle/>
           <a:p>
             <a:pPr algn="l"/>
             <a:r>
               <a:rPr sz="950" b="1">
                 <a:solidFill>
-                  <a:srgbClr val="1F2937"/>
+                  <a:srgbClr val="111111"/>
                 </a:solidFill>
                 <a:latin typeface="Aptos"/>
               </a:rPr>
@@ -20612,14 +20609,14 @@
           </a:fontRef>
         </p:style>
         <p:txBody>
-          <a:bodyPr rtlCol="0" anchor="t" wrap="square" lIns="0" rIns="0" tIns="0" bIns="0"/>
+          <a:bodyPr rtlCol="0" anchor="t" wrap="square" lIns="0" rIns="0" tIns="9144" bIns="9144"/>
           <a:lstStyle/>
           <a:p>
             <a:pPr algn="l"/>
             <a:r>
               <a:rPr sz="850" b="0">
                 <a:solidFill>
-                  <a:srgbClr val="1F2937"/>
+                  <a:srgbClr val="111111"/>
                 </a:solidFill>
                 <a:latin typeface="Aptos"/>
               </a:rPr>
@@ -20765,7 +20762,7 @@
             <a:r>
               <a:rPr sz="2000" b="1">
                 <a:solidFill>
-                  <a:srgbClr val="1F2937"/>
+                  <a:srgbClr val="6B21D4"/>
                 </a:solidFill>
                 <a:latin typeface="Aptos"/>
               </a:rPr>
@@ -20815,7 +20812,7 @@
             <a:r>
               <a:rPr sz="900" b="0">
                 <a:solidFill>
-                  <a:srgbClr val="4B5563"/>
+                  <a:srgbClr val="777777"/>
                 </a:solidFill>
                 <a:latin typeface="Aptos"/>
               </a:rPr>
@@ -20908,7 +20905,7 @@
           <a:p>
             <a:pPr algn="ctr"/>
             <a:r>
-              <a:rPr sz="1100" b="0">
+              <a:rPr sz="1100" b="1">
                 <a:solidFill>
                   <a:srgbClr val="FFFFFF"/>
                 </a:solidFill>
@@ -21050,7 +21047,7 @@
             <a:r>
               <a:rPr sz="750" b="0">
                 <a:solidFill>
-                  <a:srgbClr val="1F2937"/>
+                  <a:srgbClr val="111111"/>
                 </a:solidFill>
                 <a:latin typeface="Aptos"/>
               </a:rPr>
@@ -21098,9 +21095,9 @@
           <a:p>
             <a:pPr algn="ctr"/>
             <a:r>
-              <a:rPr sz="750" b="0">
-                <a:solidFill>
-                  <a:srgbClr val="1F2937"/>
+              <a:rPr sz="750" b="1">
+                <a:solidFill>
+                  <a:srgbClr val="4A148C"/>
                 </a:solidFill>
                 <a:latin typeface="Aptos"/>
               </a:rPr>
@@ -21240,7 +21237,7 @@
             <a:r>
               <a:rPr sz="750" b="0">
                 <a:solidFill>
-                  <a:srgbClr val="1F2937"/>
+                  <a:srgbClr val="111111"/>
                 </a:solidFill>
                 <a:latin typeface="Aptos"/>
               </a:rPr>
@@ -21288,9 +21285,9 @@
           <a:p>
             <a:pPr algn="ctr"/>
             <a:r>
-              <a:rPr sz="750" b="0">
-                <a:solidFill>
-                  <a:srgbClr val="1F2937"/>
+              <a:rPr sz="750" b="1">
+                <a:solidFill>
+                  <a:srgbClr val="4A148C"/>
                 </a:solidFill>
                 <a:latin typeface="Aptos"/>
               </a:rPr>
@@ -21570,7 +21567,7 @@
             <a:r>
               <a:rPr sz="750" b="0">
                 <a:solidFill>
-                  <a:srgbClr val="1F2937"/>
+                  <a:srgbClr val="111111"/>
                 </a:solidFill>
                 <a:latin typeface="Aptos"/>
               </a:rPr>
@@ -21618,9 +21615,9 @@
           <a:p>
             <a:pPr algn="ctr"/>
             <a:r>
-              <a:rPr sz="750" b="0">
-                <a:solidFill>
-                  <a:srgbClr val="1F2937"/>
+              <a:rPr sz="750" b="1">
+                <a:solidFill>
+                  <a:srgbClr val="4A148C"/>
                 </a:solidFill>
                 <a:latin typeface="Aptos"/>
               </a:rPr>
@@ -21760,7 +21757,7 @@
             <a:r>
               <a:rPr sz="750" b="0">
                 <a:solidFill>
-                  <a:srgbClr val="1F2937"/>
+                  <a:srgbClr val="111111"/>
                 </a:solidFill>
                 <a:latin typeface="Aptos"/>
               </a:rPr>
@@ -21808,13 +21805,25 @@
           <a:p>
             <a:pPr algn="ctr"/>
             <a:r>
-              <a:rPr sz="750" b="0">
-                <a:solidFill>
-                  <a:srgbClr val="1F2937"/>
+              <a:rPr sz="750" b="1">
+                <a:solidFill>
+                  <a:srgbClr val="4A148C"/>
                 </a:solidFill>
                 <a:latin typeface="Aptos"/>
               </a:rPr>
-              <a:t>Brinda S/Harikrishnan, Aiswarya</a:t>
+              <a:t>Brinda S/Harikrishnan,</a:t>
+            </a:r>
+          </a:p>
+          <a:p>
+            <a:pPr algn="ctr"/>
+            <a:r>
+              <a:rPr sz="750" b="1">
+                <a:solidFill>
+                  <a:srgbClr val="4A148C"/>
+                </a:solidFill>
+                <a:latin typeface="Aptos"/>
+              </a:rPr>
+              <a:t>Aiswarya</a:t>
             </a:r>
           </a:p>
         </p:txBody>
@@ -21950,7 +21959,7 @@
             <a:r>
               <a:rPr sz="750" b="0">
                 <a:solidFill>
-                  <a:srgbClr val="1F2937"/>
+                  <a:srgbClr val="111111"/>
                 </a:solidFill>
                 <a:latin typeface="Aptos"/>
               </a:rPr>
@@ -21998,9 +22007,9 @@
           <a:p>
             <a:pPr algn="ctr"/>
             <a:r>
-              <a:rPr sz="750" b="0">
-                <a:solidFill>
-                  <a:srgbClr val="1F2937"/>
+              <a:rPr sz="750" b="1">
+                <a:solidFill>
+                  <a:srgbClr val="4A148C"/>
                 </a:solidFill>
                 <a:latin typeface="Aptos"/>
               </a:rPr>
@@ -22140,7 +22149,7 @@
             <a:r>
               <a:rPr sz="750" b="0">
                 <a:solidFill>
-                  <a:srgbClr val="1F2937"/>
+                  <a:srgbClr val="111111"/>
                 </a:solidFill>
                 <a:latin typeface="Aptos"/>
               </a:rPr>
@@ -22188,9 +22197,9 @@
           <a:p>
             <a:pPr algn="ctr"/>
             <a:r>
-              <a:rPr sz="750" b="0">
-                <a:solidFill>
-                  <a:srgbClr val="1F2937"/>
+              <a:rPr sz="750" b="1">
+                <a:solidFill>
+                  <a:srgbClr val="4A148C"/>
                 </a:solidFill>
                 <a:latin typeface="Aptos"/>
               </a:rPr>
@@ -22330,11 +22339,23 @@
             <a:r>
               <a:rPr sz="750" b="0">
                 <a:solidFill>
-                  <a:srgbClr val="1F2937"/>
+                  <a:srgbClr val="111111"/>
                 </a:solidFill>
                 <a:latin typeface="Aptos"/>
               </a:rPr>
-              <a:t>Contracting(Team 1 &amp; 2) (Tax)</a:t>
+              <a:t>Contracting(Team 1 &amp; 2)</a:t>
+            </a:r>
+          </a:p>
+          <a:p>
+            <a:pPr algn="ctr"/>
+            <a:r>
+              <a:rPr sz="750" b="0">
+                <a:solidFill>
+                  <a:srgbClr val="111111"/>
+                </a:solidFill>
+                <a:latin typeface="Aptos"/>
+              </a:rPr>
+              <a:t>(Tax)</a:t>
             </a:r>
           </a:p>
         </p:txBody>
@@ -22378,13 +22399,25 @@
           <a:p>
             <a:pPr algn="ctr"/>
             <a:r>
-              <a:rPr sz="750" b="0">
-                <a:solidFill>
-                  <a:srgbClr val="1F2937"/>
+              <a:rPr sz="750" b="1">
+                <a:solidFill>
+                  <a:srgbClr val="4A148C"/>
                 </a:solidFill>
                 <a:latin typeface="Aptos"/>
               </a:rPr>
-              <a:t>Vignesh S/Preethi Khajji/Srinivasa R</a:t>
+              <a:t>Vignesh S/Preethi</a:t>
+            </a:r>
+          </a:p>
+          <a:p>
+            <a:pPr algn="ctr"/>
+            <a:r>
+              <a:rPr sz="750" b="1">
+                <a:solidFill>
+                  <a:srgbClr val="4A148C"/>
+                </a:solidFill>
+                <a:latin typeface="Aptos"/>
+              </a:rPr>
+              <a:t>Khajji/Srinivasa R</a:t>
             </a:r>
           </a:p>
         </p:txBody>
@@ -22520,7 +22553,7 @@
             <a:r>
               <a:rPr sz="750" b="0">
                 <a:solidFill>
-                  <a:srgbClr val="1F2937"/>
+                  <a:srgbClr val="111111"/>
                 </a:solidFill>
                 <a:latin typeface="Aptos"/>
               </a:rPr>
@@ -22568,9 +22601,9 @@
           <a:p>
             <a:pPr algn="ctr"/>
             <a:r>
-              <a:rPr sz="750" b="0">
-                <a:solidFill>
-                  <a:srgbClr val="1F2937"/>
+              <a:rPr sz="750" b="1">
+                <a:solidFill>
+                  <a:srgbClr val="4A148C"/>
                 </a:solidFill>
                 <a:latin typeface="Aptos"/>
               </a:rPr>
@@ -22710,11 +22743,23 @@
             <a:r>
               <a:rPr sz="750" b="0">
                 <a:solidFill>
-                  <a:srgbClr val="1F2937"/>
+                  <a:srgbClr val="111111"/>
                 </a:solidFill>
                 <a:latin typeface="Aptos"/>
               </a:rPr>
-              <a:t>Documents (DocGen)</a:t>
+              <a:t>Documents</a:t>
+            </a:r>
+          </a:p>
+          <a:p>
+            <a:pPr algn="ctr"/>
+            <a:r>
+              <a:rPr sz="750" b="0">
+                <a:solidFill>
+                  <a:srgbClr val="111111"/>
+                </a:solidFill>
+                <a:latin typeface="Aptos"/>
+              </a:rPr>
+              <a:t>(DocGen)</a:t>
             </a:r>
           </a:p>
         </p:txBody>
@@ -22758,9 +22803,9 @@
           <a:p>
             <a:pPr algn="ctr"/>
             <a:r>
-              <a:rPr sz="750" b="0">
-                <a:solidFill>
-                  <a:srgbClr val="1F2937"/>
+              <a:rPr sz="750" b="1">
+                <a:solidFill>
+                  <a:srgbClr val="4A148C"/>
                 </a:solidFill>
                 <a:latin typeface="Aptos"/>
               </a:rPr>
@@ -22900,7 +22945,7 @@
             <a:r>
               <a:rPr sz="750" b="0">
                 <a:solidFill>
-                  <a:srgbClr val="1F2937"/>
+                  <a:srgbClr val="111111"/>
                 </a:solidFill>
                 <a:latin typeface="Aptos"/>
               </a:rPr>
@@ -22948,9 +22993,9 @@
           <a:p>
             <a:pPr algn="ctr"/>
             <a:r>
-              <a:rPr sz="750" b="0">
-                <a:solidFill>
-                  <a:srgbClr val="1F2937"/>
+              <a:rPr sz="750" b="1">
+                <a:solidFill>
+                  <a:srgbClr val="4A148C"/>
                 </a:solidFill>
                 <a:latin typeface="Aptos"/>
               </a:rPr>
@@ -26386,7 +26431,7 @@
             <a:r>
               <a:rPr sz="2000" b="1">
                 <a:solidFill>
-                  <a:srgbClr val="1F2937"/>
+                  <a:srgbClr val="6B21D4"/>
                 </a:solidFill>
                 <a:latin typeface="Aptos"/>
               </a:rPr>
@@ -26434,9 +26479,9 @@
           <a:p>
             <a:pPr algn="l"/>
             <a:r>
-              <a:rPr sz="950" b="0">
-                <a:solidFill>
-                  <a:srgbClr val="1F2937"/>
+              <a:rPr sz="950" b="1">
+                <a:solidFill>
+                  <a:srgbClr val="4A148C"/>
                 </a:solidFill>
                 <a:latin typeface="Aptos"/>
               </a:rPr>
@@ -26574,9 +26619,9 @@
           <a:p>
             <a:pPr algn="l"/>
             <a:r>
-              <a:rPr sz="750" b="0">
-                <a:solidFill>
-                  <a:srgbClr val="1F2937"/>
+              <a:rPr sz="750" b="1">
+                <a:solidFill>
+                  <a:srgbClr val="111111"/>
                 </a:solidFill>
                 <a:latin typeface="Aptos"/>
               </a:rPr>
@@ -26626,7 +26671,7 @@
             <a:r>
               <a:rPr sz="700" b="0">
                 <a:solidFill>
-                  <a:srgbClr val="1F2937"/>
+                  <a:srgbClr val="6B21D4"/>
                 </a:solidFill>
                 <a:latin typeface="Aptos"/>
               </a:rPr>
@@ -26676,7 +26721,7 @@
             <a:r>
               <a:rPr sz="650" b="0">
                 <a:solidFill>
-                  <a:srgbClr val="4B5563"/>
+                  <a:srgbClr val="777777"/>
                 </a:solidFill>
                 <a:latin typeface="Aptos"/>
               </a:rPr>
@@ -26814,9 +26859,9 @@
           <a:p>
             <a:pPr algn="l"/>
             <a:r>
-              <a:rPr sz="750" b="0">
-                <a:solidFill>
-                  <a:srgbClr val="1F2937"/>
+              <a:rPr sz="750" b="1">
+                <a:solidFill>
+                  <a:srgbClr val="111111"/>
                 </a:solidFill>
                 <a:latin typeface="Aptos"/>
               </a:rPr>
@@ -26866,7 +26911,7 @@
             <a:r>
               <a:rPr sz="700" b="0">
                 <a:solidFill>
-                  <a:srgbClr val="1F2937"/>
+                  <a:srgbClr val="6B21D4"/>
                 </a:solidFill>
                 <a:latin typeface="Aptos"/>
               </a:rPr>
@@ -26916,7 +26961,7 @@
             <a:r>
               <a:rPr sz="650" b="0">
                 <a:solidFill>
-                  <a:srgbClr val="4B5563"/>
+                  <a:srgbClr val="777777"/>
                 </a:solidFill>
                 <a:latin typeface="Aptos"/>
               </a:rPr>
@@ -27054,9 +27099,9 @@
           <a:p>
             <a:pPr algn="l"/>
             <a:r>
-              <a:rPr sz="750" b="0">
-                <a:solidFill>
-                  <a:srgbClr val="1F2937"/>
+              <a:rPr sz="750" b="1">
+                <a:solidFill>
+                  <a:srgbClr val="111111"/>
                 </a:solidFill>
                 <a:latin typeface="Aptos"/>
               </a:rPr>
@@ -27106,7 +27151,7 @@
             <a:r>
               <a:rPr sz="700" b="0">
                 <a:solidFill>
-                  <a:srgbClr val="1F2937"/>
+                  <a:srgbClr val="6B21D4"/>
                 </a:solidFill>
                 <a:latin typeface="Aptos"/>
               </a:rPr>
@@ -27156,7 +27201,7 @@
             <a:r>
               <a:rPr sz="650" b="0">
                 <a:solidFill>
-                  <a:srgbClr val="4B5563"/>
+                  <a:srgbClr val="777777"/>
                 </a:solidFill>
                 <a:latin typeface="Aptos"/>
               </a:rPr>
@@ -27294,9 +27339,9 @@
           <a:p>
             <a:pPr algn="l"/>
             <a:r>
-              <a:rPr sz="750" b="0">
-                <a:solidFill>
-                  <a:srgbClr val="1F2937"/>
+              <a:rPr sz="750" b="1">
+                <a:solidFill>
+                  <a:srgbClr val="111111"/>
                 </a:solidFill>
                 <a:latin typeface="Aptos"/>
               </a:rPr>
@@ -27346,7 +27391,7 @@
             <a:r>
               <a:rPr sz="700" b="0">
                 <a:solidFill>
-                  <a:srgbClr val="1F2937"/>
+                  <a:srgbClr val="6B21D4"/>
                 </a:solidFill>
                 <a:latin typeface="Aptos"/>
               </a:rPr>
@@ -27396,7 +27441,7 @@
             <a:r>
               <a:rPr sz="650" b="0">
                 <a:solidFill>
-                  <a:srgbClr val="4B5563"/>
+                  <a:srgbClr val="777777"/>
                 </a:solidFill>
                 <a:latin typeface="Aptos"/>
               </a:rPr>
@@ -27534,9 +27579,9 @@
           <a:p>
             <a:pPr algn="l"/>
             <a:r>
-              <a:rPr sz="750" b="0">
-                <a:solidFill>
-                  <a:srgbClr val="1F2937"/>
+              <a:rPr sz="750" b="1">
+                <a:solidFill>
+                  <a:srgbClr val="111111"/>
                 </a:solidFill>
                 <a:latin typeface="Aptos"/>
               </a:rPr>
@@ -27586,7 +27631,7 @@
             <a:r>
               <a:rPr sz="700" b="0">
                 <a:solidFill>
-                  <a:srgbClr val="1F2937"/>
+                  <a:srgbClr val="6B21D4"/>
                 </a:solidFill>
                 <a:latin typeface="Aptos"/>
               </a:rPr>
@@ -27636,7 +27681,7 @@
             <a:r>
               <a:rPr sz="650" b="0">
                 <a:solidFill>
-                  <a:srgbClr val="4B5563"/>
+                  <a:srgbClr val="777777"/>
                 </a:solidFill>
                 <a:latin typeface="Aptos"/>
               </a:rPr>
@@ -27774,9 +27819,9 @@
           <a:p>
             <a:pPr algn="l"/>
             <a:r>
-              <a:rPr sz="750" b="0">
-                <a:solidFill>
-                  <a:srgbClr val="1F2937"/>
+              <a:rPr sz="750" b="1">
+                <a:solidFill>
+                  <a:srgbClr val="111111"/>
                 </a:solidFill>
                 <a:latin typeface="Aptos"/>
               </a:rPr>
@@ -27826,7 +27871,7 @@
             <a:r>
               <a:rPr sz="700" b="0">
                 <a:solidFill>
-                  <a:srgbClr val="1F2937"/>
+                  <a:srgbClr val="6B21D4"/>
                 </a:solidFill>
                 <a:latin typeface="Aptos"/>
               </a:rPr>
@@ -27876,7 +27921,7 @@
             <a:r>
               <a:rPr sz="650" b="0">
                 <a:solidFill>
-                  <a:srgbClr val="4B5563"/>
+                  <a:srgbClr val="777777"/>
                 </a:solidFill>
                 <a:latin typeface="Aptos"/>
               </a:rPr>
@@ -28014,9 +28059,9 @@
           <a:p>
             <a:pPr algn="l"/>
             <a:r>
-              <a:rPr sz="750" b="0">
-                <a:solidFill>
-                  <a:srgbClr val="1F2937"/>
+              <a:rPr sz="750" b="1">
+                <a:solidFill>
+                  <a:srgbClr val="111111"/>
                 </a:solidFill>
                 <a:latin typeface="Aptos"/>
               </a:rPr>
@@ -28066,7 +28111,7 @@
             <a:r>
               <a:rPr sz="700" b="0">
                 <a:solidFill>
-                  <a:srgbClr val="1F2937"/>
+                  <a:srgbClr val="6B21D4"/>
                 </a:solidFill>
                 <a:latin typeface="Aptos"/>
               </a:rPr>
@@ -28116,7 +28161,7 @@
             <a:r>
               <a:rPr sz="650" b="0">
                 <a:solidFill>
-                  <a:srgbClr val="4B5563"/>
+                  <a:srgbClr val="777777"/>
                 </a:solidFill>
                 <a:latin typeface="Aptos"/>
               </a:rPr>
@@ -28254,9 +28299,9 @@
           <a:p>
             <a:pPr algn="l"/>
             <a:r>
-              <a:rPr sz="750" b="0">
-                <a:solidFill>
-                  <a:srgbClr val="1F2937"/>
+              <a:rPr sz="750" b="1">
+                <a:solidFill>
+                  <a:srgbClr val="111111"/>
                 </a:solidFill>
                 <a:latin typeface="Aptos"/>
               </a:rPr>
@@ -28306,7 +28351,7 @@
             <a:r>
               <a:rPr sz="700" b="0">
                 <a:solidFill>
-                  <a:srgbClr val="1F2937"/>
+                  <a:srgbClr val="6B21D4"/>
                 </a:solidFill>
                 <a:latin typeface="Aptos"/>
               </a:rPr>
@@ -28356,7 +28401,7 @@
             <a:r>
               <a:rPr sz="650" b="0">
                 <a:solidFill>
-                  <a:srgbClr val="4B5563"/>
+                  <a:srgbClr val="777777"/>
                 </a:solidFill>
                 <a:latin typeface="Aptos"/>
               </a:rPr>
@@ -28404,9 +28449,9 @@
           <a:p>
             <a:pPr algn="l"/>
             <a:r>
-              <a:rPr sz="950" b="0">
-                <a:solidFill>
-                  <a:srgbClr val="1F2937"/>
+              <a:rPr sz="950" b="1">
+                <a:solidFill>
+                  <a:srgbClr val="4A148C"/>
                 </a:solidFill>
                 <a:latin typeface="Aptos"/>
               </a:rPr>
@@ -28544,9 +28589,9 @@
           <a:p>
             <a:pPr algn="l"/>
             <a:r>
-              <a:rPr sz="750" b="0">
-                <a:solidFill>
-                  <a:srgbClr val="1F2937"/>
+              <a:rPr sz="750" b="1">
+                <a:solidFill>
+                  <a:srgbClr val="111111"/>
                 </a:solidFill>
                 <a:latin typeface="Aptos"/>
               </a:rPr>
@@ -28596,7 +28641,7 @@
             <a:r>
               <a:rPr sz="700" b="0">
                 <a:solidFill>
-                  <a:srgbClr val="1F2937"/>
+                  <a:srgbClr val="6B21D4"/>
                 </a:solidFill>
                 <a:latin typeface="Aptos"/>
               </a:rPr>
@@ -28646,7 +28691,7 @@
             <a:r>
               <a:rPr sz="650" b="0">
                 <a:solidFill>
-                  <a:srgbClr val="4B5563"/>
+                  <a:srgbClr val="777777"/>
                 </a:solidFill>
                 <a:latin typeface="Aptos"/>
               </a:rPr>
@@ -28784,9 +28829,9 @@
           <a:p>
             <a:pPr algn="l"/>
             <a:r>
-              <a:rPr sz="750" b="0">
-                <a:solidFill>
-                  <a:srgbClr val="1F2937"/>
+              <a:rPr sz="750" b="1">
+                <a:solidFill>
+                  <a:srgbClr val="111111"/>
                 </a:solidFill>
                 <a:latin typeface="Aptos"/>
               </a:rPr>
@@ -28836,7 +28881,7 @@
             <a:r>
               <a:rPr sz="700" b="0">
                 <a:solidFill>
-                  <a:srgbClr val="1F2937"/>
+                  <a:srgbClr val="6B21D4"/>
                 </a:solidFill>
                 <a:latin typeface="Aptos"/>
               </a:rPr>
@@ -28886,7 +28931,7 @@
             <a:r>
               <a:rPr sz="650" b="0">
                 <a:solidFill>
-                  <a:srgbClr val="4B5563"/>
+                  <a:srgbClr val="777777"/>
                 </a:solidFill>
                 <a:latin typeface="Aptos"/>
               </a:rPr>
@@ -29024,9 +29069,9 @@
           <a:p>
             <a:pPr algn="l"/>
             <a:r>
-              <a:rPr sz="750" b="0">
-                <a:solidFill>
-                  <a:srgbClr val="1F2937"/>
+              <a:rPr sz="750" b="1">
+                <a:solidFill>
+                  <a:srgbClr val="111111"/>
                 </a:solidFill>
                 <a:latin typeface="Aptos"/>
               </a:rPr>
@@ -29076,7 +29121,7 @@
             <a:r>
               <a:rPr sz="700" b="0">
                 <a:solidFill>
-                  <a:srgbClr val="1F2937"/>
+                  <a:srgbClr val="6B21D4"/>
                 </a:solidFill>
                 <a:latin typeface="Aptos"/>
               </a:rPr>
@@ -29126,7 +29171,7 @@
             <a:r>
               <a:rPr sz="650" b="0">
                 <a:solidFill>
-                  <a:srgbClr val="4B5563"/>
+                  <a:srgbClr val="777777"/>
                 </a:solidFill>
                 <a:latin typeface="Aptos"/>
               </a:rPr>
@@ -29264,9 +29309,9 @@
           <a:p>
             <a:pPr algn="l"/>
             <a:r>
-              <a:rPr sz="750" b="0">
-                <a:solidFill>
-                  <a:srgbClr val="1F2937"/>
+              <a:rPr sz="750" b="1">
+                <a:solidFill>
+                  <a:srgbClr val="111111"/>
                 </a:solidFill>
                 <a:latin typeface="Aptos"/>
               </a:rPr>
@@ -29316,7 +29361,7 @@
             <a:r>
               <a:rPr sz="700" b="0">
                 <a:solidFill>
-                  <a:srgbClr val="1F2937"/>
+                  <a:srgbClr val="6B21D4"/>
                 </a:solidFill>
                 <a:latin typeface="Aptos"/>
               </a:rPr>
@@ -29366,7 +29411,7 @@
             <a:r>
               <a:rPr sz="650" b="0">
                 <a:solidFill>
-                  <a:srgbClr val="4B5563"/>
+                  <a:srgbClr val="777777"/>
                 </a:solidFill>
                 <a:latin typeface="Aptos"/>
               </a:rPr>
@@ -29504,9 +29549,9 @@
           <a:p>
             <a:pPr algn="l"/>
             <a:r>
-              <a:rPr sz="750" b="0">
-                <a:solidFill>
-                  <a:srgbClr val="1F2937"/>
+              <a:rPr sz="750" b="1">
+                <a:solidFill>
+                  <a:srgbClr val="111111"/>
                 </a:solidFill>
                 <a:latin typeface="Aptos"/>
               </a:rPr>
@@ -29556,7 +29601,7 @@
             <a:r>
               <a:rPr sz="700" b="0">
                 <a:solidFill>
-                  <a:srgbClr val="1F2937"/>
+                  <a:srgbClr val="6B21D4"/>
                 </a:solidFill>
                 <a:latin typeface="Aptos"/>
               </a:rPr>
@@ -29606,7 +29651,7 @@
             <a:r>
               <a:rPr sz="650" b="0">
                 <a:solidFill>
-                  <a:srgbClr val="4B5563"/>
+                  <a:srgbClr val="777777"/>
                 </a:solidFill>
                 <a:latin typeface="Aptos"/>
               </a:rPr>

</xml_diff>

<commit_message>
Match Slide 3 delivery tracks layout
Co-authored-by: Sagar-konkanagaon <Sagar-konkanagaon@users.noreply.github.com>
</commit_message>
<xml_diff>
--- a/CHVAC_QA_Onboarding_Updated (1).pptx
+++ b/CHVAC_QA_Onboarding_Updated (1).pptx
@@ -24572,38 +24572,38 @@
         </p:nvSpPr>
         <p:spPr>
           <a:xfrm>
-            <a:off x="463296" y="158496"/>
-            <a:ext cx="11265408" cy="414528"/>
-          </a:xfrm>
-          <a:prstGeom prst="rect">
-            <a:avLst/>
-          </a:prstGeom>
-          <a:noFill/>
-          <a:ln>
-            <a:noFill/>
-          </a:ln>
-        </p:spPr>
-        <p:style>
-          <a:lnRef idx="1">
-            <a:schemeClr val="accent1"/>
-          </a:lnRef>
-          <a:fillRef idx="3">
-            <a:schemeClr val="accent1"/>
-          </a:fillRef>
-          <a:effectRef idx="2">
-            <a:schemeClr val="accent1"/>
-          </a:effectRef>
-          <a:fontRef idx="minor">
-            <a:schemeClr val="lt1"/>
-          </a:fontRef>
-        </p:style>
-        <p:txBody>
-          <a:bodyPr rtlCol="0" anchor="ctr" wrap="square" lIns="27432" rIns="27432" tIns="4572" bIns="4572"/>
-          <a:lstStyle/>
-          <a:p>
-            <a:pPr algn="l"/>
-            <a:r>
-              <a:rPr sz="2400" b="1">
+            <a:off x="566928" y="237744"/>
+            <a:ext cx="5394960" cy="438912"/>
+          </a:xfrm>
+          <a:prstGeom prst="rect">
+            <a:avLst/>
+          </a:prstGeom>
+          <a:noFill/>
+          <a:ln>
+            <a:noFill/>
+          </a:ln>
+        </p:spPr>
+        <p:style>
+          <a:lnRef idx="1">
+            <a:schemeClr val="accent1"/>
+          </a:lnRef>
+          <a:fillRef idx="3">
+            <a:schemeClr val="accent1"/>
+          </a:fillRef>
+          <a:effectRef idx="2">
+            <a:schemeClr val="accent1"/>
+          </a:effectRef>
+          <a:fontRef idx="minor">
+            <a:schemeClr val="lt1"/>
+          </a:fontRef>
+        </p:style>
+        <p:txBody>
+          <a:bodyPr rtlCol="0" anchor="ctr" wrap="square" lIns="27432" rIns="27432" tIns="9144" bIns="9144"/>
+          <a:lstStyle/>
+          <a:p>
+            <a:pPr algn="l"/>
+            <a:r>
+              <a:rPr sz="2200" b="1">
                 <a:solidFill>
                   <a:srgbClr val="6B21D4"/>
                 </a:solidFill>
@@ -24622,38 +24622,38 @@
         </p:nvSpPr>
         <p:spPr>
           <a:xfrm>
-            <a:off x="463296" y="682752"/>
-            <a:ext cx="6583680" cy="426720"/>
-          </a:xfrm>
-          <a:prstGeom prst="rect">
-            <a:avLst/>
-          </a:prstGeom>
-          <a:noFill/>
-          <a:ln>
-            <a:noFill/>
-          </a:ln>
-        </p:spPr>
-        <p:style>
-          <a:lnRef idx="1">
-            <a:schemeClr val="accent1"/>
-          </a:lnRef>
-          <a:fillRef idx="3">
-            <a:schemeClr val="accent1"/>
-          </a:fillRef>
-          <a:effectRef idx="2">
-            <a:schemeClr val="accent1"/>
-          </a:effectRef>
-          <a:fontRef idx="minor">
-            <a:schemeClr val="lt1"/>
-          </a:fontRef>
-        </p:style>
-        <p:txBody>
-          <a:bodyPr rtlCol="0" anchor="ctr" wrap="square" lIns="27432" rIns="27432" tIns="4572" bIns="4572"/>
-          <a:lstStyle/>
-          <a:p>
-            <a:pPr algn="l"/>
-            <a:r>
-              <a:rPr sz="1000" b="0">
+            <a:off x="566928" y="749808"/>
+            <a:ext cx="6309360" cy="420624"/>
+          </a:xfrm>
+          <a:prstGeom prst="rect">
+            <a:avLst/>
+          </a:prstGeom>
+          <a:noFill/>
+          <a:ln>
+            <a:noFill/>
+          </a:ln>
+        </p:spPr>
+        <p:style>
+          <a:lnRef idx="1">
+            <a:schemeClr val="accent1"/>
+          </a:lnRef>
+          <a:fillRef idx="3">
+            <a:schemeClr val="accent1"/>
+          </a:fillRef>
+          <a:effectRef idx="2">
+            <a:schemeClr val="accent1"/>
+          </a:effectRef>
+          <a:fontRef idx="minor">
+            <a:schemeClr val="lt1"/>
+          </a:fontRef>
+        </p:style>
+        <p:txBody>
+          <a:bodyPr rtlCol="0" anchor="ctr" wrap="square" lIns="27432" rIns="27432" tIns="9144" bIns="9144"/>
+          <a:lstStyle/>
+          <a:p>
+            <a:pPr algn="l"/>
+            <a:r>
+              <a:rPr sz="1200" b="0">
                 <a:solidFill>
                   <a:srgbClr val="111111"/>
                 </a:solidFill>
@@ -24665,7 +24665,7 @@
           <a:p>
             <a:pPr algn="l"/>
             <a:r>
-              <a:rPr sz="1000" b="0">
+              <a:rPr sz="1200" b="0">
                 <a:solidFill>
                   <a:srgbClr val="111111"/>
                 </a:solidFill>
@@ -24684,8 +24684,8 @@
         </p:nvSpPr>
         <p:spPr>
           <a:xfrm>
-            <a:off x="463296" y="1280160"/>
-            <a:ext cx="6766560" cy="731520"/>
+            <a:off x="438912" y="1234440"/>
+            <a:ext cx="6812280" cy="749808"/>
           </a:xfrm>
           <a:prstGeom prst="rect">
             <a:avLst/>
@@ -24693,7 +24693,7 @@
           <a:solidFill>
             <a:srgbClr val="EDE7F6"/>
           </a:solidFill>
-          <a:ln w="6350">
+          <a:ln w="12700">
             <a:solidFill>
               <a:srgbClr val="6B21D4"/>
             </a:solidFill>
@@ -24714,7 +24714,7 @@
           </a:fontRef>
         </p:style>
         <p:txBody>
-          <a:bodyPr rtlCol="0" anchor="ctr" wrap="square" lIns="27432" rIns="27432" tIns="4572" bIns="4572"/>
+          <a:bodyPr rtlCol="0" anchor="ctr" wrap="square" lIns="27432" rIns="27432" tIns="9144" bIns="9144"/>
           <a:lstStyle/>
           <a:p>
             <a:pPr algn="ctr"/>
@@ -24729,38 +24729,83 @@
         </p:nvSpPr>
         <p:spPr>
           <a:xfrm>
-            <a:off x="609600" y="1328928"/>
-            <a:ext cx="6400800" cy="219456"/>
-          </a:xfrm>
-          <a:prstGeom prst="rect">
-            <a:avLst/>
-          </a:prstGeom>
-          <a:noFill/>
-          <a:ln>
-            <a:noFill/>
-          </a:ln>
-        </p:spPr>
-        <p:style>
-          <a:lnRef idx="1">
-            <a:schemeClr val="accent1"/>
-          </a:lnRef>
-          <a:fillRef idx="3">
-            <a:schemeClr val="accent1"/>
-          </a:fillRef>
-          <a:effectRef idx="2">
-            <a:schemeClr val="accent1"/>
-          </a:effectRef>
-          <a:fontRef idx="minor">
-            <a:schemeClr val="lt1"/>
-          </a:fontRef>
-        </p:style>
-        <p:txBody>
-          <a:bodyPr rtlCol="0" anchor="ctr" wrap="square" lIns="27432" rIns="27432" tIns="4572" bIns="4572"/>
-          <a:lstStyle/>
-          <a:p>
-            <a:pPr algn="l"/>
-            <a:r>
-              <a:rPr sz="1000" b="1">
+            <a:off x="438912" y="1234440"/>
+            <a:ext cx="91440" cy="749808"/>
+          </a:xfrm>
+          <a:prstGeom prst="rect">
+            <a:avLst/>
+          </a:prstGeom>
+          <a:solidFill>
+            <a:srgbClr val="6B21D4"/>
+          </a:solidFill>
+          <a:ln w="12700">
+            <a:solidFill>
+              <a:srgbClr val="6B21D4"/>
+            </a:solidFill>
+          </a:ln>
+        </p:spPr>
+        <p:style>
+          <a:lnRef idx="1">
+            <a:schemeClr val="accent1"/>
+          </a:lnRef>
+          <a:fillRef idx="3">
+            <a:schemeClr val="accent1"/>
+          </a:fillRef>
+          <a:effectRef idx="2">
+            <a:schemeClr val="accent1"/>
+          </a:effectRef>
+          <a:fontRef idx="minor">
+            <a:schemeClr val="lt1"/>
+          </a:fontRef>
+        </p:style>
+        <p:txBody>
+          <a:bodyPr rtlCol="0" anchor="ctr" wrap="square" lIns="27432" rIns="27432" tIns="9144" bIns="9144"/>
+          <a:lstStyle/>
+          <a:p>
+            <a:pPr algn="ctr"/>
+          </a:p>
+        </p:txBody>
+      </p:sp>
+      <p:sp>
+        <p:nvSpPr>
+          <p:cNvPr id="6" name="Rectangle 5"/>
+          <p:cNvSpPr/>
+          <p:nvPr/>
+        </p:nvSpPr>
+        <p:spPr>
+          <a:xfrm>
+            <a:off x="749808" y="1353312"/>
+            <a:ext cx="3291840" cy="256032"/>
+          </a:xfrm>
+          <a:prstGeom prst="rect">
+            <a:avLst/>
+          </a:prstGeom>
+          <a:noFill/>
+          <a:ln>
+            <a:noFill/>
+          </a:ln>
+        </p:spPr>
+        <p:style>
+          <a:lnRef idx="1">
+            <a:schemeClr val="accent1"/>
+          </a:lnRef>
+          <a:fillRef idx="3">
+            <a:schemeClr val="accent1"/>
+          </a:fillRef>
+          <a:effectRef idx="2">
+            <a:schemeClr val="accent1"/>
+          </a:effectRef>
+          <a:fontRef idx="minor">
+            <a:schemeClr val="lt1"/>
+          </a:fontRef>
+        </p:style>
+        <p:txBody>
+          <a:bodyPr rtlCol="0" anchor="ctr" wrap="square" lIns="27432" rIns="27432" tIns="9144" bIns="9144"/>
+          <a:lstStyle/>
+          <a:p>
+            <a:pPr algn="l"/>
+            <a:r>
+              <a:rPr sz="1400" b="1">
                 <a:solidFill>
                   <a:srgbClr val="111111"/>
                 </a:solidFill>
@@ -24773,39 +24818,39 @@
       </p:sp>
       <p:sp>
         <p:nvSpPr>
-          <p:cNvPr id="6" name="Rectangle 5"/>
-          <p:cNvSpPr/>
-          <p:nvPr/>
-        </p:nvSpPr>
-        <p:spPr>
-          <a:xfrm>
-            <a:off x="609600" y="1682496"/>
-            <a:ext cx="6400800" cy="195072"/>
-          </a:xfrm>
-          <a:prstGeom prst="rect">
-            <a:avLst/>
-          </a:prstGeom>
-          <a:noFill/>
-          <a:ln>
-            <a:noFill/>
-          </a:ln>
-        </p:spPr>
-        <p:style>
-          <a:lnRef idx="1">
-            <a:schemeClr val="accent1"/>
-          </a:lnRef>
-          <a:fillRef idx="3">
-            <a:schemeClr val="accent1"/>
-          </a:fillRef>
-          <a:effectRef idx="2">
-            <a:schemeClr val="accent1"/>
-          </a:effectRef>
-          <a:fontRef idx="minor">
-            <a:schemeClr val="lt1"/>
-          </a:fontRef>
-        </p:style>
-        <p:txBody>
-          <a:bodyPr rtlCol="0" anchor="ctr" wrap="square" lIns="27432" rIns="27432" tIns="4572" bIns="4572"/>
+          <p:cNvPr id="7" name="Rectangle 6"/>
+          <p:cNvSpPr/>
+          <p:nvPr/>
+        </p:nvSpPr>
+        <p:spPr>
+          <a:xfrm>
+            <a:off x="749808" y="1700784"/>
+            <a:ext cx="6126480" cy="201168"/>
+          </a:xfrm>
+          <a:prstGeom prst="rect">
+            <a:avLst/>
+          </a:prstGeom>
+          <a:noFill/>
+          <a:ln>
+            <a:noFill/>
+          </a:ln>
+        </p:spPr>
+        <p:style>
+          <a:lnRef idx="1">
+            <a:schemeClr val="accent1"/>
+          </a:lnRef>
+          <a:fillRef idx="3">
+            <a:schemeClr val="accent1"/>
+          </a:fillRef>
+          <a:effectRef idx="2">
+            <a:schemeClr val="accent1"/>
+          </a:effectRef>
+          <a:fontRef idx="minor">
+            <a:schemeClr val="lt1"/>
+          </a:fontRef>
+        </p:style>
+        <p:txBody>
+          <a:bodyPr rtlCol="0" anchor="ctr" wrap="square" lIns="27432" rIns="27432" tIns="9144" bIns="9144"/>
           <a:lstStyle/>
           <a:p>
             <a:pPr algn="l"/>
@@ -24823,148 +24868,50 @@
       </p:sp>
       <p:sp>
         <p:nvSpPr>
-          <p:cNvPr id="7" name="Rectangle 6"/>
-          <p:cNvSpPr/>
-          <p:nvPr/>
-        </p:nvSpPr>
-        <p:spPr>
-          <a:xfrm>
-            <a:off x="463296" y="2170176"/>
-            <a:ext cx="6583680" cy="219456"/>
-          </a:xfrm>
-          <a:prstGeom prst="rect">
-            <a:avLst/>
-          </a:prstGeom>
-          <a:noFill/>
-          <a:ln>
-            <a:noFill/>
-          </a:ln>
-        </p:spPr>
-        <p:style>
-          <a:lnRef idx="1">
-            <a:schemeClr val="accent1"/>
-          </a:lnRef>
-          <a:fillRef idx="3">
-            <a:schemeClr val="accent1"/>
-          </a:fillRef>
-          <a:effectRef idx="2">
-            <a:schemeClr val="accent1"/>
-          </a:effectRef>
-          <a:fontRef idx="minor">
-            <a:schemeClr val="lt1"/>
-          </a:fontRef>
-        </p:style>
-        <p:txBody>
-          <a:bodyPr rtlCol="0" anchor="ctr" wrap="square" lIns="27432" rIns="27432" tIns="4572" bIns="4572"/>
-          <a:lstStyle/>
-          <a:p>
-            <a:pPr algn="l"/>
-            <a:r>
-              <a:rPr sz="1000" b="1">
-                <a:solidFill>
-                  <a:srgbClr val="111111"/>
-                </a:solidFill>
-                <a:latin typeface="Aptos"/>
-              </a:rPr>
-              <a:t>Delivery Tracks</a:t>
-            </a:r>
-          </a:p>
-        </p:txBody>
-      </p:sp>
-      <p:sp>
-        <p:nvSpPr>
           <p:cNvPr id="8" name="Rectangle 7"/>
           <p:cNvSpPr/>
           <p:nvPr/>
         </p:nvSpPr>
         <p:spPr>
           <a:xfrm>
-            <a:off x="585216" y="2474974"/>
-            <a:ext cx="6461760" cy="1402080"/>
-          </a:xfrm>
-          <a:prstGeom prst="rect">
-            <a:avLst/>
-          </a:prstGeom>
-          <a:noFill/>
-          <a:ln>
-            <a:noFill/>
-          </a:ln>
-        </p:spPr>
-        <p:style>
-          <a:lnRef idx="1">
-            <a:schemeClr val="accent1"/>
-          </a:lnRef>
-          <a:fillRef idx="3">
-            <a:schemeClr val="accent1"/>
-          </a:fillRef>
-          <a:effectRef idx="2">
-            <a:schemeClr val="accent1"/>
-          </a:effectRef>
-          <a:fontRef idx="minor">
-            <a:schemeClr val="lt1"/>
-          </a:fontRef>
-        </p:style>
-        <p:txBody>
-          <a:bodyPr rtlCol="0" anchor="t" wrap="square" lIns="27432" rIns="27432" tIns="4572" bIns="4572"/>
-          <a:lstStyle/>
-          <a:p>
-            <a:pPr algn="l"/>
-            <a:r>
-              <a:rPr sz="1000" b="0">
-                <a:solidFill>
-                  <a:srgbClr val="111111"/>
-                </a:solidFill>
-                <a:latin typeface="Aptos"/>
-              </a:rPr>
-              <a:t>• Equipment (Team A &amp; B)</a:t>
-            </a:r>
-          </a:p>
-          <a:p>
-            <a:pPr algn="l"/>
-            <a:r>
-              <a:rPr sz="1000" b="0">
-                <a:solidFill>
-                  <a:srgbClr val="111111"/>
-                </a:solidFill>
-                <a:latin typeface="Aptos"/>
-              </a:rPr>
-              <a:t>• DMC / MDP</a:t>
-            </a:r>
-          </a:p>
-          <a:p>
-            <a:pPr algn="l"/>
-            <a:r>
-              <a:rPr sz="1000" b="0">
-                <a:solidFill>
-                  <a:srgbClr val="111111"/>
-                </a:solidFill>
-                <a:latin typeface="Aptos"/>
-              </a:rPr>
-              <a:t>• S&amp;C Contracting (Teams 1 &amp; 2)</a:t>
-            </a:r>
-          </a:p>
-          <a:p>
-            <a:pPr algn="l"/>
-            <a:r>
-              <a:rPr sz="1000" b="0">
-                <a:solidFill>
-                  <a:srgbClr val="111111"/>
-                </a:solidFill>
-                <a:latin typeface="Aptos"/>
-              </a:rPr>
-              <a:t>• WorkSight – TSA, WorkPackage, Jobs CoJo, Documents, Service</a:t>
-            </a:r>
-          </a:p>
-          <a:p>
-            <a:pPr algn="l"/>
-            <a:r>
-              <a:rPr sz="1000" b="0">
-                <a:solidFill>
-                  <a:srgbClr val="111111"/>
-                </a:solidFill>
-                <a:latin typeface="Aptos"/>
-              </a:rPr>
-              <a:t>• Other Projects – TDA (Trane Design Assist)</a:t>
+            <a:off x="7754112" y="768096"/>
+            <a:ext cx="3931920" cy="256032"/>
+          </a:xfrm>
+          <a:prstGeom prst="rect">
+            <a:avLst/>
+          </a:prstGeom>
+          <a:noFill/>
+          <a:ln>
+            <a:noFill/>
+          </a:ln>
+        </p:spPr>
+        <p:style>
+          <a:lnRef idx="1">
+            <a:schemeClr val="accent1"/>
+          </a:lnRef>
+          <a:fillRef idx="3">
+            <a:schemeClr val="accent1"/>
+          </a:fillRef>
+          <a:effectRef idx="2">
+            <a:schemeClr val="accent1"/>
+          </a:effectRef>
+          <a:fontRef idx="minor">
+            <a:schemeClr val="lt1"/>
+          </a:fontRef>
+        </p:style>
+        <p:txBody>
+          <a:bodyPr rtlCol="0" anchor="ctr" wrap="square" lIns="27432" rIns="27432" tIns="9144" bIns="9144"/>
+          <a:lstStyle/>
+          <a:p>
+            <a:pPr algn="l"/>
+            <a:r>
+              <a:rPr sz="1200" b="1">
+                <a:solidFill>
+                  <a:srgbClr val="4A148C"/>
+                </a:solidFill>
+                <a:latin typeface="Aptos"/>
+              </a:rPr>
+              <a:t>Team at a Glance</a:t>
             </a:r>
           </a:p>
         </p:txBody>
@@ -24977,58 +24924,8 @@
         </p:nvSpPr>
         <p:spPr>
           <a:xfrm>
-            <a:off x="7583424" y="914400"/>
-            <a:ext cx="4145280" cy="268224"/>
-          </a:xfrm>
-          <a:prstGeom prst="rect">
-            <a:avLst/>
-          </a:prstGeom>
-          <a:noFill/>
-          <a:ln>
-            <a:noFill/>
-          </a:ln>
-        </p:spPr>
-        <p:style>
-          <a:lnRef idx="1">
-            <a:schemeClr val="accent1"/>
-          </a:lnRef>
-          <a:fillRef idx="3">
-            <a:schemeClr val="accent1"/>
-          </a:fillRef>
-          <a:effectRef idx="2">
-            <a:schemeClr val="accent1"/>
-          </a:effectRef>
-          <a:fontRef idx="minor">
-            <a:schemeClr val="lt1"/>
-          </a:fontRef>
-        </p:style>
-        <p:txBody>
-          <a:bodyPr rtlCol="0" anchor="ctr" wrap="square" lIns="27432" rIns="27432" tIns="4572" bIns="4572"/>
-          <a:lstStyle/>
-          <a:p>
-            <a:pPr algn="l"/>
-            <a:r>
-              <a:rPr sz="1000" b="1">
-                <a:solidFill>
-                  <a:srgbClr val="4A148C"/>
-                </a:solidFill>
-                <a:latin typeface="Aptos"/>
-              </a:rPr>
-              <a:t>Team at a Glance</a:t>
-            </a:r>
-          </a:p>
-        </p:txBody>
-      </p:sp>
-      <p:sp>
-        <p:nvSpPr>
-          <p:cNvPr id="10" name="Rectangle 9"/>
-          <p:cNvSpPr/>
-          <p:nvPr/>
-        </p:nvSpPr>
-        <p:spPr>
-          <a:xfrm>
-            <a:off x="7583424" y="1292352"/>
-            <a:ext cx="4145280" cy="329184"/>
+            <a:off x="7726679" y="1124712"/>
+            <a:ext cx="4114800" cy="365760"/>
           </a:xfrm>
           <a:prstGeom prst="rect">
             <a:avLst/>
@@ -25036,7 +24933,7 @@
           <a:solidFill>
             <a:srgbClr val="FFFFFF"/>
           </a:solidFill>
-          <a:ln w="6350">
+          <a:ln w="12700">
             <a:solidFill>
               <a:srgbClr val="EEEEEE"/>
             </a:solidFill>
@@ -25057,7 +24954,7 @@
           </a:fontRef>
         </p:style>
         <p:txBody>
-          <a:bodyPr rtlCol="0" anchor="ctr" wrap="square" lIns="27432" rIns="27432" tIns="4572" bIns="4572"/>
+          <a:bodyPr rtlCol="0" anchor="ctr" wrap="square" lIns="27432" rIns="27432" tIns="9144" bIns="9144"/>
           <a:lstStyle/>
           <a:p>
             <a:pPr algn="ctr"/>
@@ -25066,50 +24963,100 @@
       </p:sp>
       <p:sp>
         <p:nvSpPr>
+          <p:cNvPr id="10" name="Rectangle 9"/>
+          <p:cNvSpPr/>
+          <p:nvPr/>
+        </p:nvSpPr>
+        <p:spPr>
+          <a:xfrm>
+            <a:off x="7882127" y="1161288"/>
+            <a:ext cx="2057400" cy="237744"/>
+          </a:xfrm>
+          <a:prstGeom prst="rect">
+            <a:avLst/>
+          </a:prstGeom>
+          <a:noFill/>
+          <a:ln>
+            <a:noFill/>
+          </a:ln>
+        </p:spPr>
+        <p:style>
+          <a:lnRef idx="1">
+            <a:schemeClr val="accent1"/>
+          </a:lnRef>
+          <a:fillRef idx="3">
+            <a:schemeClr val="accent1"/>
+          </a:fillRef>
+          <a:effectRef idx="2">
+            <a:schemeClr val="accent1"/>
+          </a:effectRef>
+          <a:fontRef idx="minor">
+            <a:schemeClr val="lt1"/>
+          </a:fontRef>
+        </p:style>
+        <p:txBody>
+          <a:bodyPr rtlCol="0" anchor="ctr" wrap="square" lIns="27432" rIns="27432" tIns="9144" bIns="9144"/>
+          <a:lstStyle/>
+          <a:p>
+            <a:pPr algn="l"/>
+            <a:r>
+              <a:rPr sz="1000" b="1">
+                <a:solidFill>
+                  <a:srgbClr val="111111"/>
+                </a:solidFill>
+                <a:latin typeface="Aptos"/>
+              </a:rPr>
+              <a:t>Quality Analysts</a:t>
+            </a:r>
+          </a:p>
+        </p:txBody>
+      </p:sp>
+      <p:sp>
+        <p:nvSpPr>
           <p:cNvPr id="11" name="Rectangle 10"/>
           <p:cNvSpPr/>
           <p:nvPr/>
         </p:nvSpPr>
         <p:spPr>
           <a:xfrm>
-            <a:off x="7729728" y="1316736"/>
-            <a:ext cx="2316480" cy="219456"/>
-          </a:xfrm>
-          <a:prstGeom prst="rect">
-            <a:avLst/>
-          </a:prstGeom>
-          <a:noFill/>
-          <a:ln>
-            <a:noFill/>
-          </a:ln>
-        </p:spPr>
-        <p:style>
-          <a:lnRef idx="1">
-            <a:schemeClr val="accent1"/>
-          </a:lnRef>
-          <a:fillRef idx="3">
-            <a:schemeClr val="accent1"/>
-          </a:fillRef>
-          <a:effectRef idx="2">
-            <a:schemeClr val="accent1"/>
-          </a:effectRef>
-          <a:fontRef idx="minor">
-            <a:schemeClr val="lt1"/>
-          </a:fontRef>
-        </p:style>
-        <p:txBody>
-          <a:bodyPr rtlCol="0" anchor="ctr" wrap="square" lIns="27432" rIns="27432" tIns="4572" bIns="4572"/>
-          <a:lstStyle/>
-          <a:p>
-            <a:pPr algn="l"/>
+            <a:off x="10863072" y="1161288"/>
+            <a:ext cx="502920" cy="237744"/>
+          </a:xfrm>
+          <a:prstGeom prst="rect">
+            <a:avLst/>
+          </a:prstGeom>
+          <a:noFill/>
+          <a:ln>
+            <a:noFill/>
+          </a:ln>
+        </p:spPr>
+        <p:style>
+          <a:lnRef idx="1">
+            <a:schemeClr val="accent1"/>
+          </a:lnRef>
+          <a:fillRef idx="3">
+            <a:schemeClr val="accent1"/>
+          </a:fillRef>
+          <a:effectRef idx="2">
+            <a:schemeClr val="accent1"/>
+          </a:effectRef>
+          <a:fontRef idx="minor">
+            <a:schemeClr val="lt1"/>
+          </a:fontRef>
+        </p:style>
+        <p:txBody>
+          <a:bodyPr rtlCol="0" anchor="ctr" wrap="square" lIns="27432" rIns="27432" tIns="9144" bIns="9144"/>
+          <a:lstStyle/>
+          <a:p>
+            <a:pPr algn="ctr"/>
             <a:r>
               <a:rPr sz="1000" b="1">
                 <a:solidFill>
-                  <a:srgbClr val="111111"/>
-                </a:solidFill>
-                <a:latin typeface="Aptos"/>
-              </a:rPr>
-              <a:t>Quality Analysts</a:t>
+                  <a:srgbClr val="6B21D4"/>
+                </a:solidFill>
+                <a:latin typeface="Aptos"/>
+              </a:rPr>
+              <a:t>25+</a:t>
             </a:r>
           </a:p>
         </p:txBody>
@@ -25122,58 +25069,8 @@
         </p:nvSpPr>
         <p:spPr>
           <a:xfrm>
-            <a:off x="10668000" y="1316736"/>
-            <a:ext cx="670560" cy="219456"/>
-          </a:xfrm>
-          <a:prstGeom prst="rect">
-            <a:avLst/>
-          </a:prstGeom>
-          <a:noFill/>
-          <a:ln>
-            <a:noFill/>
-          </a:ln>
-        </p:spPr>
-        <p:style>
-          <a:lnRef idx="1">
-            <a:schemeClr val="accent1"/>
-          </a:lnRef>
-          <a:fillRef idx="3">
-            <a:schemeClr val="accent1"/>
-          </a:fillRef>
-          <a:effectRef idx="2">
-            <a:schemeClr val="accent1"/>
-          </a:effectRef>
-          <a:fontRef idx="minor">
-            <a:schemeClr val="lt1"/>
-          </a:fontRef>
-        </p:style>
-        <p:txBody>
-          <a:bodyPr rtlCol="0" anchor="ctr" wrap="square" lIns="27432" rIns="27432" tIns="4572" bIns="4572"/>
-          <a:lstStyle/>
-          <a:p>
-            <a:pPr algn="ctr"/>
-            <a:r>
-              <a:rPr sz="1000" b="1">
-                <a:solidFill>
-                  <a:srgbClr val="6B21D4"/>
-                </a:solidFill>
-                <a:latin typeface="Aptos"/>
-              </a:rPr>
-              <a:t>25+</a:t>
-            </a:r>
-          </a:p>
-        </p:txBody>
-      </p:sp>
-      <p:sp>
-        <p:nvSpPr>
-          <p:cNvPr id="13" name="Rectangle 12"/>
-          <p:cNvSpPr/>
-          <p:nvPr/>
-        </p:nvSpPr>
-        <p:spPr>
-          <a:xfrm>
-            <a:off x="7583424" y="1658112"/>
-            <a:ext cx="4145280" cy="329184"/>
+            <a:off x="7726679" y="1490472"/>
+            <a:ext cx="4114800" cy="365760"/>
           </a:xfrm>
           <a:prstGeom prst="rect">
             <a:avLst/>
@@ -25181,7 +25078,7 @@
           <a:solidFill>
             <a:srgbClr val="F3F0FA"/>
           </a:solidFill>
-          <a:ln w="6350">
+          <a:ln w="12700">
             <a:solidFill>
               <a:srgbClr val="EEEEEE"/>
             </a:solidFill>
@@ -25202,7 +25099,7 @@
           </a:fontRef>
         </p:style>
         <p:txBody>
-          <a:bodyPr rtlCol="0" anchor="ctr" wrap="square" lIns="27432" rIns="27432" tIns="4572" bIns="4572"/>
+          <a:bodyPr rtlCol="0" anchor="ctr" wrap="square" lIns="27432" rIns="27432" tIns="9144" bIns="9144"/>
           <a:lstStyle/>
           <a:p>
             <a:pPr algn="ctr"/>
@@ -25211,50 +25108,100 @@
       </p:sp>
       <p:sp>
         <p:nvSpPr>
+          <p:cNvPr id="13" name="Rectangle 12"/>
+          <p:cNvSpPr/>
+          <p:nvPr/>
+        </p:nvSpPr>
+        <p:spPr>
+          <a:xfrm>
+            <a:off x="7882127" y="1527048"/>
+            <a:ext cx="2057400" cy="237744"/>
+          </a:xfrm>
+          <a:prstGeom prst="rect">
+            <a:avLst/>
+          </a:prstGeom>
+          <a:noFill/>
+          <a:ln>
+            <a:noFill/>
+          </a:ln>
+        </p:spPr>
+        <p:style>
+          <a:lnRef idx="1">
+            <a:schemeClr val="accent1"/>
+          </a:lnRef>
+          <a:fillRef idx="3">
+            <a:schemeClr val="accent1"/>
+          </a:fillRef>
+          <a:effectRef idx="2">
+            <a:schemeClr val="accent1"/>
+          </a:effectRef>
+          <a:fontRef idx="minor">
+            <a:schemeClr val="lt1"/>
+          </a:fontRef>
+        </p:style>
+        <p:txBody>
+          <a:bodyPr rtlCol="0" anchor="ctr" wrap="square" lIns="27432" rIns="27432" tIns="9144" bIns="9144"/>
+          <a:lstStyle/>
+          <a:p>
+            <a:pPr algn="l"/>
+            <a:r>
+              <a:rPr sz="1000" b="1">
+                <a:solidFill>
+                  <a:srgbClr val="111111"/>
+                </a:solidFill>
+                <a:latin typeface="Aptos"/>
+              </a:rPr>
+              <a:t>Developers</a:t>
+            </a:r>
+          </a:p>
+        </p:txBody>
+      </p:sp>
+      <p:sp>
+        <p:nvSpPr>
           <p:cNvPr id="14" name="Rectangle 13"/>
           <p:cNvSpPr/>
           <p:nvPr/>
         </p:nvSpPr>
         <p:spPr>
           <a:xfrm>
-            <a:off x="7729728" y="1682496"/>
-            <a:ext cx="2316480" cy="219456"/>
-          </a:xfrm>
-          <a:prstGeom prst="rect">
-            <a:avLst/>
-          </a:prstGeom>
-          <a:noFill/>
-          <a:ln>
-            <a:noFill/>
-          </a:ln>
-        </p:spPr>
-        <p:style>
-          <a:lnRef idx="1">
-            <a:schemeClr val="accent1"/>
-          </a:lnRef>
-          <a:fillRef idx="3">
-            <a:schemeClr val="accent1"/>
-          </a:fillRef>
-          <a:effectRef idx="2">
-            <a:schemeClr val="accent1"/>
-          </a:effectRef>
-          <a:fontRef idx="minor">
-            <a:schemeClr val="lt1"/>
-          </a:fontRef>
-        </p:style>
-        <p:txBody>
-          <a:bodyPr rtlCol="0" anchor="ctr" wrap="square" lIns="27432" rIns="27432" tIns="4572" bIns="4572"/>
-          <a:lstStyle/>
-          <a:p>
-            <a:pPr algn="l"/>
+            <a:off x="10863072" y="1527048"/>
+            <a:ext cx="502920" cy="237744"/>
+          </a:xfrm>
+          <a:prstGeom prst="rect">
+            <a:avLst/>
+          </a:prstGeom>
+          <a:noFill/>
+          <a:ln>
+            <a:noFill/>
+          </a:ln>
+        </p:spPr>
+        <p:style>
+          <a:lnRef idx="1">
+            <a:schemeClr val="accent1"/>
+          </a:lnRef>
+          <a:fillRef idx="3">
+            <a:schemeClr val="accent1"/>
+          </a:fillRef>
+          <a:effectRef idx="2">
+            <a:schemeClr val="accent1"/>
+          </a:effectRef>
+          <a:fontRef idx="minor">
+            <a:schemeClr val="lt1"/>
+          </a:fontRef>
+        </p:style>
+        <p:txBody>
+          <a:bodyPr rtlCol="0" anchor="ctr" wrap="square" lIns="27432" rIns="27432" tIns="9144" bIns="9144"/>
+          <a:lstStyle/>
+          <a:p>
+            <a:pPr algn="ctr"/>
             <a:r>
               <a:rPr sz="1000" b="1">
                 <a:solidFill>
-                  <a:srgbClr val="111111"/>
-                </a:solidFill>
-                <a:latin typeface="Aptos"/>
-              </a:rPr>
-              <a:t>Developers</a:t>
+                  <a:srgbClr val="6B21D4"/>
+                </a:solidFill>
+                <a:latin typeface="Aptos"/>
+              </a:rPr>
+              <a:t>30+</a:t>
             </a:r>
           </a:p>
         </p:txBody>
@@ -25267,58 +25214,8 @@
         </p:nvSpPr>
         <p:spPr>
           <a:xfrm>
-            <a:off x="10668000" y="1682496"/>
-            <a:ext cx="670560" cy="219456"/>
-          </a:xfrm>
-          <a:prstGeom prst="rect">
-            <a:avLst/>
-          </a:prstGeom>
-          <a:noFill/>
-          <a:ln>
-            <a:noFill/>
-          </a:ln>
-        </p:spPr>
-        <p:style>
-          <a:lnRef idx="1">
-            <a:schemeClr val="accent1"/>
-          </a:lnRef>
-          <a:fillRef idx="3">
-            <a:schemeClr val="accent1"/>
-          </a:fillRef>
-          <a:effectRef idx="2">
-            <a:schemeClr val="accent1"/>
-          </a:effectRef>
-          <a:fontRef idx="minor">
-            <a:schemeClr val="lt1"/>
-          </a:fontRef>
-        </p:style>
-        <p:txBody>
-          <a:bodyPr rtlCol="0" anchor="ctr" wrap="square" lIns="27432" rIns="27432" tIns="4572" bIns="4572"/>
-          <a:lstStyle/>
-          <a:p>
-            <a:pPr algn="ctr"/>
-            <a:r>
-              <a:rPr sz="1000" b="1">
-                <a:solidFill>
-                  <a:srgbClr val="6B21D4"/>
-                </a:solidFill>
-                <a:latin typeface="Aptos"/>
-              </a:rPr>
-              <a:t>30+</a:t>
-            </a:r>
-          </a:p>
-        </p:txBody>
-      </p:sp>
-      <p:sp>
-        <p:nvSpPr>
-          <p:cNvPr id="16" name="Rectangle 15"/>
-          <p:cNvSpPr/>
-          <p:nvPr/>
-        </p:nvSpPr>
-        <p:spPr>
-          <a:xfrm>
-            <a:off x="7583424" y="2023872"/>
-            <a:ext cx="4145280" cy="329184"/>
+            <a:off x="7726679" y="1856231"/>
+            <a:ext cx="4114800" cy="365760"/>
           </a:xfrm>
           <a:prstGeom prst="rect">
             <a:avLst/>
@@ -25326,7 +25223,7 @@
           <a:solidFill>
             <a:srgbClr val="FFFFFF"/>
           </a:solidFill>
-          <a:ln w="6350">
+          <a:ln w="12700">
             <a:solidFill>
               <a:srgbClr val="EEEEEE"/>
             </a:solidFill>
@@ -25347,7 +25244,7 @@
           </a:fontRef>
         </p:style>
         <p:txBody>
-          <a:bodyPr rtlCol="0" anchor="ctr" wrap="square" lIns="27432" rIns="27432" tIns="4572" bIns="4572"/>
+          <a:bodyPr rtlCol="0" anchor="ctr" wrap="square" lIns="27432" rIns="27432" tIns="9144" bIns="9144"/>
           <a:lstStyle/>
           <a:p>
             <a:pPr algn="ctr"/>
@@ -25356,50 +25253,100 @@
       </p:sp>
       <p:sp>
         <p:nvSpPr>
+          <p:cNvPr id="16" name="Rectangle 15"/>
+          <p:cNvSpPr/>
+          <p:nvPr/>
+        </p:nvSpPr>
+        <p:spPr>
+          <a:xfrm>
+            <a:off x="7882127" y="1892807"/>
+            <a:ext cx="2057400" cy="237744"/>
+          </a:xfrm>
+          <a:prstGeom prst="rect">
+            <a:avLst/>
+          </a:prstGeom>
+          <a:noFill/>
+          <a:ln>
+            <a:noFill/>
+          </a:ln>
+        </p:spPr>
+        <p:style>
+          <a:lnRef idx="1">
+            <a:schemeClr val="accent1"/>
+          </a:lnRef>
+          <a:fillRef idx="3">
+            <a:schemeClr val="accent1"/>
+          </a:fillRef>
+          <a:effectRef idx="2">
+            <a:schemeClr val="accent1"/>
+          </a:effectRef>
+          <a:fontRef idx="minor">
+            <a:schemeClr val="lt1"/>
+          </a:fontRef>
+        </p:style>
+        <p:txBody>
+          <a:bodyPr rtlCol="0" anchor="ctr" wrap="square" lIns="27432" rIns="27432" tIns="9144" bIns="9144"/>
+          <a:lstStyle/>
+          <a:p>
+            <a:pPr algn="l"/>
+            <a:r>
+              <a:rPr sz="1000" b="1">
+                <a:solidFill>
+                  <a:srgbClr val="111111"/>
+                </a:solidFill>
+                <a:latin typeface="Aptos"/>
+              </a:rPr>
+              <a:t>Product Owners</a:t>
+            </a:r>
+          </a:p>
+        </p:txBody>
+      </p:sp>
+      <p:sp>
+        <p:nvSpPr>
           <p:cNvPr id="17" name="Rectangle 16"/>
           <p:cNvSpPr/>
           <p:nvPr/>
         </p:nvSpPr>
         <p:spPr>
           <a:xfrm>
-            <a:off x="7729728" y="2048256"/>
-            <a:ext cx="2316480" cy="219456"/>
-          </a:xfrm>
-          <a:prstGeom prst="rect">
-            <a:avLst/>
-          </a:prstGeom>
-          <a:noFill/>
-          <a:ln>
-            <a:noFill/>
-          </a:ln>
-        </p:spPr>
-        <p:style>
-          <a:lnRef idx="1">
-            <a:schemeClr val="accent1"/>
-          </a:lnRef>
-          <a:fillRef idx="3">
-            <a:schemeClr val="accent1"/>
-          </a:fillRef>
-          <a:effectRef idx="2">
-            <a:schemeClr val="accent1"/>
-          </a:effectRef>
-          <a:fontRef idx="minor">
-            <a:schemeClr val="lt1"/>
-          </a:fontRef>
-        </p:style>
-        <p:txBody>
-          <a:bodyPr rtlCol="0" anchor="ctr" wrap="square" lIns="27432" rIns="27432" tIns="4572" bIns="4572"/>
-          <a:lstStyle/>
-          <a:p>
-            <a:pPr algn="l"/>
+            <a:off x="10863072" y="1892807"/>
+            <a:ext cx="502920" cy="237744"/>
+          </a:xfrm>
+          <a:prstGeom prst="rect">
+            <a:avLst/>
+          </a:prstGeom>
+          <a:noFill/>
+          <a:ln>
+            <a:noFill/>
+          </a:ln>
+        </p:spPr>
+        <p:style>
+          <a:lnRef idx="1">
+            <a:schemeClr val="accent1"/>
+          </a:lnRef>
+          <a:fillRef idx="3">
+            <a:schemeClr val="accent1"/>
+          </a:fillRef>
+          <a:effectRef idx="2">
+            <a:schemeClr val="accent1"/>
+          </a:effectRef>
+          <a:fontRef idx="minor">
+            <a:schemeClr val="lt1"/>
+          </a:fontRef>
+        </p:style>
+        <p:txBody>
+          <a:bodyPr rtlCol="0" anchor="ctr" wrap="square" lIns="27432" rIns="27432" tIns="9144" bIns="9144"/>
+          <a:lstStyle/>
+          <a:p>
+            <a:pPr algn="ctr"/>
             <a:r>
               <a:rPr sz="1000" b="1">
                 <a:solidFill>
-                  <a:srgbClr val="111111"/>
-                </a:solidFill>
-                <a:latin typeface="Aptos"/>
-              </a:rPr>
-              <a:t>Product Owners</a:t>
+                  <a:srgbClr val="6B21D4"/>
+                </a:solidFill>
+                <a:latin typeface="Aptos"/>
+              </a:rPr>
+              <a:t>10</a:t>
             </a:r>
           </a:p>
         </p:txBody>
@@ -25412,58 +25359,8 @@
         </p:nvSpPr>
         <p:spPr>
           <a:xfrm>
-            <a:off x="10668000" y="2048256"/>
-            <a:ext cx="670560" cy="219456"/>
-          </a:xfrm>
-          <a:prstGeom prst="rect">
-            <a:avLst/>
-          </a:prstGeom>
-          <a:noFill/>
-          <a:ln>
-            <a:noFill/>
-          </a:ln>
-        </p:spPr>
-        <p:style>
-          <a:lnRef idx="1">
-            <a:schemeClr val="accent1"/>
-          </a:lnRef>
-          <a:fillRef idx="3">
-            <a:schemeClr val="accent1"/>
-          </a:fillRef>
-          <a:effectRef idx="2">
-            <a:schemeClr val="accent1"/>
-          </a:effectRef>
-          <a:fontRef idx="minor">
-            <a:schemeClr val="lt1"/>
-          </a:fontRef>
-        </p:style>
-        <p:txBody>
-          <a:bodyPr rtlCol="0" anchor="ctr" wrap="square" lIns="27432" rIns="27432" tIns="4572" bIns="4572"/>
-          <a:lstStyle/>
-          <a:p>
-            <a:pPr algn="ctr"/>
-            <a:r>
-              <a:rPr sz="1000" b="1">
-                <a:solidFill>
-                  <a:srgbClr val="6B21D4"/>
-                </a:solidFill>
-                <a:latin typeface="Aptos"/>
-              </a:rPr>
-              <a:t>10</a:t>
-            </a:r>
-          </a:p>
-        </p:txBody>
-      </p:sp>
-      <p:sp>
-        <p:nvSpPr>
-          <p:cNvPr id="19" name="Rectangle 18"/>
-          <p:cNvSpPr/>
-          <p:nvPr/>
-        </p:nvSpPr>
-        <p:spPr>
-          <a:xfrm>
-            <a:off x="7583424" y="2389632"/>
-            <a:ext cx="4145280" cy="329184"/>
+            <a:off x="7726679" y="2221991"/>
+            <a:ext cx="4114800" cy="365760"/>
           </a:xfrm>
           <a:prstGeom prst="rect">
             <a:avLst/>
@@ -25471,7 +25368,7 @@
           <a:solidFill>
             <a:srgbClr val="F3F0FA"/>
           </a:solidFill>
-          <a:ln w="6350">
+          <a:ln w="12700">
             <a:solidFill>
               <a:srgbClr val="EEEEEE"/>
             </a:solidFill>
@@ -25492,7 +25389,7 @@
           </a:fontRef>
         </p:style>
         <p:txBody>
-          <a:bodyPr rtlCol="0" anchor="ctr" wrap="square" lIns="27432" rIns="27432" tIns="4572" bIns="4572"/>
+          <a:bodyPr rtlCol="0" anchor="ctr" wrap="square" lIns="27432" rIns="27432" tIns="9144" bIns="9144"/>
           <a:lstStyle/>
           <a:p>
             <a:pPr algn="ctr"/>
@@ -25501,50 +25398,100 @@
       </p:sp>
       <p:sp>
         <p:nvSpPr>
+          <p:cNvPr id="19" name="Rectangle 18"/>
+          <p:cNvSpPr/>
+          <p:nvPr/>
+        </p:nvSpPr>
+        <p:spPr>
+          <a:xfrm>
+            <a:off x="7882127" y="2258568"/>
+            <a:ext cx="2057400" cy="237744"/>
+          </a:xfrm>
+          <a:prstGeom prst="rect">
+            <a:avLst/>
+          </a:prstGeom>
+          <a:noFill/>
+          <a:ln>
+            <a:noFill/>
+          </a:ln>
+        </p:spPr>
+        <p:style>
+          <a:lnRef idx="1">
+            <a:schemeClr val="accent1"/>
+          </a:lnRef>
+          <a:fillRef idx="3">
+            <a:schemeClr val="accent1"/>
+          </a:fillRef>
+          <a:effectRef idx="2">
+            <a:schemeClr val="accent1"/>
+          </a:effectRef>
+          <a:fontRef idx="minor">
+            <a:schemeClr val="lt1"/>
+          </a:fontRef>
+        </p:style>
+        <p:txBody>
+          <a:bodyPr rtlCol="0" anchor="ctr" wrap="square" lIns="27432" rIns="27432" tIns="9144" bIns="9144"/>
+          <a:lstStyle/>
+          <a:p>
+            <a:pPr algn="l"/>
+            <a:r>
+              <a:rPr sz="1000" b="1">
+                <a:solidFill>
+                  <a:srgbClr val="111111"/>
+                </a:solidFill>
+                <a:latin typeface="Aptos"/>
+              </a:rPr>
+              <a:t>Scrum Masters</a:t>
+            </a:r>
+          </a:p>
+        </p:txBody>
+      </p:sp>
+      <p:sp>
+        <p:nvSpPr>
           <p:cNvPr id="20" name="Rectangle 19"/>
           <p:cNvSpPr/>
           <p:nvPr/>
         </p:nvSpPr>
         <p:spPr>
           <a:xfrm>
-            <a:off x="7729728" y="2414016"/>
-            <a:ext cx="2316480" cy="219456"/>
-          </a:xfrm>
-          <a:prstGeom prst="rect">
-            <a:avLst/>
-          </a:prstGeom>
-          <a:noFill/>
-          <a:ln>
-            <a:noFill/>
-          </a:ln>
-        </p:spPr>
-        <p:style>
-          <a:lnRef idx="1">
-            <a:schemeClr val="accent1"/>
-          </a:lnRef>
-          <a:fillRef idx="3">
-            <a:schemeClr val="accent1"/>
-          </a:fillRef>
-          <a:effectRef idx="2">
-            <a:schemeClr val="accent1"/>
-          </a:effectRef>
-          <a:fontRef idx="minor">
-            <a:schemeClr val="lt1"/>
-          </a:fontRef>
-        </p:style>
-        <p:txBody>
-          <a:bodyPr rtlCol="0" anchor="ctr" wrap="square" lIns="27432" rIns="27432" tIns="4572" bIns="4572"/>
-          <a:lstStyle/>
-          <a:p>
-            <a:pPr algn="l"/>
+            <a:off x="10863072" y="2258568"/>
+            <a:ext cx="502920" cy="237744"/>
+          </a:xfrm>
+          <a:prstGeom prst="rect">
+            <a:avLst/>
+          </a:prstGeom>
+          <a:noFill/>
+          <a:ln>
+            <a:noFill/>
+          </a:ln>
+        </p:spPr>
+        <p:style>
+          <a:lnRef idx="1">
+            <a:schemeClr val="accent1"/>
+          </a:lnRef>
+          <a:fillRef idx="3">
+            <a:schemeClr val="accent1"/>
+          </a:fillRef>
+          <a:effectRef idx="2">
+            <a:schemeClr val="accent1"/>
+          </a:effectRef>
+          <a:fontRef idx="minor">
+            <a:schemeClr val="lt1"/>
+          </a:fontRef>
+        </p:style>
+        <p:txBody>
+          <a:bodyPr rtlCol="0" anchor="ctr" wrap="square" lIns="27432" rIns="27432" tIns="9144" bIns="9144"/>
+          <a:lstStyle/>
+          <a:p>
+            <a:pPr algn="ctr"/>
             <a:r>
               <a:rPr sz="1000" b="1">
                 <a:solidFill>
-                  <a:srgbClr val="111111"/>
-                </a:solidFill>
-                <a:latin typeface="Aptos"/>
-              </a:rPr>
-              <a:t>Scrum Masters</a:t>
+                  <a:srgbClr val="6B21D4"/>
+                </a:solidFill>
+                <a:latin typeface="Aptos"/>
+              </a:rPr>
+              <a:t>5</a:t>
             </a:r>
           </a:p>
         </p:txBody>
@@ -25557,58 +25504,8 @@
         </p:nvSpPr>
         <p:spPr>
           <a:xfrm>
-            <a:off x="10668000" y="2414016"/>
-            <a:ext cx="670560" cy="219456"/>
-          </a:xfrm>
-          <a:prstGeom prst="rect">
-            <a:avLst/>
-          </a:prstGeom>
-          <a:noFill/>
-          <a:ln>
-            <a:noFill/>
-          </a:ln>
-        </p:spPr>
-        <p:style>
-          <a:lnRef idx="1">
-            <a:schemeClr val="accent1"/>
-          </a:lnRef>
-          <a:fillRef idx="3">
-            <a:schemeClr val="accent1"/>
-          </a:fillRef>
-          <a:effectRef idx="2">
-            <a:schemeClr val="accent1"/>
-          </a:effectRef>
-          <a:fontRef idx="minor">
-            <a:schemeClr val="lt1"/>
-          </a:fontRef>
-        </p:style>
-        <p:txBody>
-          <a:bodyPr rtlCol="0" anchor="ctr" wrap="square" lIns="27432" rIns="27432" tIns="4572" bIns="4572"/>
-          <a:lstStyle/>
-          <a:p>
-            <a:pPr algn="ctr"/>
-            <a:r>
-              <a:rPr sz="1000" b="1">
-                <a:solidFill>
-                  <a:srgbClr val="6B21D4"/>
-                </a:solidFill>
-                <a:latin typeface="Aptos"/>
-              </a:rPr>
-              <a:t>5</a:t>
-            </a:r>
-          </a:p>
-        </p:txBody>
-      </p:sp>
-      <p:sp>
-        <p:nvSpPr>
-          <p:cNvPr id="22" name="Rectangle 21"/>
-          <p:cNvSpPr/>
-          <p:nvPr/>
-        </p:nvSpPr>
-        <p:spPr>
-          <a:xfrm>
-            <a:off x="7583424" y="2755390"/>
-            <a:ext cx="4145280" cy="329184"/>
+            <a:off x="7726679" y="2587751"/>
+            <a:ext cx="4114800" cy="365760"/>
           </a:xfrm>
           <a:prstGeom prst="rect">
             <a:avLst/>
@@ -25616,7 +25513,7 @@
           <a:solidFill>
             <a:srgbClr val="FFFFFF"/>
           </a:solidFill>
-          <a:ln w="6350">
+          <a:ln w="12700">
             <a:solidFill>
               <a:srgbClr val="EEEEEE"/>
             </a:solidFill>
@@ -25637,7 +25534,7 @@
           </a:fontRef>
         </p:style>
         <p:txBody>
-          <a:bodyPr rtlCol="0" anchor="ctr" wrap="square" lIns="27432" rIns="27432" tIns="4572" bIns="4572"/>
+          <a:bodyPr rtlCol="0" anchor="ctr" wrap="square" lIns="27432" rIns="27432" tIns="9144" bIns="9144"/>
           <a:lstStyle/>
           <a:p>
             <a:pPr algn="ctr"/>
@@ -25646,50 +25543,100 @@
       </p:sp>
       <p:sp>
         <p:nvSpPr>
+          <p:cNvPr id="22" name="Rectangle 21"/>
+          <p:cNvSpPr/>
+          <p:nvPr/>
+        </p:nvSpPr>
+        <p:spPr>
+          <a:xfrm>
+            <a:off x="7882127" y="2624327"/>
+            <a:ext cx="2057400" cy="237744"/>
+          </a:xfrm>
+          <a:prstGeom prst="rect">
+            <a:avLst/>
+          </a:prstGeom>
+          <a:noFill/>
+          <a:ln>
+            <a:noFill/>
+          </a:ln>
+        </p:spPr>
+        <p:style>
+          <a:lnRef idx="1">
+            <a:schemeClr val="accent1"/>
+          </a:lnRef>
+          <a:fillRef idx="3">
+            <a:schemeClr val="accent1"/>
+          </a:fillRef>
+          <a:effectRef idx="2">
+            <a:schemeClr val="accent1"/>
+          </a:effectRef>
+          <a:fontRef idx="minor">
+            <a:schemeClr val="lt1"/>
+          </a:fontRef>
+        </p:style>
+        <p:txBody>
+          <a:bodyPr rtlCol="0" anchor="ctr" wrap="square" lIns="27432" rIns="27432" tIns="9144" bIns="9144"/>
+          <a:lstStyle/>
+          <a:p>
+            <a:pPr algn="l"/>
+            <a:r>
+              <a:rPr sz="1000" b="1">
+                <a:solidFill>
+                  <a:srgbClr val="111111"/>
+                </a:solidFill>
+                <a:latin typeface="Aptos"/>
+              </a:rPr>
+              <a:t>Func. Analysts</a:t>
+            </a:r>
+          </a:p>
+        </p:txBody>
+      </p:sp>
+      <p:sp>
+        <p:nvSpPr>
           <p:cNvPr id="23" name="Rectangle 22"/>
           <p:cNvSpPr/>
           <p:nvPr/>
         </p:nvSpPr>
         <p:spPr>
           <a:xfrm>
-            <a:off x="7729728" y="2779774"/>
-            <a:ext cx="2316480" cy="219456"/>
-          </a:xfrm>
-          <a:prstGeom prst="rect">
-            <a:avLst/>
-          </a:prstGeom>
-          <a:noFill/>
-          <a:ln>
-            <a:noFill/>
-          </a:ln>
-        </p:spPr>
-        <p:style>
-          <a:lnRef idx="1">
-            <a:schemeClr val="accent1"/>
-          </a:lnRef>
-          <a:fillRef idx="3">
-            <a:schemeClr val="accent1"/>
-          </a:fillRef>
-          <a:effectRef idx="2">
-            <a:schemeClr val="accent1"/>
-          </a:effectRef>
-          <a:fontRef idx="minor">
-            <a:schemeClr val="lt1"/>
-          </a:fontRef>
-        </p:style>
-        <p:txBody>
-          <a:bodyPr rtlCol="0" anchor="ctr" wrap="square" lIns="27432" rIns="27432" tIns="4572" bIns="4572"/>
-          <a:lstStyle/>
-          <a:p>
-            <a:pPr algn="l"/>
+            <a:off x="10863072" y="2624327"/>
+            <a:ext cx="502920" cy="237744"/>
+          </a:xfrm>
+          <a:prstGeom prst="rect">
+            <a:avLst/>
+          </a:prstGeom>
+          <a:noFill/>
+          <a:ln>
+            <a:noFill/>
+          </a:ln>
+        </p:spPr>
+        <p:style>
+          <a:lnRef idx="1">
+            <a:schemeClr val="accent1"/>
+          </a:lnRef>
+          <a:fillRef idx="3">
+            <a:schemeClr val="accent1"/>
+          </a:fillRef>
+          <a:effectRef idx="2">
+            <a:schemeClr val="accent1"/>
+          </a:effectRef>
+          <a:fontRef idx="minor">
+            <a:schemeClr val="lt1"/>
+          </a:fontRef>
+        </p:style>
+        <p:txBody>
+          <a:bodyPr rtlCol="0" anchor="ctr" wrap="square" lIns="27432" rIns="27432" tIns="9144" bIns="9144"/>
+          <a:lstStyle/>
+          <a:p>
+            <a:pPr algn="ctr"/>
             <a:r>
               <a:rPr sz="1000" b="1">
                 <a:solidFill>
-                  <a:srgbClr val="111111"/>
-                </a:solidFill>
-                <a:latin typeface="Aptos"/>
-              </a:rPr>
-              <a:t>Func. Analysts</a:t>
+                  <a:srgbClr val="6B21D4"/>
+                </a:solidFill>
+                <a:latin typeface="Aptos"/>
+              </a:rPr>
+              <a:t>10+</a:t>
             </a:r>
           </a:p>
         </p:txBody>
@@ -25702,58 +25649,8 @@
         </p:nvSpPr>
         <p:spPr>
           <a:xfrm>
-            <a:off x="10668000" y="2779774"/>
-            <a:ext cx="670560" cy="219456"/>
-          </a:xfrm>
-          <a:prstGeom prst="rect">
-            <a:avLst/>
-          </a:prstGeom>
-          <a:noFill/>
-          <a:ln>
-            <a:noFill/>
-          </a:ln>
-        </p:spPr>
-        <p:style>
-          <a:lnRef idx="1">
-            <a:schemeClr val="accent1"/>
-          </a:lnRef>
-          <a:fillRef idx="3">
-            <a:schemeClr val="accent1"/>
-          </a:fillRef>
-          <a:effectRef idx="2">
-            <a:schemeClr val="accent1"/>
-          </a:effectRef>
-          <a:fontRef idx="minor">
-            <a:schemeClr val="lt1"/>
-          </a:fontRef>
-        </p:style>
-        <p:txBody>
-          <a:bodyPr rtlCol="0" anchor="ctr" wrap="square" lIns="27432" rIns="27432" tIns="4572" bIns="4572"/>
-          <a:lstStyle/>
-          <a:p>
-            <a:pPr algn="ctr"/>
-            <a:r>
-              <a:rPr sz="1000" b="1">
-                <a:solidFill>
-                  <a:srgbClr val="6B21D4"/>
-                </a:solidFill>
-                <a:latin typeface="Aptos"/>
-              </a:rPr>
-              <a:t>10+</a:t>
-            </a:r>
-          </a:p>
-        </p:txBody>
-      </p:sp>
-      <p:sp>
-        <p:nvSpPr>
-          <p:cNvPr id="25" name="Rectangle 24"/>
-          <p:cNvSpPr/>
-          <p:nvPr/>
-        </p:nvSpPr>
-        <p:spPr>
-          <a:xfrm>
-            <a:off x="7583424" y="3121152"/>
-            <a:ext cx="4145280" cy="329184"/>
+            <a:off x="7726679" y="2953511"/>
+            <a:ext cx="4114800" cy="365760"/>
           </a:xfrm>
           <a:prstGeom prst="rect">
             <a:avLst/>
@@ -25761,7 +25658,7 @@
           <a:solidFill>
             <a:srgbClr val="F3F0FA"/>
           </a:solidFill>
-          <a:ln w="6350">
+          <a:ln w="12700">
             <a:solidFill>
               <a:srgbClr val="EEEEEE"/>
             </a:solidFill>
@@ -25782,7 +25679,7 @@
           </a:fontRef>
         </p:style>
         <p:txBody>
-          <a:bodyPr rtlCol="0" anchor="ctr" wrap="square" lIns="27432" rIns="27432" tIns="4572" bIns="4572"/>
+          <a:bodyPr rtlCol="0" anchor="ctr" wrap="square" lIns="27432" rIns="27432" tIns="9144" bIns="9144"/>
           <a:lstStyle/>
           <a:p>
             <a:pPr algn="ctr"/>
@@ -25791,100 +25688,150 @@
       </p:sp>
       <p:sp>
         <p:nvSpPr>
+          <p:cNvPr id="25" name="Rectangle 24"/>
+          <p:cNvSpPr/>
+          <p:nvPr/>
+        </p:nvSpPr>
+        <p:spPr>
+          <a:xfrm>
+            <a:off x="7882127" y="2990087"/>
+            <a:ext cx="2057400" cy="237744"/>
+          </a:xfrm>
+          <a:prstGeom prst="rect">
+            <a:avLst/>
+          </a:prstGeom>
+          <a:noFill/>
+          <a:ln>
+            <a:noFill/>
+          </a:ln>
+        </p:spPr>
+        <p:style>
+          <a:lnRef idx="1">
+            <a:schemeClr val="accent1"/>
+          </a:lnRef>
+          <a:fillRef idx="3">
+            <a:schemeClr val="accent1"/>
+          </a:fillRef>
+          <a:effectRef idx="2">
+            <a:schemeClr val="accent1"/>
+          </a:effectRef>
+          <a:fontRef idx="minor">
+            <a:schemeClr val="lt1"/>
+          </a:fontRef>
+        </p:style>
+        <p:txBody>
+          <a:bodyPr rtlCol="0" anchor="ctr" wrap="square" lIns="27432" rIns="27432" tIns="9144" bIns="9144"/>
+          <a:lstStyle/>
+          <a:p>
+            <a:pPr algn="l"/>
+            <a:r>
+              <a:rPr sz="1000" b="1">
+                <a:solidFill>
+                  <a:srgbClr val="111111"/>
+                </a:solidFill>
+                <a:latin typeface="Aptos"/>
+              </a:rPr>
+              <a:t>BAs / PAs</a:t>
+            </a:r>
+          </a:p>
+        </p:txBody>
+      </p:sp>
+      <p:sp>
+        <p:nvSpPr>
           <p:cNvPr id="26" name="Rectangle 25"/>
           <p:cNvSpPr/>
           <p:nvPr/>
         </p:nvSpPr>
         <p:spPr>
           <a:xfrm>
-            <a:off x="7729728" y="3145536"/>
-            <a:ext cx="2316480" cy="219456"/>
-          </a:xfrm>
-          <a:prstGeom prst="rect">
-            <a:avLst/>
-          </a:prstGeom>
-          <a:noFill/>
-          <a:ln>
-            <a:noFill/>
-          </a:ln>
-        </p:spPr>
-        <p:style>
-          <a:lnRef idx="1">
-            <a:schemeClr val="accent1"/>
-          </a:lnRef>
-          <a:fillRef idx="3">
-            <a:schemeClr val="accent1"/>
-          </a:fillRef>
-          <a:effectRef idx="2">
-            <a:schemeClr val="accent1"/>
-          </a:effectRef>
-          <a:fontRef idx="minor">
-            <a:schemeClr val="lt1"/>
-          </a:fontRef>
-        </p:style>
-        <p:txBody>
-          <a:bodyPr rtlCol="0" anchor="ctr" wrap="square" lIns="27432" rIns="27432" tIns="4572" bIns="4572"/>
-          <a:lstStyle/>
-          <a:p>
-            <a:pPr algn="l"/>
+            <a:off x="10863072" y="2990087"/>
+            <a:ext cx="502920" cy="237744"/>
+          </a:xfrm>
+          <a:prstGeom prst="rect">
+            <a:avLst/>
+          </a:prstGeom>
+          <a:noFill/>
+          <a:ln>
+            <a:noFill/>
+          </a:ln>
+        </p:spPr>
+        <p:style>
+          <a:lnRef idx="1">
+            <a:schemeClr val="accent1"/>
+          </a:lnRef>
+          <a:fillRef idx="3">
+            <a:schemeClr val="accent1"/>
+          </a:fillRef>
+          <a:effectRef idx="2">
+            <a:schemeClr val="accent1"/>
+          </a:effectRef>
+          <a:fontRef idx="minor">
+            <a:schemeClr val="lt1"/>
+          </a:fontRef>
+        </p:style>
+        <p:txBody>
+          <a:bodyPr rtlCol="0" anchor="ctr" wrap="square" lIns="27432" rIns="27432" tIns="9144" bIns="9144"/>
+          <a:lstStyle/>
+          <a:p>
+            <a:pPr algn="ctr"/>
             <a:r>
               <a:rPr sz="1000" b="1">
                 <a:solidFill>
+                  <a:srgbClr val="6B21D4"/>
+                </a:solidFill>
+                <a:latin typeface="Aptos"/>
+              </a:rPr>
+              <a:t>8</a:t>
+            </a:r>
+          </a:p>
+        </p:txBody>
+      </p:sp>
+      <p:sp>
+        <p:nvSpPr>
+          <p:cNvPr id="27" name="Rectangle 26"/>
+          <p:cNvSpPr/>
+          <p:nvPr/>
+        </p:nvSpPr>
+        <p:spPr>
+          <a:xfrm>
+            <a:off x="566928" y="2286000"/>
+            <a:ext cx="2971800" cy="274320"/>
+          </a:xfrm>
+          <a:prstGeom prst="rect">
+            <a:avLst/>
+          </a:prstGeom>
+          <a:noFill/>
+          <a:ln>
+            <a:noFill/>
+          </a:ln>
+        </p:spPr>
+        <p:style>
+          <a:lnRef idx="1">
+            <a:schemeClr val="accent1"/>
+          </a:lnRef>
+          <a:fillRef idx="3">
+            <a:schemeClr val="accent1"/>
+          </a:fillRef>
+          <a:effectRef idx="2">
+            <a:schemeClr val="accent1"/>
+          </a:effectRef>
+          <a:fontRef idx="minor">
+            <a:schemeClr val="lt1"/>
+          </a:fontRef>
+        </p:style>
+        <p:txBody>
+          <a:bodyPr rtlCol="0" anchor="ctr" wrap="square" lIns="27432" rIns="27432" tIns="9144" bIns="9144"/>
+          <a:lstStyle/>
+          <a:p>
+            <a:pPr algn="l"/>
+            <a:r>
+              <a:rPr sz="1200" b="1">
+                <a:solidFill>
                   <a:srgbClr val="111111"/>
                 </a:solidFill>
                 <a:latin typeface="Aptos"/>
               </a:rPr>
-              <a:t>BAs / PAs</a:t>
-            </a:r>
-          </a:p>
-        </p:txBody>
-      </p:sp>
-      <p:sp>
-        <p:nvSpPr>
-          <p:cNvPr id="27" name="Rectangle 26"/>
-          <p:cNvSpPr/>
-          <p:nvPr/>
-        </p:nvSpPr>
-        <p:spPr>
-          <a:xfrm>
-            <a:off x="10668000" y="3145536"/>
-            <a:ext cx="670560" cy="219456"/>
-          </a:xfrm>
-          <a:prstGeom prst="rect">
-            <a:avLst/>
-          </a:prstGeom>
-          <a:noFill/>
-          <a:ln>
-            <a:noFill/>
-          </a:ln>
-        </p:spPr>
-        <p:style>
-          <a:lnRef idx="1">
-            <a:schemeClr val="accent1"/>
-          </a:lnRef>
-          <a:fillRef idx="3">
-            <a:schemeClr val="accent1"/>
-          </a:fillRef>
-          <a:effectRef idx="2">
-            <a:schemeClr val="accent1"/>
-          </a:effectRef>
-          <a:fontRef idx="minor">
-            <a:schemeClr val="lt1"/>
-          </a:fontRef>
-        </p:style>
-        <p:txBody>
-          <a:bodyPr rtlCol="0" anchor="ctr" wrap="square" lIns="27432" rIns="27432" tIns="4572" bIns="4572"/>
-          <a:lstStyle/>
-          <a:p>
-            <a:pPr algn="ctr"/>
-            <a:r>
-              <a:rPr sz="1000" b="1">
-                <a:solidFill>
-                  <a:srgbClr val="6B21D4"/>
-                </a:solidFill>
-                <a:latin typeface="Aptos"/>
-              </a:rPr>
-              <a:t>8</a:t>
+              <a:t>Delivery Tracks Worksight</a:t>
             </a:r>
           </a:p>
         </p:txBody>
@@ -25897,33 +25844,229 @@
         </p:nvSpPr>
         <p:spPr>
           <a:xfrm>
-            <a:off x="463296" y="6388608"/>
-            <a:ext cx="426720" cy="219456"/>
-          </a:xfrm>
-          <a:prstGeom prst="rect">
-            <a:avLst/>
-          </a:prstGeom>
-          <a:noFill/>
-          <a:ln>
-            <a:noFill/>
-          </a:ln>
-        </p:spPr>
-        <p:style>
-          <a:lnRef idx="1">
-            <a:schemeClr val="accent1"/>
-          </a:lnRef>
-          <a:fillRef idx="3">
-            <a:schemeClr val="accent1"/>
-          </a:fillRef>
-          <a:effectRef idx="2">
-            <a:schemeClr val="accent1"/>
-          </a:effectRef>
-          <a:fontRef idx="minor">
-            <a:schemeClr val="lt1"/>
-          </a:fontRef>
-        </p:style>
-        <p:txBody>
-          <a:bodyPr rtlCol="0" anchor="ctr" wrap="square" lIns="27432" rIns="27432" tIns="4572" bIns="4572"/>
+            <a:off x="566928" y="2578608"/>
+            <a:ext cx="5806440" cy="1664208"/>
+          </a:xfrm>
+          <a:prstGeom prst="rect">
+            <a:avLst/>
+          </a:prstGeom>
+          <a:noFill/>
+          <a:ln>
+            <a:noFill/>
+          </a:ln>
+        </p:spPr>
+        <p:style>
+          <a:lnRef idx="1">
+            <a:schemeClr val="accent1"/>
+          </a:lnRef>
+          <a:fillRef idx="3">
+            <a:schemeClr val="accent1"/>
+          </a:fillRef>
+          <a:effectRef idx="2">
+            <a:schemeClr val="accent1"/>
+          </a:effectRef>
+          <a:fontRef idx="minor">
+            <a:schemeClr val="lt1"/>
+          </a:fontRef>
+        </p:style>
+        <p:txBody>
+          <a:bodyPr rtlCol="0" anchor="t" wrap="square" lIns="27432" rIns="27432" tIns="9144" bIns="9144"/>
+          <a:lstStyle/>
+          <a:p>
+            <a:pPr algn="l"/>
+            <a:r>
+              <a:rPr sz="1100" b="1">
+                <a:solidFill>
+                  <a:srgbClr val="111111"/>
+                </a:solidFill>
+                <a:latin typeface="Aptos"/>
+              </a:rPr>
+              <a:t>-   Jobs</a:t>
+            </a:r>
+          </a:p>
+          <a:p>
+            <a:pPr algn="l"/>
+            <a:r>
+              <a:rPr sz="1100" b="1">
+                <a:solidFill>
+                  <a:srgbClr val="111111"/>
+                </a:solidFill>
+                <a:latin typeface="Aptos"/>
+              </a:rPr>
+              <a:t>-   DMC</a:t>
+            </a:r>
+          </a:p>
+          <a:p>
+            <a:pPr algn="l"/>
+            <a:r>
+              <a:rPr sz="1100" b="1">
+                <a:solidFill>
+                  <a:srgbClr val="111111"/>
+                </a:solidFill>
+                <a:latin typeface="Aptos"/>
+              </a:rPr>
+              <a:t>-   TSA</a:t>
+            </a:r>
+          </a:p>
+          <a:p>
+            <a:pPr algn="l"/>
+            <a:r>
+              <a:rPr sz="1100" b="1">
+                <a:solidFill>
+                  <a:srgbClr val="111111"/>
+                </a:solidFill>
+                <a:latin typeface="Aptos"/>
+              </a:rPr>
+              <a:t>-   COJO</a:t>
+            </a:r>
+          </a:p>
+          <a:p>
+            <a:pPr algn="l"/>
+            <a:r>
+              <a:rPr sz="1100" b="1">
+                <a:solidFill>
+                  <a:srgbClr val="111111"/>
+                </a:solidFill>
+                <a:latin typeface="Aptos"/>
+              </a:rPr>
+              <a:t>-   Workpackage</a:t>
+            </a:r>
+          </a:p>
+          <a:p>
+            <a:pPr algn="l"/>
+            <a:r>
+              <a:rPr sz="1100" b="1">
+                <a:solidFill>
+                  <a:srgbClr val="111111"/>
+                </a:solidFill>
+                <a:latin typeface="Aptos"/>
+              </a:rPr>
+              <a:t>-   Documents</a:t>
+            </a:r>
+          </a:p>
+          <a:p>
+            <a:pPr algn="l"/>
+            <a:r>
+              <a:rPr sz="1100" b="1">
+                <a:solidFill>
+                  <a:srgbClr val="111111"/>
+                </a:solidFill>
+                <a:latin typeface="Aptos"/>
+              </a:rPr>
+              <a:t>-   Equipment(Team A and B)</a:t>
+            </a:r>
+          </a:p>
+          <a:p>
+            <a:pPr algn="l"/>
+            <a:r>
+              <a:rPr sz="1100" b="1">
+                <a:solidFill>
+                  <a:srgbClr val="111111"/>
+                </a:solidFill>
+                <a:latin typeface="Aptos"/>
+              </a:rPr>
+              <a:t>-   Service and Contracting(Team 1 and 2)</a:t>
+            </a:r>
+          </a:p>
+          <a:p>
+            <a:pPr algn="l"/>
+            <a:r>
+              <a:rPr sz="1100" b="1">
+                <a:solidFill>
+                  <a:srgbClr val="111111"/>
+                </a:solidFill>
+                <a:latin typeface="Aptos"/>
+              </a:rPr>
+              <a:t>-   MDP</a:t>
+            </a:r>
+          </a:p>
+        </p:txBody>
+      </p:sp>
+      <p:sp>
+        <p:nvSpPr>
+          <p:cNvPr id="29" name="Rectangle 28"/>
+          <p:cNvSpPr/>
+          <p:nvPr/>
+        </p:nvSpPr>
+        <p:spPr>
+          <a:xfrm>
+            <a:off x="566928" y="4754880"/>
+            <a:ext cx="3840480" cy="310896"/>
+          </a:xfrm>
+          <a:prstGeom prst="rect">
+            <a:avLst/>
+          </a:prstGeom>
+          <a:noFill/>
+          <a:ln>
+            <a:noFill/>
+          </a:ln>
+        </p:spPr>
+        <p:style>
+          <a:lnRef idx="1">
+            <a:schemeClr val="accent1"/>
+          </a:lnRef>
+          <a:fillRef idx="3">
+            <a:schemeClr val="accent1"/>
+          </a:fillRef>
+          <a:effectRef idx="2">
+            <a:schemeClr val="accent1"/>
+          </a:effectRef>
+          <a:fontRef idx="minor">
+            <a:schemeClr val="lt1"/>
+          </a:fontRef>
+        </p:style>
+        <p:txBody>
+          <a:bodyPr rtlCol="0" anchor="ctr" wrap="square" lIns="27432" rIns="27432" tIns="9144" bIns="9144"/>
+          <a:lstStyle/>
+          <a:p>
+            <a:pPr algn="l"/>
+            <a:r>
+              <a:rPr sz="1200" b="1">
+                <a:solidFill>
+                  <a:srgbClr val="111111"/>
+                </a:solidFill>
+                <a:latin typeface="Aptos"/>
+              </a:rPr>
+              <a:t>TDA(Trane Design Assist)</a:t>
+            </a:r>
+          </a:p>
+        </p:txBody>
+      </p:sp>
+      <p:sp>
+        <p:nvSpPr>
+          <p:cNvPr id="30" name="Rectangle 29"/>
+          <p:cNvSpPr/>
+          <p:nvPr/>
+        </p:nvSpPr>
+        <p:spPr>
+          <a:xfrm>
+            <a:off x="566928" y="6537960"/>
+            <a:ext cx="320040" cy="164592"/>
+          </a:xfrm>
+          <a:prstGeom prst="rect">
+            <a:avLst/>
+          </a:prstGeom>
+          <a:noFill/>
+          <a:ln>
+            <a:noFill/>
+          </a:ln>
+        </p:spPr>
+        <p:style>
+          <a:lnRef idx="1">
+            <a:schemeClr val="accent1"/>
+          </a:lnRef>
+          <a:fillRef idx="3">
+            <a:schemeClr val="accent1"/>
+          </a:fillRef>
+          <a:effectRef idx="2">
+            <a:schemeClr val="accent1"/>
+          </a:effectRef>
+          <a:fontRef idx="minor">
+            <a:schemeClr val="lt1"/>
+          </a:fontRef>
+        </p:style>
+        <p:txBody>
+          <a:bodyPr rtlCol="0" anchor="ctr" wrap="square" lIns="27432" rIns="27432" tIns="9144" bIns="9144"/>
           <a:lstStyle/>
           <a:p>
             <a:pPr algn="l"/>
@@ -25941,7 +26084,7 @@
       </p:sp>
       <p:pic>
         <p:nvPicPr>
-          <p:cNvPr id="29" name="Picture 28" descr="trane_real_logo.png"/>
+          <p:cNvPr id="31" name="Picture 30" descr="image.png"/>
           <p:cNvPicPr>
             <a:picLocks noChangeAspect="1"/>
           </p:cNvPicPr>
@@ -25955,8 +26098,8 @@
         </p:blipFill>
         <p:spPr>
           <a:xfrm>
-            <a:off x="10424160" y="6156960"/>
-            <a:ext cx="1463040" cy="633984"/>
+            <a:off x="10469880" y="6172200"/>
+            <a:ext cx="1417320" cy="612648"/>
           </a:xfrm>
           <a:prstGeom prst="rect">
             <a:avLst/>

</xml_diff>

<commit_message>
Restore Service box on reporting slide
Co-authored-by: Sagar-konkanagaon <Sagar-konkanagaon@users.noreply.github.com>
</commit_message>
<xml_diff>
--- a/CHVAC_QA_Onboarding_Updated (1).pptx
+++ b/CHVAC_QA_Onboarding_Updated (1).pptx
@@ -28428,6 +28428,196 @@
           </a:prstGeom>
         </p:spPr>
       </p:pic>
+      <p:sp>
+        <p:nvSpPr>
+          <p:cNvPr id="45" name="Rectangle 44"/>
+          <p:cNvSpPr/>
+          <p:nvPr/>
+        </p:nvSpPr>
+        <p:spPr>
+          <a:xfrm>
+            <a:off x="6236208" y="4032504"/>
+            <a:ext cx="1554480" cy="960120"/>
+          </a:xfrm>
+          <a:prstGeom prst="rect">
+            <a:avLst/>
+          </a:prstGeom>
+          <a:solidFill>
+            <a:srgbClr val="F3F0FA"/>
+          </a:solidFill>
+          <a:ln w="8890">
+            <a:solidFill>
+              <a:srgbClr val="C4B5FD"/>
+            </a:solidFill>
+          </a:ln>
+        </p:spPr>
+        <p:style>
+          <a:lnRef idx="1">
+            <a:schemeClr val="accent1"/>
+          </a:lnRef>
+          <a:fillRef idx="3">
+            <a:schemeClr val="accent1"/>
+          </a:fillRef>
+          <a:effectRef idx="2">
+            <a:schemeClr val="accent1"/>
+          </a:effectRef>
+          <a:fontRef idx="minor">
+            <a:schemeClr val="lt1"/>
+          </a:fontRef>
+        </p:style>
+        <p:txBody>
+          <a:bodyPr rtlCol="0" anchor="ctr"/>
+          <a:lstStyle/>
+          <a:p>
+            <a:pPr algn="ctr"/>
+          </a:p>
+        </p:txBody>
+      </p:sp>
+      <p:sp>
+        <p:nvSpPr>
+          <p:cNvPr id="46" name="Rectangle 45"/>
+          <p:cNvSpPr/>
+          <p:nvPr/>
+        </p:nvSpPr>
+        <p:spPr>
+          <a:xfrm>
+            <a:off x="6236208" y="4032504"/>
+            <a:ext cx="54864" cy="960120"/>
+          </a:xfrm>
+          <a:prstGeom prst="rect">
+            <a:avLst/>
+          </a:prstGeom>
+          <a:solidFill>
+            <a:srgbClr val="6B21D4"/>
+          </a:solidFill>
+          <a:ln>
+            <a:solidFill>
+              <a:srgbClr val="6B21D4"/>
+            </a:solidFill>
+          </a:ln>
+        </p:spPr>
+        <p:style>
+          <a:lnRef idx="1">
+            <a:schemeClr val="accent1"/>
+          </a:lnRef>
+          <a:fillRef idx="3">
+            <a:schemeClr val="accent1"/>
+          </a:fillRef>
+          <a:effectRef idx="2">
+            <a:schemeClr val="accent1"/>
+          </a:effectRef>
+          <a:fontRef idx="minor">
+            <a:schemeClr val="lt1"/>
+          </a:fontRef>
+        </p:style>
+        <p:txBody>
+          <a:bodyPr rtlCol="0" anchor="ctr"/>
+          <a:lstStyle/>
+          <a:p>
+            <a:pPr algn="ctr"/>
+          </a:p>
+        </p:txBody>
+      </p:sp>
+      <p:sp>
+        <p:nvSpPr>
+          <p:cNvPr id="47" name="Rectangle 46"/>
+          <p:cNvSpPr/>
+          <p:nvPr/>
+        </p:nvSpPr>
+        <p:spPr>
+          <a:xfrm>
+            <a:off x="6309360" y="4087368"/>
+            <a:ext cx="1444752" cy="274320"/>
+          </a:xfrm>
+          <a:prstGeom prst="rect">
+            <a:avLst/>
+          </a:prstGeom>
+          <a:noFill/>
+          <a:ln>
+            <a:noFill/>
+          </a:ln>
+        </p:spPr>
+        <p:style>
+          <a:lnRef idx="1">
+            <a:schemeClr val="accent1"/>
+          </a:lnRef>
+          <a:fillRef idx="3">
+            <a:schemeClr val="accent1"/>
+          </a:fillRef>
+          <a:effectRef idx="2">
+            <a:schemeClr val="accent1"/>
+          </a:effectRef>
+          <a:fontRef idx="minor">
+            <a:schemeClr val="lt1"/>
+          </a:fontRef>
+        </p:style>
+        <p:txBody>
+          <a:bodyPr rtlCol="0" anchor="ctr" wrap="square" lIns="18288" rIns="18288" tIns="4572" bIns="4572"/>
+          <a:lstStyle/>
+          <a:p>
+            <a:pPr algn="ctr"/>
+            <a:r>
+              <a:rPr sz="950" b="1">
+                <a:solidFill>
+                  <a:srgbClr val="111111"/>
+                </a:solidFill>
+                <a:latin typeface="Aptos"/>
+              </a:rPr>
+              <a:t>Service</a:t>
+            </a:r>
+          </a:p>
+        </p:txBody>
+      </p:sp>
+      <p:sp>
+        <p:nvSpPr>
+          <p:cNvPr id="48" name="Rectangle 47"/>
+          <p:cNvSpPr/>
+          <p:nvPr/>
+        </p:nvSpPr>
+        <p:spPr>
+          <a:xfrm>
+            <a:off x="6309360" y="4398264"/>
+            <a:ext cx="1444752" cy="228600"/>
+          </a:xfrm>
+          <a:prstGeom prst="rect">
+            <a:avLst/>
+          </a:prstGeom>
+          <a:noFill/>
+          <a:ln>
+            <a:noFill/>
+          </a:ln>
+        </p:spPr>
+        <p:style>
+          <a:lnRef idx="1">
+            <a:schemeClr val="accent1"/>
+          </a:lnRef>
+          <a:fillRef idx="3">
+            <a:schemeClr val="accent1"/>
+          </a:fillRef>
+          <a:effectRef idx="2">
+            <a:schemeClr val="accent1"/>
+          </a:effectRef>
+          <a:fontRef idx="minor">
+            <a:schemeClr val="lt1"/>
+          </a:fontRef>
+        </p:style>
+        <p:txBody>
+          <a:bodyPr rtlCol="0" anchor="ctr" wrap="square" lIns="18288" rIns="18288" tIns="4572" bIns="4572"/>
+          <a:lstStyle/>
+          <a:p>
+            <a:pPr algn="ctr"/>
+            <a:r>
+              <a:rPr sz="850" b="1">
+                <a:solidFill>
+                  <a:srgbClr val="4A148C"/>
+                </a:solidFill>
+                <a:latin typeface="Aptos"/>
+              </a:rPr>
+              <a:t>Frank M</a:t>
+            </a:r>
+          </a:p>
+        </p:txBody>
+      </p:sp>
     </p:spTree>
   </p:cSld>
   <p:clrMapOvr>

</xml_diff>